<commit_message>
docs: capture verified Jenkins Sonar and Grafana results in the French presentation
</commit_message>
<xml_diff>
--- a/docs/presentation/eventsProject-Tache.pptx
+++ b/docs/presentation/eventsProject-Tache.pptx
@@ -5,7 +5,7 @@
     <p:sldMasterId id="2147483648" r:id="rId1"/>
   </p:sldMasterIdLst>
   <p:notesMasterIdLst>
-    <p:notesMasterId r:id="rId21"/>
+    <p:notesMasterId r:id="rId26"/>
   </p:notesMasterIdLst>
   <p:sldIdLst>
     <p:sldId id="256" r:id="rId2"/>
@@ -27,6 +27,11 @@
     <p:sldId id="272" r:id="rId18"/>
     <p:sldId id="273" r:id="rId19"/>
     <p:sldId id="274" r:id="rId20"/>
+    <p:sldId id="275" r:id="rId21"/>
+    <p:sldId id="276" r:id="rId22"/>
+    <p:sldId id="277" r:id="rId23"/>
+    <p:sldId id="278" r:id="rId24"/>
+    <p:sldId id="279" r:id="rId25"/>
   </p:sldIdLst>
   <p:sldSz cx="12192000" cy="6858000"/>
   <p:notesSz cx="6858000" cy="9144000"/>
@@ -208,7 +213,7 @@
             </a:lvl1pPr>
           </a:lstStyle>
           <a:p>
-            <a:fld id="{3D9E8F67-594C-410A-8D75-F3C7CF2974B1}" type="datetimeFigureOut">
+            <a:fld id="{E2A5EAC1-0049-44D6-989B-F817D27EE345}" type="datetimeFigureOut">
               <a:rPr lang="en-US" smtClean="0"/>
               <a:t>10/29/2026</a:t>
             </a:fld>
@@ -367,7 +372,7 @@
             </a:lvl1pPr>
           </a:lstStyle>
           <a:p>
-            <a:fld id="{86FB0CA4-F3F5-4448-B780-C0E244D43AEA}" type="slidenum">
+            <a:fld id="{39E91E94-9227-4269-937B-80A0D5D87A88}" type="slidenum">
               <a:rPr lang="en-US" smtClean="0"/>
               <a:t>‹#›</a:t>
             </a:fld>
@@ -378,7 +383,7 @@
     </p:spTree>
     <p:extLst>
       <p:ext uri="{BB962C8B-B14F-4D97-AF65-F5344CB8AC3E}">
-        <p14:creationId xmlns:p14="http://schemas.microsoft.com/office/powerpoint/2010/main" val="4268559085"/>
+        <p14:creationId xmlns:p14="http://schemas.microsoft.com/office/powerpoint/2010/main" val="1321516564"/>
       </p:ext>
     </p:extLst>
   </p:cSld>
@@ -541,7 +546,7 @@
           <a:bodyPr/>
           <a:lstStyle/>
           <a:p>
-            <a:fld id="{86FB0CA4-F3F5-4448-B780-C0E244D43AEA}" type="slidenum">
+            <a:fld id="{39E91E94-9227-4269-937B-80A0D5D87A88}" type="slidenum">
               <a:rPr lang="en-US" smtClean="0"/>
               <a:t>1</a:t>
             </a:fld>
@@ -552,7 +557,7 @@
     </p:spTree>
     <p:extLst>
       <p:ext uri="{BB962C8B-B14F-4D97-AF65-F5344CB8AC3E}">
-        <p14:creationId xmlns:p14="http://schemas.microsoft.com/office/powerpoint/2010/main" val="972309363"/>
+        <p14:creationId xmlns:p14="http://schemas.microsoft.com/office/powerpoint/2010/main" val="2440493528"/>
       </p:ext>
     </p:extLst>
   </p:cSld>
@@ -625,7 +630,7 @@
           <a:bodyPr/>
           <a:lstStyle/>
           <a:p>
-            <a:fld id="{86FB0CA4-F3F5-4448-B780-C0E244D43AEA}" type="slidenum">
+            <a:fld id="{39E91E94-9227-4269-937B-80A0D5D87A88}" type="slidenum">
               <a:rPr lang="en-US" smtClean="0"/>
               <a:t>10</a:t>
             </a:fld>
@@ -636,7 +641,7 @@
     </p:spTree>
     <p:extLst>
       <p:ext uri="{BB962C8B-B14F-4D97-AF65-F5344CB8AC3E}">
-        <p14:creationId xmlns:p14="http://schemas.microsoft.com/office/powerpoint/2010/main" val="1669097452"/>
+        <p14:creationId xmlns:p14="http://schemas.microsoft.com/office/powerpoint/2010/main" val="2866487243"/>
       </p:ext>
     </p:extLst>
   </p:cSld>
@@ -709,7 +714,7 @@
           <a:bodyPr/>
           <a:lstStyle/>
           <a:p>
-            <a:fld id="{86FB0CA4-F3F5-4448-B780-C0E244D43AEA}" type="slidenum">
+            <a:fld id="{39E91E94-9227-4269-937B-80A0D5D87A88}" type="slidenum">
               <a:rPr lang="en-US" smtClean="0"/>
               <a:t>11</a:t>
             </a:fld>
@@ -720,7 +725,7 @@
     </p:spTree>
     <p:extLst>
       <p:ext uri="{BB962C8B-B14F-4D97-AF65-F5344CB8AC3E}">
-        <p14:creationId xmlns:p14="http://schemas.microsoft.com/office/powerpoint/2010/main" val="3285103363"/>
+        <p14:creationId xmlns:p14="http://schemas.microsoft.com/office/powerpoint/2010/main" val="3865239220"/>
       </p:ext>
     </p:extLst>
   </p:cSld>
@@ -793,7 +798,7 @@
           <a:bodyPr/>
           <a:lstStyle/>
           <a:p>
-            <a:fld id="{86FB0CA4-F3F5-4448-B780-C0E244D43AEA}" type="slidenum">
+            <a:fld id="{39E91E94-9227-4269-937B-80A0D5D87A88}" type="slidenum">
               <a:rPr lang="en-US" smtClean="0"/>
               <a:t>12</a:t>
             </a:fld>
@@ -804,7 +809,7 @@
     </p:spTree>
     <p:extLst>
       <p:ext uri="{BB962C8B-B14F-4D97-AF65-F5344CB8AC3E}">
-        <p14:creationId xmlns:p14="http://schemas.microsoft.com/office/powerpoint/2010/main" val="2889355515"/>
+        <p14:creationId xmlns:p14="http://schemas.microsoft.com/office/powerpoint/2010/main" val="1597038625"/>
       </p:ext>
     </p:extLst>
   </p:cSld>
@@ -877,7 +882,7 @@
           <a:bodyPr/>
           <a:lstStyle/>
           <a:p>
-            <a:fld id="{86FB0CA4-F3F5-4448-B780-C0E244D43AEA}" type="slidenum">
+            <a:fld id="{39E91E94-9227-4269-937B-80A0D5D87A88}" type="slidenum">
               <a:rPr lang="en-US" smtClean="0"/>
               <a:t>13</a:t>
             </a:fld>
@@ -888,7 +893,7 @@
     </p:spTree>
     <p:extLst>
       <p:ext uri="{BB962C8B-B14F-4D97-AF65-F5344CB8AC3E}">
-        <p14:creationId xmlns:p14="http://schemas.microsoft.com/office/powerpoint/2010/main" val="3054751213"/>
+        <p14:creationId xmlns:p14="http://schemas.microsoft.com/office/powerpoint/2010/main" val="2083878556"/>
       </p:ext>
     </p:extLst>
   </p:cSld>
@@ -961,7 +966,7 @@
           <a:bodyPr/>
           <a:lstStyle/>
           <a:p>
-            <a:fld id="{86FB0CA4-F3F5-4448-B780-C0E244D43AEA}" type="slidenum">
+            <a:fld id="{39E91E94-9227-4269-937B-80A0D5D87A88}" type="slidenum">
               <a:rPr lang="en-US" smtClean="0"/>
               <a:t>14</a:t>
             </a:fld>
@@ -972,7 +977,7 @@
     </p:spTree>
     <p:extLst>
       <p:ext uri="{BB962C8B-B14F-4D97-AF65-F5344CB8AC3E}">
-        <p14:creationId xmlns:p14="http://schemas.microsoft.com/office/powerpoint/2010/main" val="2189542704"/>
+        <p14:creationId xmlns:p14="http://schemas.microsoft.com/office/powerpoint/2010/main" val="2401353998"/>
       </p:ext>
     </p:extLst>
   </p:cSld>
@@ -1045,7 +1050,7 @@
           <a:bodyPr/>
           <a:lstStyle/>
           <a:p>
-            <a:fld id="{86FB0CA4-F3F5-4448-B780-C0E244D43AEA}" type="slidenum">
+            <a:fld id="{39E91E94-9227-4269-937B-80A0D5D87A88}" type="slidenum">
               <a:rPr lang="en-US" smtClean="0"/>
               <a:t>15</a:t>
             </a:fld>
@@ -1056,7 +1061,7 @@
     </p:spTree>
     <p:extLst>
       <p:ext uri="{BB962C8B-B14F-4D97-AF65-F5344CB8AC3E}">
-        <p14:creationId xmlns:p14="http://schemas.microsoft.com/office/powerpoint/2010/main" val="2120588604"/>
+        <p14:creationId xmlns:p14="http://schemas.microsoft.com/office/powerpoint/2010/main" val="1074881612"/>
       </p:ext>
     </p:extLst>
   </p:cSld>
@@ -1129,7 +1134,7 @@
           <a:bodyPr/>
           <a:lstStyle/>
           <a:p>
-            <a:fld id="{86FB0CA4-F3F5-4448-B780-C0E244D43AEA}" type="slidenum">
+            <a:fld id="{39E91E94-9227-4269-937B-80A0D5D87A88}" type="slidenum">
               <a:rPr lang="en-US" smtClean="0"/>
               <a:t>16</a:t>
             </a:fld>
@@ -1140,7 +1145,7 @@
     </p:spTree>
     <p:extLst>
       <p:ext uri="{BB962C8B-B14F-4D97-AF65-F5344CB8AC3E}">
-        <p14:creationId xmlns:p14="http://schemas.microsoft.com/office/powerpoint/2010/main" val="1419044385"/>
+        <p14:creationId xmlns:p14="http://schemas.microsoft.com/office/powerpoint/2010/main" val="3600502929"/>
       </p:ext>
     </p:extLst>
   </p:cSld>
@@ -1213,7 +1218,7 @@
           <a:bodyPr/>
           <a:lstStyle/>
           <a:p>
-            <a:fld id="{86FB0CA4-F3F5-4448-B780-C0E244D43AEA}" type="slidenum">
+            <a:fld id="{39E91E94-9227-4269-937B-80A0D5D87A88}" type="slidenum">
               <a:rPr lang="en-US" smtClean="0"/>
               <a:t>17</a:t>
             </a:fld>
@@ -1224,7 +1229,7 @@
     </p:spTree>
     <p:extLst>
       <p:ext uri="{BB962C8B-B14F-4D97-AF65-F5344CB8AC3E}">
-        <p14:creationId xmlns:p14="http://schemas.microsoft.com/office/powerpoint/2010/main" val="4150949435"/>
+        <p14:creationId xmlns:p14="http://schemas.microsoft.com/office/powerpoint/2010/main" val="3240129585"/>
       </p:ext>
     </p:extLst>
   </p:cSld>
@@ -1297,7 +1302,7 @@
           <a:bodyPr/>
           <a:lstStyle/>
           <a:p>
-            <a:fld id="{86FB0CA4-F3F5-4448-B780-C0E244D43AEA}" type="slidenum">
+            <a:fld id="{39E91E94-9227-4269-937B-80A0D5D87A88}" type="slidenum">
               <a:rPr lang="en-US" smtClean="0"/>
               <a:t>18</a:t>
             </a:fld>
@@ -1308,7 +1313,7 @@
     </p:spTree>
     <p:extLst>
       <p:ext uri="{BB962C8B-B14F-4D97-AF65-F5344CB8AC3E}">
-        <p14:creationId xmlns:p14="http://schemas.microsoft.com/office/powerpoint/2010/main" val="1816691837"/>
+        <p14:creationId xmlns:p14="http://schemas.microsoft.com/office/powerpoint/2010/main" val="1307325829"/>
       </p:ext>
     </p:extLst>
   </p:cSld>
@@ -1381,7 +1386,7 @@
           <a:bodyPr/>
           <a:lstStyle/>
           <a:p>
-            <a:fld id="{86FB0CA4-F3F5-4448-B780-C0E244D43AEA}" type="slidenum">
+            <a:fld id="{39E91E94-9227-4269-937B-80A0D5D87A88}" type="slidenum">
               <a:rPr lang="en-US" smtClean="0"/>
               <a:t>19</a:t>
             </a:fld>
@@ -1392,7 +1397,7 @@
     </p:spTree>
     <p:extLst>
       <p:ext uri="{BB962C8B-B14F-4D97-AF65-F5344CB8AC3E}">
-        <p14:creationId xmlns:p14="http://schemas.microsoft.com/office/powerpoint/2010/main" val="1914550509"/>
+        <p14:creationId xmlns:p14="http://schemas.microsoft.com/office/powerpoint/2010/main" val="2482262260"/>
       </p:ext>
     </p:extLst>
   </p:cSld>
@@ -1465,7 +1470,7 @@
           <a:bodyPr/>
           <a:lstStyle/>
           <a:p>
-            <a:fld id="{86FB0CA4-F3F5-4448-B780-C0E244D43AEA}" type="slidenum">
+            <a:fld id="{39E91E94-9227-4269-937B-80A0D5D87A88}" type="slidenum">
               <a:rPr lang="en-US" smtClean="0"/>
               <a:t>2</a:t>
             </a:fld>
@@ -1476,7 +1481,427 @@
     </p:spTree>
     <p:extLst>
       <p:ext uri="{BB962C8B-B14F-4D97-AF65-F5344CB8AC3E}">
-        <p14:creationId xmlns:p14="http://schemas.microsoft.com/office/powerpoint/2010/main" val="3549744349"/>
+        <p14:creationId xmlns:p14="http://schemas.microsoft.com/office/powerpoint/2010/main" val="2399758814"/>
+      </p:ext>
+    </p:extLst>
+  </p:cSld>
+  <p:clrMapOvr>
+    <a:masterClrMapping/>
+  </p:clrMapOvr>
+</p:notes>
+</file>
+
+<file path=ppt/notesSlides/notesSlide20.xml><?xml version="1.0" encoding="utf-8"?>
+<p:notes xmlns:a="http://schemas.openxmlformats.org/drawingml/2006/main" xmlns:r="http://schemas.openxmlformats.org/officeDocument/2006/relationships" xmlns:p="http://schemas.openxmlformats.org/presentationml/2006/main">
+  <p:cSld>
+    <p:spTree>
+      <p:nvGrpSpPr>
+        <p:cNvPr id="1" name=""/>
+        <p:cNvGrpSpPr/>
+        <p:nvPr/>
+      </p:nvGrpSpPr>
+      <p:grpSpPr>
+        <a:xfrm>
+          <a:off x="0" y="0"/>
+          <a:ext cx="0" cy="0"/>
+          <a:chOff x="0" y="0"/>
+          <a:chExt cx="0" cy="0"/>
+        </a:xfrm>
+      </p:grpSpPr>
+      <p:sp>
+        <p:nvSpPr>
+          <p:cNvPr id="2" name="Slide Image Placeholder 1"/>
+          <p:cNvSpPr>
+            <a:spLocks noGrp="1" noRot="1" noChangeAspect="1"/>
+          </p:cNvSpPr>
+          <p:nvPr>
+            <p:ph type="sldImg"/>
+          </p:nvPr>
+        </p:nvSpPr>
+        <p:spPr/>
+      </p:sp>
+      <p:sp>
+        <p:nvSpPr>
+          <p:cNvPr id="3" name="Notes Placeholder 2"/>
+          <p:cNvSpPr>
+            <a:spLocks noGrp="1"/>
+          </p:cNvSpPr>
+          <p:nvPr>
+            <p:ph type="body" idx="1"/>
+          </p:nvPr>
+        </p:nvSpPr>
+        <p:spPr/>
+        <p:txBody>
+          <a:bodyPr/>
+          <a:lstStyle/>
+          <a:p>
+            <a:endParaRPr lang="en-US"/>
+          </a:p>
+        </p:txBody>
+      </p:sp>
+      <p:sp>
+        <p:nvSpPr>
+          <p:cNvPr id="4" name="Slide Number Placeholder 3"/>
+          <p:cNvSpPr>
+            <a:spLocks noGrp="1"/>
+          </p:cNvSpPr>
+          <p:nvPr>
+            <p:ph type="sldNum" sz="quarter" idx="10"/>
+          </p:nvPr>
+        </p:nvSpPr>
+        <p:spPr/>
+        <p:txBody>
+          <a:bodyPr/>
+          <a:lstStyle/>
+          <a:p>
+            <a:fld id="{39E91E94-9227-4269-937B-80A0D5D87A88}" type="slidenum">
+              <a:rPr lang="en-US" smtClean="0"/>
+              <a:t>20</a:t>
+            </a:fld>
+            <a:endParaRPr lang="en-US"/>
+          </a:p>
+        </p:txBody>
+      </p:sp>
+    </p:spTree>
+    <p:extLst>
+      <p:ext uri="{BB962C8B-B14F-4D97-AF65-F5344CB8AC3E}">
+        <p14:creationId xmlns:p14="http://schemas.microsoft.com/office/powerpoint/2010/main" val="1394240634"/>
+      </p:ext>
+    </p:extLst>
+  </p:cSld>
+  <p:clrMapOvr>
+    <a:masterClrMapping/>
+  </p:clrMapOvr>
+</p:notes>
+</file>
+
+<file path=ppt/notesSlides/notesSlide21.xml><?xml version="1.0" encoding="utf-8"?>
+<p:notes xmlns:a="http://schemas.openxmlformats.org/drawingml/2006/main" xmlns:r="http://schemas.openxmlformats.org/officeDocument/2006/relationships" xmlns:p="http://schemas.openxmlformats.org/presentationml/2006/main">
+  <p:cSld>
+    <p:spTree>
+      <p:nvGrpSpPr>
+        <p:cNvPr id="1" name=""/>
+        <p:cNvGrpSpPr/>
+        <p:nvPr/>
+      </p:nvGrpSpPr>
+      <p:grpSpPr>
+        <a:xfrm>
+          <a:off x="0" y="0"/>
+          <a:ext cx="0" cy="0"/>
+          <a:chOff x="0" y="0"/>
+          <a:chExt cx="0" cy="0"/>
+        </a:xfrm>
+      </p:grpSpPr>
+      <p:sp>
+        <p:nvSpPr>
+          <p:cNvPr id="2" name="Slide Image Placeholder 1"/>
+          <p:cNvSpPr>
+            <a:spLocks noGrp="1" noRot="1" noChangeAspect="1"/>
+          </p:cNvSpPr>
+          <p:nvPr>
+            <p:ph type="sldImg"/>
+          </p:nvPr>
+        </p:nvSpPr>
+        <p:spPr/>
+      </p:sp>
+      <p:sp>
+        <p:nvSpPr>
+          <p:cNvPr id="3" name="Notes Placeholder 2"/>
+          <p:cNvSpPr>
+            <a:spLocks noGrp="1"/>
+          </p:cNvSpPr>
+          <p:nvPr>
+            <p:ph type="body" idx="1"/>
+          </p:nvPr>
+        </p:nvSpPr>
+        <p:spPr/>
+        <p:txBody>
+          <a:bodyPr/>
+          <a:lstStyle/>
+          <a:p>
+            <a:endParaRPr lang="en-US"/>
+          </a:p>
+        </p:txBody>
+      </p:sp>
+      <p:sp>
+        <p:nvSpPr>
+          <p:cNvPr id="4" name="Slide Number Placeholder 3"/>
+          <p:cNvSpPr>
+            <a:spLocks noGrp="1"/>
+          </p:cNvSpPr>
+          <p:nvPr>
+            <p:ph type="sldNum" sz="quarter" idx="10"/>
+          </p:nvPr>
+        </p:nvSpPr>
+        <p:spPr/>
+        <p:txBody>
+          <a:bodyPr/>
+          <a:lstStyle/>
+          <a:p>
+            <a:fld id="{39E91E94-9227-4269-937B-80A0D5D87A88}" type="slidenum">
+              <a:rPr lang="en-US" smtClean="0"/>
+              <a:t>21</a:t>
+            </a:fld>
+            <a:endParaRPr lang="en-US"/>
+          </a:p>
+        </p:txBody>
+      </p:sp>
+    </p:spTree>
+    <p:extLst>
+      <p:ext uri="{BB962C8B-B14F-4D97-AF65-F5344CB8AC3E}">
+        <p14:creationId xmlns:p14="http://schemas.microsoft.com/office/powerpoint/2010/main" val="2603842740"/>
+      </p:ext>
+    </p:extLst>
+  </p:cSld>
+  <p:clrMapOvr>
+    <a:masterClrMapping/>
+  </p:clrMapOvr>
+</p:notes>
+</file>
+
+<file path=ppt/notesSlides/notesSlide22.xml><?xml version="1.0" encoding="utf-8"?>
+<p:notes xmlns:a="http://schemas.openxmlformats.org/drawingml/2006/main" xmlns:r="http://schemas.openxmlformats.org/officeDocument/2006/relationships" xmlns:p="http://schemas.openxmlformats.org/presentationml/2006/main">
+  <p:cSld>
+    <p:spTree>
+      <p:nvGrpSpPr>
+        <p:cNvPr id="1" name=""/>
+        <p:cNvGrpSpPr/>
+        <p:nvPr/>
+      </p:nvGrpSpPr>
+      <p:grpSpPr>
+        <a:xfrm>
+          <a:off x="0" y="0"/>
+          <a:ext cx="0" cy="0"/>
+          <a:chOff x="0" y="0"/>
+          <a:chExt cx="0" cy="0"/>
+        </a:xfrm>
+      </p:grpSpPr>
+      <p:sp>
+        <p:nvSpPr>
+          <p:cNvPr id="2" name="Slide Image Placeholder 1"/>
+          <p:cNvSpPr>
+            <a:spLocks noGrp="1" noRot="1" noChangeAspect="1"/>
+          </p:cNvSpPr>
+          <p:nvPr>
+            <p:ph type="sldImg"/>
+          </p:nvPr>
+        </p:nvSpPr>
+        <p:spPr/>
+      </p:sp>
+      <p:sp>
+        <p:nvSpPr>
+          <p:cNvPr id="3" name="Notes Placeholder 2"/>
+          <p:cNvSpPr>
+            <a:spLocks noGrp="1"/>
+          </p:cNvSpPr>
+          <p:nvPr>
+            <p:ph type="body" idx="1"/>
+          </p:nvPr>
+        </p:nvSpPr>
+        <p:spPr/>
+        <p:txBody>
+          <a:bodyPr/>
+          <a:lstStyle/>
+          <a:p>
+            <a:endParaRPr lang="en-US"/>
+          </a:p>
+        </p:txBody>
+      </p:sp>
+      <p:sp>
+        <p:nvSpPr>
+          <p:cNvPr id="4" name="Slide Number Placeholder 3"/>
+          <p:cNvSpPr>
+            <a:spLocks noGrp="1"/>
+          </p:cNvSpPr>
+          <p:nvPr>
+            <p:ph type="sldNum" sz="quarter" idx="10"/>
+          </p:nvPr>
+        </p:nvSpPr>
+        <p:spPr/>
+        <p:txBody>
+          <a:bodyPr/>
+          <a:lstStyle/>
+          <a:p>
+            <a:fld id="{39E91E94-9227-4269-937B-80A0D5D87A88}" type="slidenum">
+              <a:rPr lang="en-US" smtClean="0"/>
+              <a:t>22</a:t>
+            </a:fld>
+            <a:endParaRPr lang="en-US"/>
+          </a:p>
+        </p:txBody>
+      </p:sp>
+    </p:spTree>
+    <p:extLst>
+      <p:ext uri="{BB962C8B-B14F-4D97-AF65-F5344CB8AC3E}">
+        <p14:creationId xmlns:p14="http://schemas.microsoft.com/office/powerpoint/2010/main" val="3629553499"/>
+      </p:ext>
+    </p:extLst>
+  </p:cSld>
+  <p:clrMapOvr>
+    <a:masterClrMapping/>
+  </p:clrMapOvr>
+</p:notes>
+</file>
+
+<file path=ppt/notesSlides/notesSlide23.xml><?xml version="1.0" encoding="utf-8"?>
+<p:notes xmlns:a="http://schemas.openxmlformats.org/drawingml/2006/main" xmlns:r="http://schemas.openxmlformats.org/officeDocument/2006/relationships" xmlns:p="http://schemas.openxmlformats.org/presentationml/2006/main">
+  <p:cSld>
+    <p:spTree>
+      <p:nvGrpSpPr>
+        <p:cNvPr id="1" name=""/>
+        <p:cNvGrpSpPr/>
+        <p:nvPr/>
+      </p:nvGrpSpPr>
+      <p:grpSpPr>
+        <a:xfrm>
+          <a:off x="0" y="0"/>
+          <a:ext cx="0" cy="0"/>
+          <a:chOff x="0" y="0"/>
+          <a:chExt cx="0" cy="0"/>
+        </a:xfrm>
+      </p:grpSpPr>
+      <p:sp>
+        <p:nvSpPr>
+          <p:cNvPr id="2" name="Slide Image Placeholder 1"/>
+          <p:cNvSpPr>
+            <a:spLocks noGrp="1" noRot="1" noChangeAspect="1"/>
+          </p:cNvSpPr>
+          <p:nvPr>
+            <p:ph type="sldImg"/>
+          </p:nvPr>
+        </p:nvSpPr>
+        <p:spPr/>
+      </p:sp>
+      <p:sp>
+        <p:nvSpPr>
+          <p:cNvPr id="3" name="Notes Placeholder 2"/>
+          <p:cNvSpPr>
+            <a:spLocks noGrp="1"/>
+          </p:cNvSpPr>
+          <p:nvPr>
+            <p:ph type="body" idx="1"/>
+          </p:nvPr>
+        </p:nvSpPr>
+        <p:spPr/>
+        <p:txBody>
+          <a:bodyPr/>
+          <a:lstStyle/>
+          <a:p>
+            <a:endParaRPr lang="en-US"/>
+          </a:p>
+        </p:txBody>
+      </p:sp>
+      <p:sp>
+        <p:nvSpPr>
+          <p:cNvPr id="4" name="Slide Number Placeholder 3"/>
+          <p:cNvSpPr>
+            <a:spLocks noGrp="1"/>
+          </p:cNvSpPr>
+          <p:nvPr>
+            <p:ph type="sldNum" sz="quarter" idx="10"/>
+          </p:nvPr>
+        </p:nvSpPr>
+        <p:spPr/>
+        <p:txBody>
+          <a:bodyPr/>
+          <a:lstStyle/>
+          <a:p>
+            <a:fld id="{39E91E94-9227-4269-937B-80A0D5D87A88}" type="slidenum">
+              <a:rPr lang="en-US" smtClean="0"/>
+              <a:t>23</a:t>
+            </a:fld>
+            <a:endParaRPr lang="en-US"/>
+          </a:p>
+        </p:txBody>
+      </p:sp>
+    </p:spTree>
+    <p:extLst>
+      <p:ext uri="{BB962C8B-B14F-4D97-AF65-F5344CB8AC3E}">
+        <p14:creationId xmlns:p14="http://schemas.microsoft.com/office/powerpoint/2010/main" val="2291460243"/>
+      </p:ext>
+    </p:extLst>
+  </p:cSld>
+  <p:clrMapOvr>
+    <a:masterClrMapping/>
+  </p:clrMapOvr>
+</p:notes>
+</file>
+
+<file path=ppt/notesSlides/notesSlide24.xml><?xml version="1.0" encoding="utf-8"?>
+<p:notes xmlns:a="http://schemas.openxmlformats.org/drawingml/2006/main" xmlns:r="http://schemas.openxmlformats.org/officeDocument/2006/relationships" xmlns:p="http://schemas.openxmlformats.org/presentationml/2006/main">
+  <p:cSld>
+    <p:spTree>
+      <p:nvGrpSpPr>
+        <p:cNvPr id="1" name=""/>
+        <p:cNvGrpSpPr/>
+        <p:nvPr/>
+      </p:nvGrpSpPr>
+      <p:grpSpPr>
+        <a:xfrm>
+          <a:off x="0" y="0"/>
+          <a:ext cx="0" cy="0"/>
+          <a:chOff x="0" y="0"/>
+          <a:chExt cx="0" cy="0"/>
+        </a:xfrm>
+      </p:grpSpPr>
+      <p:sp>
+        <p:nvSpPr>
+          <p:cNvPr id="2" name="Slide Image Placeholder 1"/>
+          <p:cNvSpPr>
+            <a:spLocks noGrp="1" noRot="1" noChangeAspect="1"/>
+          </p:cNvSpPr>
+          <p:nvPr>
+            <p:ph type="sldImg"/>
+          </p:nvPr>
+        </p:nvSpPr>
+        <p:spPr/>
+      </p:sp>
+      <p:sp>
+        <p:nvSpPr>
+          <p:cNvPr id="3" name="Notes Placeholder 2"/>
+          <p:cNvSpPr>
+            <a:spLocks noGrp="1"/>
+          </p:cNvSpPr>
+          <p:nvPr>
+            <p:ph type="body" idx="1"/>
+          </p:nvPr>
+        </p:nvSpPr>
+        <p:spPr/>
+        <p:txBody>
+          <a:bodyPr/>
+          <a:lstStyle/>
+          <a:p>
+            <a:endParaRPr lang="en-US"/>
+          </a:p>
+        </p:txBody>
+      </p:sp>
+      <p:sp>
+        <p:nvSpPr>
+          <p:cNvPr id="4" name="Slide Number Placeholder 3"/>
+          <p:cNvSpPr>
+            <a:spLocks noGrp="1"/>
+          </p:cNvSpPr>
+          <p:nvPr>
+            <p:ph type="sldNum" sz="quarter" idx="10"/>
+          </p:nvPr>
+        </p:nvSpPr>
+        <p:spPr/>
+        <p:txBody>
+          <a:bodyPr/>
+          <a:lstStyle/>
+          <a:p>
+            <a:fld id="{39E91E94-9227-4269-937B-80A0D5D87A88}" type="slidenum">
+              <a:rPr lang="en-US" smtClean="0"/>
+              <a:t>24</a:t>
+            </a:fld>
+            <a:endParaRPr lang="en-US"/>
+          </a:p>
+        </p:txBody>
+      </p:sp>
+    </p:spTree>
+    <p:extLst>
+      <p:ext uri="{BB962C8B-B14F-4D97-AF65-F5344CB8AC3E}">
+        <p14:creationId xmlns:p14="http://schemas.microsoft.com/office/powerpoint/2010/main" val="3229301419"/>
       </p:ext>
     </p:extLst>
   </p:cSld>
@@ -1549,7 +1974,7 @@
           <a:bodyPr/>
           <a:lstStyle/>
           <a:p>
-            <a:fld id="{86FB0CA4-F3F5-4448-B780-C0E244D43AEA}" type="slidenum">
+            <a:fld id="{39E91E94-9227-4269-937B-80A0D5D87A88}" type="slidenum">
               <a:rPr lang="en-US" smtClean="0"/>
               <a:t>3</a:t>
             </a:fld>
@@ -1560,7 +1985,7 @@
     </p:spTree>
     <p:extLst>
       <p:ext uri="{BB962C8B-B14F-4D97-AF65-F5344CB8AC3E}">
-        <p14:creationId xmlns:p14="http://schemas.microsoft.com/office/powerpoint/2010/main" val="507341278"/>
+        <p14:creationId xmlns:p14="http://schemas.microsoft.com/office/powerpoint/2010/main" val="2779272014"/>
       </p:ext>
     </p:extLst>
   </p:cSld>
@@ -1633,7 +2058,7 @@
           <a:bodyPr/>
           <a:lstStyle/>
           <a:p>
-            <a:fld id="{86FB0CA4-F3F5-4448-B780-C0E244D43AEA}" type="slidenum">
+            <a:fld id="{39E91E94-9227-4269-937B-80A0D5D87A88}" type="slidenum">
               <a:rPr lang="en-US" smtClean="0"/>
               <a:t>4</a:t>
             </a:fld>
@@ -1644,7 +2069,7 @@
     </p:spTree>
     <p:extLst>
       <p:ext uri="{BB962C8B-B14F-4D97-AF65-F5344CB8AC3E}">
-        <p14:creationId xmlns:p14="http://schemas.microsoft.com/office/powerpoint/2010/main" val="1116828471"/>
+        <p14:creationId xmlns:p14="http://schemas.microsoft.com/office/powerpoint/2010/main" val="4138991492"/>
       </p:ext>
     </p:extLst>
   </p:cSld>
@@ -1717,7 +2142,7 @@
           <a:bodyPr/>
           <a:lstStyle/>
           <a:p>
-            <a:fld id="{86FB0CA4-F3F5-4448-B780-C0E244D43AEA}" type="slidenum">
+            <a:fld id="{39E91E94-9227-4269-937B-80A0D5D87A88}" type="slidenum">
               <a:rPr lang="en-US" smtClean="0"/>
               <a:t>5</a:t>
             </a:fld>
@@ -1728,7 +2153,7 @@
     </p:spTree>
     <p:extLst>
       <p:ext uri="{BB962C8B-B14F-4D97-AF65-F5344CB8AC3E}">
-        <p14:creationId xmlns:p14="http://schemas.microsoft.com/office/powerpoint/2010/main" val="1393431680"/>
+        <p14:creationId xmlns:p14="http://schemas.microsoft.com/office/powerpoint/2010/main" val="3496718713"/>
       </p:ext>
     </p:extLst>
   </p:cSld>
@@ -1801,7 +2226,7 @@
           <a:bodyPr/>
           <a:lstStyle/>
           <a:p>
-            <a:fld id="{86FB0CA4-F3F5-4448-B780-C0E244D43AEA}" type="slidenum">
+            <a:fld id="{39E91E94-9227-4269-937B-80A0D5D87A88}" type="slidenum">
               <a:rPr lang="en-US" smtClean="0"/>
               <a:t>6</a:t>
             </a:fld>
@@ -1812,7 +2237,7 @@
     </p:spTree>
     <p:extLst>
       <p:ext uri="{BB962C8B-B14F-4D97-AF65-F5344CB8AC3E}">
-        <p14:creationId xmlns:p14="http://schemas.microsoft.com/office/powerpoint/2010/main" val="1659331410"/>
+        <p14:creationId xmlns:p14="http://schemas.microsoft.com/office/powerpoint/2010/main" val="2760396397"/>
       </p:ext>
     </p:extLst>
   </p:cSld>
@@ -1885,7 +2310,7 @@
           <a:bodyPr/>
           <a:lstStyle/>
           <a:p>
-            <a:fld id="{86FB0CA4-F3F5-4448-B780-C0E244D43AEA}" type="slidenum">
+            <a:fld id="{39E91E94-9227-4269-937B-80A0D5D87A88}" type="slidenum">
               <a:rPr lang="en-US" smtClean="0"/>
               <a:t>7</a:t>
             </a:fld>
@@ -1896,7 +2321,7 @@
     </p:spTree>
     <p:extLst>
       <p:ext uri="{BB962C8B-B14F-4D97-AF65-F5344CB8AC3E}">
-        <p14:creationId xmlns:p14="http://schemas.microsoft.com/office/powerpoint/2010/main" val="2715580459"/>
+        <p14:creationId xmlns:p14="http://schemas.microsoft.com/office/powerpoint/2010/main" val="715391740"/>
       </p:ext>
     </p:extLst>
   </p:cSld>
@@ -1969,7 +2394,7 @@
           <a:bodyPr/>
           <a:lstStyle/>
           <a:p>
-            <a:fld id="{86FB0CA4-F3F5-4448-B780-C0E244D43AEA}" type="slidenum">
+            <a:fld id="{39E91E94-9227-4269-937B-80A0D5D87A88}" type="slidenum">
               <a:rPr lang="en-US" smtClean="0"/>
               <a:t>8</a:t>
             </a:fld>
@@ -1980,7 +2405,7 @@
     </p:spTree>
     <p:extLst>
       <p:ext uri="{BB962C8B-B14F-4D97-AF65-F5344CB8AC3E}">
-        <p14:creationId xmlns:p14="http://schemas.microsoft.com/office/powerpoint/2010/main" val="1717416255"/>
+        <p14:creationId xmlns:p14="http://schemas.microsoft.com/office/powerpoint/2010/main" val="818798279"/>
       </p:ext>
     </p:extLst>
   </p:cSld>
@@ -2053,7 +2478,7 @@
           <a:bodyPr/>
           <a:lstStyle/>
           <a:p>
-            <a:fld id="{86FB0CA4-F3F5-4448-B780-C0E244D43AEA}" type="slidenum">
+            <a:fld id="{39E91E94-9227-4269-937B-80A0D5D87A88}" type="slidenum">
               <a:rPr lang="en-US" smtClean="0"/>
               <a:t>9</a:t>
             </a:fld>
@@ -2064,7 +2489,7 @@
     </p:spTree>
     <p:extLst>
       <p:ext uri="{BB962C8B-B14F-4D97-AF65-F5344CB8AC3E}">
-        <p14:creationId xmlns:p14="http://schemas.microsoft.com/office/powerpoint/2010/main" val="4259646062"/>
+        <p14:creationId xmlns:p14="http://schemas.microsoft.com/office/powerpoint/2010/main" val="598568397"/>
       </p:ext>
     </p:extLst>
   </p:cSld>
@@ -2203,7 +2628,7 @@
           <a:bodyPr/>
           <a:lstStyle/>
           <a:p>
-            <a:fld id="{87AE9DAE-BDE8-4290-836F-6F9C5B1661FB}" type="datetimeFigureOut">
+            <a:fld id="{DF576A0F-B297-49EA-9A26-68F7C937C1F4}" type="datetimeFigureOut">
               <a:rPr lang="en-US" smtClean="0"/>
               <a:t>10/29/2026</a:t>
             </a:fld>
@@ -2245,7 +2670,7 @@
           <a:bodyPr/>
           <a:lstStyle/>
           <a:p>
-            <a:fld id="{42A21DF6-8644-4A2E-9DB5-7834D67732D0}" type="slidenum">
+            <a:fld id="{2A7D25A6-F907-4F71-B230-A0943727CD78}" type="slidenum">
               <a:rPr lang="en-US" smtClean="0"/>
               <a:t>‹#›</a:t>
             </a:fld>
@@ -2256,7 +2681,7 @@
     </p:spTree>
     <p:extLst>
       <p:ext uri="{BB962C8B-B14F-4D97-AF65-F5344CB8AC3E}">
-        <p14:creationId xmlns:p14="http://schemas.microsoft.com/office/powerpoint/2010/main" val="1147545009"/>
+        <p14:creationId xmlns:p14="http://schemas.microsoft.com/office/powerpoint/2010/main" val="1096479138"/>
       </p:ext>
     </p:extLst>
   </p:cSld>
@@ -2373,7 +2798,7 @@
           <a:bodyPr/>
           <a:lstStyle/>
           <a:p>
-            <a:fld id="{87AE9DAE-BDE8-4290-836F-6F9C5B1661FB}" type="datetimeFigureOut">
+            <a:fld id="{DF576A0F-B297-49EA-9A26-68F7C937C1F4}" type="datetimeFigureOut">
               <a:rPr lang="en-US" smtClean="0"/>
               <a:t>10/29/2026</a:t>
             </a:fld>
@@ -2415,7 +2840,7 @@
           <a:bodyPr/>
           <a:lstStyle/>
           <a:p>
-            <a:fld id="{42A21DF6-8644-4A2E-9DB5-7834D67732D0}" type="slidenum">
+            <a:fld id="{2A7D25A6-F907-4F71-B230-A0943727CD78}" type="slidenum">
               <a:rPr lang="en-US" smtClean="0"/>
               <a:t>‹#›</a:t>
             </a:fld>
@@ -2426,7 +2851,7 @@
     </p:spTree>
     <p:extLst>
       <p:ext uri="{BB962C8B-B14F-4D97-AF65-F5344CB8AC3E}">
-        <p14:creationId xmlns:p14="http://schemas.microsoft.com/office/powerpoint/2010/main" val="1256824020"/>
+        <p14:creationId xmlns:p14="http://schemas.microsoft.com/office/powerpoint/2010/main" val="2448885096"/>
       </p:ext>
     </p:extLst>
   </p:cSld>
@@ -2553,7 +2978,7 @@
           <a:bodyPr/>
           <a:lstStyle/>
           <a:p>
-            <a:fld id="{87AE9DAE-BDE8-4290-836F-6F9C5B1661FB}" type="datetimeFigureOut">
+            <a:fld id="{DF576A0F-B297-49EA-9A26-68F7C937C1F4}" type="datetimeFigureOut">
               <a:rPr lang="en-US" smtClean="0"/>
               <a:t>10/29/2026</a:t>
             </a:fld>
@@ -2595,7 +3020,7 @@
           <a:bodyPr/>
           <a:lstStyle/>
           <a:p>
-            <a:fld id="{42A21DF6-8644-4A2E-9DB5-7834D67732D0}" type="slidenum">
+            <a:fld id="{2A7D25A6-F907-4F71-B230-A0943727CD78}" type="slidenum">
               <a:rPr lang="en-US" smtClean="0"/>
               <a:t>‹#›</a:t>
             </a:fld>
@@ -2606,7 +3031,7 @@
     </p:spTree>
     <p:extLst>
       <p:ext uri="{BB962C8B-B14F-4D97-AF65-F5344CB8AC3E}">
-        <p14:creationId xmlns:p14="http://schemas.microsoft.com/office/powerpoint/2010/main" val="3654701131"/>
+        <p14:creationId xmlns:p14="http://schemas.microsoft.com/office/powerpoint/2010/main" val="464436706"/>
       </p:ext>
     </p:extLst>
   </p:cSld>
@@ -2723,7 +3148,7 @@
           <a:bodyPr/>
           <a:lstStyle/>
           <a:p>
-            <a:fld id="{87AE9DAE-BDE8-4290-836F-6F9C5B1661FB}" type="datetimeFigureOut">
+            <a:fld id="{DF576A0F-B297-49EA-9A26-68F7C937C1F4}" type="datetimeFigureOut">
               <a:rPr lang="en-US" smtClean="0"/>
               <a:t>10/29/2026</a:t>
             </a:fld>
@@ -2765,7 +3190,7 @@
           <a:bodyPr/>
           <a:lstStyle/>
           <a:p>
-            <a:fld id="{42A21DF6-8644-4A2E-9DB5-7834D67732D0}" type="slidenum">
+            <a:fld id="{2A7D25A6-F907-4F71-B230-A0943727CD78}" type="slidenum">
               <a:rPr lang="en-US" smtClean="0"/>
               <a:t>‹#›</a:t>
             </a:fld>
@@ -2776,7 +3201,7 @@
     </p:spTree>
     <p:extLst>
       <p:ext uri="{BB962C8B-B14F-4D97-AF65-F5344CB8AC3E}">
-        <p14:creationId xmlns:p14="http://schemas.microsoft.com/office/powerpoint/2010/main" val="515184777"/>
+        <p14:creationId xmlns:p14="http://schemas.microsoft.com/office/powerpoint/2010/main" val="1032933428"/>
       </p:ext>
     </p:extLst>
   </p:cSld>
@@ -2969,7 +3394,7 @@
           <a:bodyPr/>
           <a:lstStyle/>
           <a:p>
-            <a:fld id="{87AE9DAE-BDE8-4290-836F-6F9C5B1661FB}" type="datetimeFigureOut">
+            <a:fld id="{DF576A0F-B297-49EA-9A26-68F7C937C1F4}" type="datetimeFigureOut">
               <a:rPr lang="en-US" smtClean="0"/>
               <a:t>10/29/2026</a:t>
             </a:fld>
@@ -3011,7 +3436,7 @@
           <a:bodyPr/>
           <a:lstStyle/>
           <a:p>
-            <a:fld id="{42A21DF6-8644-4A2E-9DB5-7834D67732D0}" type="slidenum">
+            <a:fld id="{2A7D25A6-F907-4F71-B230-A0943727CD78}" type="slidenum">
               <a:rPr lang="en-US" smtClean="0"/>
               <a:t>‹#›</a:t>
             </a:fld>
@@ -3022,7 +3447,7 @@
     </p:spTree>
     <p:extLst>
       <p:ext uri="{BB962C8B-B14F-4D97-AF65-F5344CB8AC3E}">
-        <p14:creationId xmlns:p14="http://schemas.microsoft.com/office/powerpoint/2010/main" val="1401461055"/>
+        <p14:creationId xmlns:p14="http://schemas.microsoft.com/office/powerpoint/2010/main" val="1039457174"/>
       </p:ext>
     </p:extLst>
   </p:cSld>
@@ -3201,7 +3626,7 @@
           <a:bodyPr/>
           <a:lstStyle/>
           <a:p>
-            <a:fld id="{87AE9DAE-BDE8-4290-836F-6F9C5B1661FB}" type="datetimeFigureOut">
+            <a:fld id="{DF576A0F-B297-49EA-9A26-68F7C937C1F4}" type="datetimeFigureOut">
               <a:rPr lang="en-US" smtClean="0"/>
               <a:t>10/29/2026</a:t>
             </a:fld>
@@ -3243,7 +3668,7 @@
           <a:bodyPr/>
           <a:lstStyle/>
           <a:p>
-            <a:fld id="{42A21DF6-8644-4A2E-9DB5-7834D67732D0}" type="slidenum">
+            <a:fld id="{2A7D25A6-F907-4F71-B230-A0943727CD78}" type="slidenum">
               <a:rPr lang="en-US" smtClean="0"/>
               <a:t>‹#›</a:t>
             </a:fld>
@@ -3254,7 +3679,7 @@
     </p:spTree>
     <p:extLst>
       <p:ext uri="{BB962C8B-B14F-4D97-AF65-F5344CB8AC3E}">
-        <p14:creationId xmlns:p14="http://schemas.microsoft.com/office/powerpoint/2010/main" val="1584025628"/>
+        <p14:creationId xmlns:p14="http://schemas.microsoft.com/office/powerpoint/2010/main" val="871475173"/>
       </p:ext>
     </p:extLst>
   </p:cSld>
@@ -3568,7 +3993,7 @@
           <a:bodyPr/>
           <a:lstStyle/>
           <a:p>
-            <a:fld id="{87AE9DAE-BDE8-4290-836F-6F9C5B1661FB}" type="datetimeFigureOut">
+            <a:fld id="{DF576A0F-B297-49EA-9A26-68F7C937C1F4}" type="datetimeFigureOut">
               <a:rPr lang="en-US" smtClean="0"/>
               <a:t>10/29/2026</a:t>
             </a:fld>
@@ -3610,7 +4035,7 @@
           <a:bodyPr/>
           <a:lstStyle/>
           <a:p>
-            <a:fld id="{42A21DF6-8644-4A2E-9DB5-7834D67732D0}" type="slidenum">
+            <a:fld id="{2A7D25A6-F907-4F71-B230-A0943727CD78}" type="slidenum">
               <a:rPr lang="en-US" smtClean="0"/>
               <a:t>‹#›</a:t>
             </a:fld>
@@ -3621,7 +4046,7 @@
     </p:spTree>
     <p:extLst>
       <p:ext uri="{BB962C8B-B14F-4D97-AF65-F5344CB8AC3E}">
-        <p14:creationId xmlns:p14="http://schemas.microsoft.com/office/powerpoint/2010/main" val="1047490338"/>
+        <p14:creationId xmlns:p14="http://schemas.microsoft.com/office/powerpoint/2010/main" val="2342612629"/>
       </p:ext>
     </p:extLst>
   </p:cSld>
@@ -3686,7 +4111,7 @@
           <a:bodyPr/>
           <a:lstStyle/>
           <a:p>
-            <a:fld id="{87AE9DAE-BDE8-4290-836F-6F9C5B1661FB}" type="datetimeFigureOut">
+            <a:fld id="{DF576A0F-B297-49EA-9A26-68F7C937C1F4}" type="datetimeFigureOut">
               <a:rPr lang="en-US" smtClean="0"/>
               <a:t>10/29/2026</a:t>
             </a:fld>
@@ -3728,7 +4153,7 @@
           <a:bodyPr/>
           <a:lstStyle/>
           <a:p>
-            <a:fld id="{42A21DF6-8644-4A2E-9DB5-7834D67732D0}" type="slidenum">
+            <a:fld id="{2A7D25A6-F907-4F71-B230-A0943727CD78}" type="slidenum">
               <a:rPr lang="en-US" smtClean="0"/>
               <a:t>‹#›</a:t>
             </a:fld>
@@ -3739,7 +4164,7 @@
     </p:spTree>
     <p:extLst>
       <p:ext uri="{BB962C8B-B14F-4D97-AF65-F5344CB8AC3E}">
-        <p14:creationId xmlns:p14="http://schemas.microsoft.com/office/powerpoint/2010/main" val="1760479461"/>
+        <p14:creationId xmlns:p14="http://schemas.microsoft.com/office/powerpoint/2010/main" val="1164170204"/>
       </p:ext>
     </p:extLst>
   </p:cSld>
@@ -3781,7 +4206,7 @@
           <a:bodyPr/>
           <a:lstStyle/>
           <a:p>
-            <a:fld id="{87AE9DAE-BDE8-4290-836F-6F9C5B1661FB}" type="datetimeFigureOut">
+            <a:fld id="{DF576A0F-B297-49EA-9A26-68F7C937C1F4}" type="datetimeFigureOut">
               <a:rPr lang="en-US" smtClean="0"/>
               <a:t>10/29/2026</a:t>
             </a:fld>
@@ -3823,7 +4248,7 @@
           <a:bodyPr/>
           <a:lstStyle/>
           <a:p>
-            <a:fld id="{42A21DF6-8644-4A2E-9DB5-7834D67732D0}" type="slidenum">
+            <a:fld id="{2A7D25A6-F907-4F71-B230-A0943727CD78}" type="slidenum">
               <a:rPr lang="en-US" smtClean="0"/>
               <a:t>‹#›</a:t>
             </a:fld>
@@ -3834,7 +4259,7 @@
     </p:spTree>
     <p:extLst>
       <p:ext uri="{BB962C8B-B14F-4D97-AF65-F5344CB8AC3E}">
-        <p14:creationId xmlns:p14="http://schemas.microsoft.com/office/powerpoint/2010/main" val="3746719913"/>
+        <p14:creationId xmlns:p14="http://schemas.microsoft.com/office/powerpoint/2010/main" val="1918931567"/>
       </p:ext>
     </p:extLst>
   </p:cSld>
@@ -4058,7 +4483,7 @@
           <a:bodyPr/>
           <a:lstStyle/>
           <a:p>
-            <a:fld id="{87AE9DAE-BDE8-4290-836F-6F9C5B1661FB}" type="datetimeFigureOut">
+            <a:fld id="{DF576A0F-B297-49EA-9A26-68F7C937C1F4}" type="datetimeFigureOut">
               <a:rPr lang="en-US" smtClean="0"/>
               <a:t>10/29/2026</a:t>
             </a:fld>
@@ -4100,7 +4525,7 @@
           <a:bodyPr/>
           <a:lstStyle/>
           <a:p>
-            <a:fld id="{42A21DF6-8644-4A2E-9DB5-7834D67732D0}" type="slidenum">
+            <a:fld id="{2A7D25A6-F907-4F71-B230-A0943727CD78}" type="slidenum">
               <a:rPr lang="en-US" smtClean="0"/>
               <a:t>‹#›</a:t>
             </a:fld>
@@ -4111,7 +4536,7 @@
     </p:spTree>
     <p:extLst>
       <p:ext uri="{BB962C8B-B14F-4D97-AF65-F5344CB8AC3E}">
-        <p14:creationId xmlns:p14="http://schemas.microsoft.com/office/powerpoint/2010/main" val="2592373594"/>
+        <p14:creationId xmlns:p14="http://schemas.microsoft.com/office/powerpoint/2010/main" val="1585973772"/>
       </p:ext>
     </p:extLst>
   </p:cSld>
@@ -4311,7 +4736,7 @@
           <a:bodyPr/>
           <a:lstStyle/>
           <a:p>
-            <a:fld id="{87AE9DAE-BDE8-4290-836F-6F9C5B1661FB}" type="datetimeFigureOut">
+            <a:fld id="{DF576A0F-B297-49EA-9A26-68F7C937C1F4}" type="datetimeFigureOut">
               <a:rPr lang="en-US" smtClean="0"/>
               <a:t>10/29/2026</a:t>
             </a:fld>
@@ -4353,7 +4778,7 @@
           <a:bodyPr/>
           <a:lstStyle/>
           <a:p>
-            <a:fld id="{42A21DF6-8644-4A2E-9DB5-7834D67732D0}" type="slidenum">
+            <a:fld id="{2A7D25A6-F907-4F71-B230-A0943727CD78}" type="slidenum">
               <a:rPr lang="en-US" smtClean="0"/>
               <a:t>‹#›</a:t>
             </a:fld>
@@ -4364,7 +4789,7 @@
     </p:spTree>
     <p:extLst>
       <p:ext uri="{BB962C8B-B14F-4D97-AF65-F5344CB8AC3E}">
-        <p14:creationId xmlns:p14="http://schemas.microsoft.com/office/powerpoint/2010/main" val="1973744766"/>
+        <p14:creationId xmlns:p14="http://schemas.microsoft.com/office/powerpoint/2010/main" val="692165931"/>
       </p:ext>
     </p:extLst>
   </p:cSld>
@@ -4524,7 +4949,7 @@
             </a:lvl1pPr>
           </a:lstStyle>
           <a:p>
-            <a:fld id="{87AE9DAE-BDE8-4290-836F-6F9C5B1661FB}" type="datetimeFigureOut">
+            <a:fld id="{DF576A0F-B297-49EA-9A26-68F7C937C1F4}" type="datetimeFigureOut">
               <a:rPr lang="en-US" smtClean="0"/>
               <a:t>10/29/2026</a:t>
             </a:fld>
@@ -4602,7 +5027,7 @@
             </a:lvl1pPr>
           </a:lstStyle>
           <a:p>
-            <a:fld id="{42A21DF6-8644-4A2E-9DB5-7834D67732D0}" type="slidenum">
+            <a:fld id="{2A7D25A6-F907-4F71-B230-A0943727CD78}" type="slidenum">
               <a:rPr lang="en-US" smtClean="0"/>
               <a:t>‹#›</a:t>
             </a:fld>
@@ -4613,7 +5038,7 @@
     </p:spTree>
     <p:extLst>
       <p:ext uri="{BB962C8B-B14F-4D97-AF65-F5344CB8AC3E}">
-        <p14:creationId xmlns:p14="http://schemas.microsoft.com/office/powerpoint/2010/main" val="1541516362"/>
+        <p14:creationId xmlns:p14="http://schemas.microsoft.com/office/powerpoint/2010/main" val="3335129912"/>
       </p:ext>
     </p:extLst>
   </p:cSld>
@@ -5183,7 +5608,7 @@
     </p:spTree>
     <p:extLst>
       <p:ext uri="{BB962C8B-B14F-4D97-AF65-F5344CB8AC3E}">
-        <p14:creationId xmlns:p14="http://schemas.microsoft.com/office/powerpoint/2010/main" val="144726698"/>
+        <p14:creationId xmlns:p14="http://schemas.microsoft.com/office/powerpoint/2010/main" val="486204109"/>
       </p:ext>
     </p:extLst>
   </p:cSld>
@@ -5281,13 +5706,13 @@
           <a:lstStyle/>
           <a:p>
             <a:r>
-              <a:rPr lang="en-US" sz="2800" smtClean="0">
+              <a:rPr lang="fr-FR" sz="2800" smtClean="0">
                 <a:solidFill>
                   <a:srgbClr val="FFFFFF"/>
                 </a:solidFill>
                 <a:latin typeface="Segoe UI" panose="020B0502040204020203" pitchFamily="34" charset="0"/>
               </a:rPr>
-              <a:t>Des logs utiles</a:t>
+              <a:t>Une analyse Sonar réellement évaluée</a:t>
             </a:r>
             <a:endParaRPr lang="en-US" sz="2800">
               <a:solidFill>
@@ -5327,7 +5752,7 @@
                 </a:solidFill>
                 <a:latin typeface="Segoe UI" panose="020B0502040204020203" pitchFamily="34" charset="0"/>
               </a:rPr>
-              <a:t>DEBUG, INFO, WARN sur API ; ERROR démontré par une panne simulée dans un test.</a:t>
+              <a:t>Gate OK : nouveau code couvert à 81,9 %, duplication nulle et aucune violation nouvelle.</a:t>
             </a:r>
             <a:endParaRPr lang="en-US" sz="1600">
               <a:solidFill>
@@ -5360,8 +5785,8 @@
         </p:blipFill>
         <p:spPr>
           <a:xfrm>
-            <a:off x="1953054" y="1981200"/>
-            <a:ext cx="8285892" cy="4318000"/>
+            <a:off x="2209800" y="1981200"/>
+            <a:ext cx="7772400" cy="4318000"/>
           </a:xfrm>
           <a:prstGeom prst="rect">
             <a:avLst/>
@@ -5397,7 +5822,7 @@
                 </a:solidFill>
                 <a:latin typeface="Segoe UI" panose="020B0502040204020203" pitchFamily="34" charset="0"/>
               </a:rPr>
-              <a:t>Preuve : 03-logging/tache-levels.png</a:t>
+              <a:t>Preuve : 06-sonarqube/sonar-final-new-code.png</a:t>
             </a:r>
             <a:endParaRPr lang="en-US" sz="900">
               <a:solidFill>
@@ -5451,7 +5876,7 @@
     </p:spTree>
     <p:extLst>
       <p:ext uri="{BB962C8B-B14F-4D97-AF65-F5344CB8AC3E}">
-        <p14:creationId xmlns:p14="http://schemas.microsoft.com/office/powerpoint/2010/main" val="1633829534"/>
+        <p14:creationId xmlns:p14="http://schemas.microsoft.com/office/powerpoint/2010/main" val="3298236615"/>
       </p:ext>
     </p:extLst>
   </p:cSld>
@@ -5555,7 +5980,7 @@
                 </a:solidFill>
                 <a:latin typeface="Segoe UI" panose="020B0502040204020203" pitchFamily="34" charset="0"/>
               </a:rPr>
-              <a:t>Application et MySQL en conteneurs</a:t>
+              <a:t>Une qualité mesurée sans masquer le périmètre</a:t>
             </a:r>
             <a:endParaRPr lang="en-US" sz="2800">
               <a:solidFill>
@@ -5595,7 +6020,7 @@
                 </a:solidFill>
                 <a:latin typeface="Segoe UI" panose="020B0502040204020203" pitchFamily="34" charset="0"/>
               </a:rPr>
-              <a:t>Cycle HTTP vérifié dans Docker ; readiness UP et utilisateur applicatif non privilégié.</a:t>
+              <a:t>Zéro vulnérabilité après correction des quatre entrées ; couverture globale 49,6 %, distincte du nouveau code.</a:t>
             </a:r>
             <a:endParaRPr lang="en-US" sz="1600">
               <a:solidFill>
@@ -5628,8 +6053,8 @@
         </p:blipFill>
         <p:spPr>
           <a:xfrm>
-            <a:off x="1953054" y="1981200"/>
-            <a:ext cx="8285892" cy="4318000"/>
+            <a:off x="2209800" y="1981200"/>
+            <a:ext cx="7772400" cy="4318000"/>
           </a:xfrm>
           <a:prstGeom prst="rect">
             <a:avLst/>
@@ -5665,7 +6090,7 @@
                 </a:solidFill>
                 <a:latin typeface="Segoe UI" panose="020B0502040204020203" pitchFamily="34" charset="0"/>
               </a:rPr>
-              <a:t>Preuve : 09-docker/docker-api-success.png</a:t>
+              <a:t>Preuve : 06-sonarqube/sonar-final-dashboard.png</a:t>
             </a:r>
             <a:endParaRPr lang="en-US" sz="900">
               <a:solidFill>
@@ -5719,7 +6144,7 @@
     </p:spTree>
     <p:extLst>
       <p:ext uri="{BB962C8B-B14F-4D97-AF65-F5344CB8AC3E}">
-        <p14:creationId xmlns:p14="http://schemas.microsoft.com/office/powerpoint/2010/main" val="4089625075"/>
+        <p14:creationId xmlns:p14="http://schemas.microsoft.com/office/powerpoint/2010/main" val="2294904085"/>
       </p:ext>
     </p:extLst>
   </p:cSld>
@@ -5823,7 +6248,7 @@
                 </a:solidFill>
                 <a:latin typeface="Segoe UI" panose="020B0502040204020203" pitchFamily="34" charset="0"/>
               </a:rPr>
-              <a:t>Vérifier les conteneurs</a:t>
+              <a:t>Une chaîne Jenkins exécutée</a:t>
             </a:r>
             <a:endParaRPr lang="en-US" sz="2800">
               <a:solidFill>
@@ -5863,7 +6288,7 @@
                 </a:solidFill>
                 <a:latin typeface="Segoe UI" panose="020B0502040204020203" pitchFamily="34" charset="0"/>
               </a:rPr>
-              <a:t>Application et base isolées ; volumes persistants et ports liés à localhost.</a:t>
+              <a:t>Build #4 réussi : tests, gate, package, Nexus, image Docker, déploiement kind et vérification HTTP.</a:t>
             </a:r>
             <a:endParaRPr lang="en-US" sz="1600">
               <a:solidFill>
@@ -5883,7 +6308,7 @@
           <p:nvPr/>
         </p:nvPicPr>
         <p:blipFill>
-          <a:blip r:embed="rId3">
+          <a:blip r:embed="rId3" cstate="print">
             <a:extLst>
               <a:ext uri="{28A0092B-C50C-407E-A947-70E740481C1C}">
                 <a14:useLocalDpi xmlns:a14="http://schemas.microsoft.com/office/drawing/2010/main" val="0"/>
@@ -5896,8 +6321,8 @@
         </p:blipFill>
         <p:spPr>
           <a:xfrm>
-            <a:off x="1953054" y="1981200"/>
-            <a:ext cx="8285892" cy="4318000"/>
+            <a:off x="2687053" y="1981200"/>
+            <a:ext cx="6817895" cy="4318000"/>
           </a:xfrm>
           <a:prstGeom prst="rect">
             <a:avLst/>
@@ -5933,7 +6358,7 @@
                 </a:solidFill>
                 <a:latin typeface="Segoe UI" panose="020B0502040204020203" pitchFamily="34" charset="0"/>
               </a:rPr>
-              <a:t>Preuve : 09-docker/docker-containers.png</a:t>
+              <a:t>Preuve : 08-jenkins/jenkins-pipeline-overview.png</a:t>
             </a:r>
             <a:endParaRPr lang="en-US" sz="900">
               <a:solidFill>
@@ -5987,7 +6412,7 @@
     </p:spTree>
     <p:extLst>
       <p:ext uri="{BB962C8B-B14F-4D97-AF65-F5344CB8AC3E}">
-        <p14:creationId xmlns:p14="http://schemas.microsoft.com/office/powerpoint/2010/main" val="814695287"/>
+        <p14:creationId xmlns:p14="http://schemas.microsoft.com/office/powerpoint/2010/main" val="3054971862"/>
       </p:ext>
     </p:extLst>
   </p:cSld>
@@ -6091,7 +6516,7 @@
                 </a:solidFill>
                 <a:latin typeface="Segoe UI" panose="020B0502040204020203" pitchFamily="34" charset="0"/>
               </a:rPr>
-              <a:t>Un déploiement Kubernetes réel</a:t>
+              <a:t>Une couverture métier mesurée</a:t>
             </a:r>
             <a:endParaRPr lang="en-US" sz="2800">
               <a:solidFill>
@@ -6131,7 +6556,7 @@
                 </a:solidFill>
                 <a:latin typeface="Segoe UI" panose="020B0502040204020203" pitchFamily="34" charset="0"/>
               </a:rPr>
-              <a:t>Pods applicatif et MySQL prêts, Services actifs et volume persistant lié.</a:t>
+              <a:t>TacheService : 24 lignes et 4 branches couvertes ; ce résultat concerne ce service.</a:t>
             </a:r>
             <a:endParaRPr lang="en-US" sz="1600">
               <a:solidFill>
@@ -6201,7 +6626,7 @@
                 </a:solidFill>
                 <a:latin typeface="Segoe UI" panose="020B0502040204020203" pitchFamily="34" charset="0"/>
               </a:rPr>
-              <a:t>Preuve : 10-kubernetes/kubernetes-resources.png</a:t>
+              <a:t>Preuve : 04-unit-tests/coverage-service.png</a:t>
             </a:r>
             <a:endParaRPr lang="en-US" sz="900">
               <a:solidFill>
@@ -6255,7 +6680,7 @@
     </p:spTree>
     <p:extLst>
       <p:ext uri="{BB962C8B-B14F-4D97-AF65-F5344CB8AC3E}">
-        <p14:creationId xmlns:p14="http://schemas.microsoft.com/office/powerpoint/2010/main" val="287071439"/>
+        <p14:creationId xmlns:p14="http://schemas.microsoft.com/office/powerpoint/2010/main" val="3282565928"/>
       </p:ext>
     </p:extLst>
   </p:cSld>
@@ -6359,7 +6784,7 @@
                 </a:solidFill>
                 <a:latin typeface="Segoe UI" panose="020B0502040204020203" pitchFamily="34" charset="0"/>
               </a:rPr>
-              <a:t>Vérifier le service métier</a:t>
+              <a:t>Des logs utiles</a:t>
             </a:r>
             <a:endParaRPr lang="en-US" sz="2800">
               <a:solidFill>
@@ -6399,7 +6824,7 @@
                 </a:solidFill>
                 <a:latin typeface="Segoe UI" panose="020B0502040204020203" pitchFamily="34" charset="0"/>
               </a:rPr>
-              <a:t>Le cycle HTTP complet réussit via Kubernetes ; readiness inclut la base MySQL.</a:t>
+              <a:t>DEBUG, INFO, WARN sur API ; ERROR démontré par une panne simulée dans un test.</a:t>
             </a:r>
             <a:endParaRPr lang="en-US" sz="1600">
               <a:solidFill>
@@ -6469,7 +6894,7 @@
                 </a:solidFill>
                 <a:latin typeface="Segoe UI" panose="020B0502040204020203" pitchFamily="34" charset="0"/>
               </a:rPr>
-              <a:t>Preuve : 10-kubernetes/kubernetes-api-success.png</a:t>
+              <a:t>Preuve : 03-logging/tache-levels.png</a:t>
             </a:r>
             <a:endParaRPr lang="en-US" sz="900">
               <a:solidFill>
@@ -6523,7 +6948,7 @@
     </p:spTree>
     <p:extLst>
       <p:ext uri="{BB962C8B-B14F-4D97-AF65-F5344CB8AC3E}">
-        <p14:creationId xmlns:p14="http://schemas.microsoft.com/office/powerpoint/2010/main" val="2740317932"/>
+        <p14:creationId xmlns:p14="http://schemas.microsoft.com/office/powerpoint/2010/main" val="1171873359"/>
       </p:ext>
     </p:extLst>
   </p:cSld>
@@ -6621,13 +7046,13 @@
           <a:lstStyle/>
           <a:p>
             <a:r>
-              <a:rPr lang="en-US" sz="2800" smtClean="0">
+              <a:rPr lang="fr-FR" sz="2800" smtClean="0">
                 <a:solidFill>
                   <a:srgbClr val="FFFFFF"/>
                 </a:solidFill>
                 <a:latin typeface="Segoe UI" panose="020B0502040204020203" pitchFamily="34" charset="0"/>
               </a:rPr>
-              <a:t>Provisionner avec Terraform</a:t>
+              <a:t>Application et MySQL en conteneurs</a:t>
             </a:r>
             <a:endParaRPr lang="en-US" sz="2800">
               <a:solidFill>
@@ -6667,7 +7092,7 @@
                 </a:solidFill>
                 <a:latin typeface="Segoe UI" panose="020B0502040204020203" pitchFamily="34" charset="0"/>
               </a:rPr>
-              <a:t>Plan examiné et approuvé : 6 ressources Prometheus créées, aucune destruction.</a:t>
+              <a:t>Cycle HTTP vérifié dans Docker ; readiness UP et utilisateur applicatif non privilégié.</a:t>
             </a:r>
             <a:endParaRPr lang="en-US" sz="1600">
               <a:solidFill>
@@ -6737,7 +7162,7 @@
                 </a:solidFill>
                 <a:latin typeface="Segoe UI" panose="020B0502040204020203" pitchFamily="34" charset="0"/>
               </a:rPr>
-              <a:t>Preuve : 11-terraform/terraform-apply.png</a:t>
+              <a:t>Preuve : 09-docker/docker-api-success.png</a:t>
             </a:r>
             <a:endParaRPr lang="en-US" sz="900">
               <a:solidFill>
@@ -6791,7 +7216,7 @@
     </p:spTree>
     <p:extLst>
       <p:ext uri="{BB962C8B-B14F-4D97-AF65-F5344CB8AC3E}">
-        <p14:creationId xmlns:p14="http://schemas.microsoft.com/office/powerpoint/2010/main" val="521254787"/>
+        <p14:creationId xmlns:p14="http://schemas.microsoft.com/office/powerpoint/2010/main" val="286608906"/>
       </p:ext>
     </p:extLst>
   </p:cSld>
@@ -6895,7 +7320,7 @@
                 </a:solidFill>
                 <a:latin typeface="Segoe UI" panose="020B0502040204020203" pitchFamily="34" charset="0"/>
               </a:rPr>
-              <a:t>Contrôler la convergence</a:t>
+              <a:t>Vérifier les conteneurs</a:t>
             </a:r>
             <a:endParaRPr lang="en-US" sz="2800">
               <a:solidFill>
@@ -6935,7 +7360,7 @@
                 </a:solidFill>
                 <a:latin typeface="Segoe UI" panose="020B0502040204020203" pitchFamily="34" charset="0"/>
               </a:rPr>
-              <a:t>Un nouveau plan ne détecte aucune différence entre configuration et infrastructure.</a:t>
+              <a:t>Application et base isolées ; volumes persistants et ports liés à localhost.</a:t>
             </a:r>
             <a:endParaRPr lang="en-US" sz="1600">
               <a:solidFill>
@@ -7005,7 +7430,7 @@
                 </a:solidFill>
                 <a:latin typeface="Segoe UI" panose="020B0502040204020203" pitchFamily="34" charset="0"/>
               </a:rPr>
-              <a:t>Preuve : 11-terraform/terraform-no-drift.png</a:t>
+              <a:t>Preuve : 09-docker/docker-containers.png</a:t>
             </a:r>
             <a:endParaRPr lang="en-US" sz="900">
               <a:solidFill>
@@ -7059,7 +7484,7 @@
     </p:spTree>
     <p:extLst>
       <p:ext uri="{BB962C8B-B14F-4D97-AF65-F5344CB8AC3E}">
-        <p14:creationId xmlns:p14="http://schemas.microsoft.com/office/powerpoint/2010/main" val="501690031"/>
+        <p14:creationId xmlns:p14="http://schemas.microsoft.com/office/powerpoint/2010/main" val="3571019790"/>
       </p:ext>
     </p:extLst>
   </p:cSld>
@@ -7157,13 +7582,13 @@
           <a:lstStyle/>
           <a:p>
             <a:r>
-              <a:rPr lang="fr-FR" sz="2800" smtClean="0">
+              <a:rPr lang="en-US" sz="2800" smtClean="0">
                 <a:solidFill>
                   <a:srgbClr val="FFFFFF"/>
                 </a:solidFill>
                 <a:latin typeface="Segoe UI" panose="020B0502040204020203" pitchFamily="34" charset="0"/>
               </a:rPr>
-              <a:t>Observer une application réellement collectée</a:t>
+              <a:t>Un déploiement Kubernetes réel</a:t>
             </a:r>
             <a:endParaRPr lang="en-US" sz="2800">
               <a:solidFill>
@@ -7203,7 +7628,7 @@
                 </a:solidFill>
                 <a:latin typeface="Segoe UI" panose="020B0502040204020203" pitchFamily="34" charset="0"/>
               </a:rPr>
-              <a:t>Prometheus collecte la cible Kubernetes events : 1/1 UP, métriques exposées par Actuator.</a:t>
+              <a:t>Pods applicatif et MySQL prêts, Services actifs et volume persistant lié.</a:t>
             </a:r>
             <a:endParaRPr lang="en-US" sz="1600">
               <a:solidFill>
@@ -7236,8 +7661,8 @@
         </p:blipFill>
         <p:spPr>
           <a:xfrm>
-            <a:off x="381000" y="1981199"/>
-            <a:ext cx="11430000" cy="3175000"/>
+            <a:off x="1953054" y="1981200"/>
+            <a:ext cx="8285892" cy="4318000"/>
           </a:xfrm>
           <a:prstGeom prst="rect">
             <a:avLst/>
@@ -7273,7 +7698,7 @@
                 </a:solidFill>
                 <a:latin typeface="Segoe UI" panose="020B0502040204020203" pitchFamily="34" charset="0"/>
               </a:rPr>
-              <a:t>Preuve : 13-monitoring/prometheus-targets.png</a:t>
+              <a:t>Preuve : 10-kubernetes/kubernetes-resources.png</a:t>
             </a:r>
             <a:endParaRPr lang="en-US" sz="900">
               <a:solidFill>
@@ -7327,7 +7752,7 @@
     </p:spTree>
     <p:extLst>
       <p:ext uri="{BB962C8B-B14F-4D97-AF65-F5344CB8AC3E}">
-        <p14:creationId xmlns:p14="http://schemas.microsoft.com/office/powerpoint/2010/main" val="811975643"/>
+        <p14:creationId xmlns:p14="http://schemas.microsoft.com/office/powerpoint/2010/main" val="437395934"/>
       </p:ext>
     </p:extLst>
   </p:cSld>
@@ -7425,13 +7850,13 @@
           <a:lstStyle/>
           <a:p>
             <a:r>
-              <a:rPr lang="fr-FR" sz="2800" smtClean="0">
+              <a:rPr lang="en-US" sz="2800" smtClean="0">
                 <a:solidFill>
                   <a:srgbClr val="FFFFFF"/>
                 </a:solidFill>
                 <a:latin typeface="Segoe UI" panose="020B0502040204020203" pitchFamily="34" charset="0"/>
               </a:rPr>
-              <a:t>Publier le livrable dans Nexus</a:t>
+              <a:t>Vérifier le service métier</a:t>
             </a:r>
             <a:endParaRPr lang="en-US" sz="2800">
               <a:solidFill>
@@ -7471,7 +7896,7 @@
                 </a:solidFill>
                 <a:latin typeface="Segoe UI" panose="020B0502040204020203" pitchFamily="34" charset="0"/>
               </a:rPr>
-              <a:t>Le dépôt Maven snapshots contient le JAR et le POM de tn.esprit:eventsProject:1.0.0-SNAPSHOT.</a:t>
+              <a:t>Le cycle HTTP complet réussit via Kubernetes ; readiness inclut la base MySQL.</a:t>
             </a:r>
             <a:endParaRPr lang="en-US" sz="1600">
               <a:solidFill>
@@ -7504,8 +7929,8 @@
         </p:blipFill>
         <p:spPr>
           <a:xfrm>
-            <a:off x="1312985" y="1981200"/>
-            <a:ext cx="9566031" cy="4318000"/>
+            <a:off x="1953054" y="1981200"/>
+            <a:ext cx="8285892" cy="4318000"/>
           </a:xfrm>
           <a:prstGeom prst="rect">
             <a:avLst/>
@@ -7541,7 +7966,7 @@
                 </a:solidFill>
                 <a:latin typeface="Segoe UI" panose="020B0502040204020203" pitchFamily="34" charset="0"/>
               </a:rPr>
-              <a:t>Preuve : 07-nexus/nexus-repository.png</a:t>
+              <a:t>Preuve : 10-kubernetes/kubernetes-api-success.png</a:t>
             </a:r>
             <a:endParaRPr lang="en-US" sz="900">
               <a:solidFill>
@@ -7595,7 +8020,7 @@
     </p:spTree>
     <p:extLst>
       <p:ext uri="{BB962C8B-B14F-4D97-AF65-F5344CB8AC3E}">
-        <p14:creationId xmlns:p14="http://schemas.microsoft.com/office/powerpoint/2010/main" val="1160173181"/>
+        <p14:creationId xmlns:p14="http://schemas.microsoft.com/office/powerpoint/2010/main" val="3582428800"/>
       </p:ext>
     </p:extLst>
   </p:cSld>
@@ -7699,7 +8124,7 @@
                 </a:solidFill>
                 <a:latin typeface="Segoe UI" panose="020B0502040204020203" pitchFamily="34" charset="0"/>
               </a:rPr>
-              <a:t>Vérifier le livrable publié</a:t>
+              <a:t>Provisionner avec Terraform</a:t>
             </a:r>
             <a:endParaRPr lang="en-US" sz="2800">
               <a:solidFill>
@@ -7739,7 +8164,7 @@
                 </a:solidFill>
                 <a:latin typeface="Segoe UI" panose="020B0502040204020203" pitchFamily="34" charset="0"/>
               </a:rPr>
-              <a:t>Le JAR téléchargé depuis Nexus possède le même SHA-256 que le livrable local.</a:t>
+              <a:t>Plan examiné et approuvé : 6 ressources Prometheus créées, aucune destruction.</a:t>
             </a:r>
             <a:endParaRPr lang="en-US" sz="1600">
               <a:solidFill>
@@ -7809,7 +8234,7 @@
                 </a:solidFill>
                 <a:latin typeface="Segoe UI" panose="020B0502040204020203" pitchFamily="34" charset="0"/>
               </a:rPr>
-              <a:t>Preuve : 07-nexus/nexus-verification.png</a:t>
+              <a:t>Preuve : 11-terraform/terraform-apply.png</a:t>
             </a:r>
             <a:endParaRPr lang="en-US" sz="900">
               <a:solidFill>
@@ -7863,7 +8288,7 @@
     </p:spTree>
     <p:extLst>
       <p:ext uri="{BB962C8B-B14F-4D97-AF65-F5344CB8AC3E}">
-        <p14:creationId xmlns:p14="http://schemas.microsoft.com/office/powerpoint/2010/main" val="2284738698"/>
+        <p14:creationId xmlns:p14="http://schemas.microsoft.com/office/powerpoint/2010/main" val="2784599714"/>
       </p:ext>
     </p:extLst>
   </p:cSld>
@@ -8131,7 +8556,1347 @@
     </p:spTree>
     <p:extLst>
       <p:ext uri="{BB962C8B-B14F-4D97-AF65-F5344CB8AC3E}">
-        <p14:creationId xmlns:p14="http://schemas.microsoft.com/office/powerpoint/2010/main" val="3850592713"/>
+        <p14:creationId xmlns:p14="http://schemas.microsoft.com/office/powerpoint/2010/main" val="3835462484"/>
+      </p:ext>
+    </p:extLst>
+  </p:cSld>
+  <p:clrMapOvr>
+    <a:masterClrMapping/>
+  </p:clrMapOvr>
+</p:sld>
+</file>
+
+<file path=ppt/slides/slide20.xml><?xml version="1.0" encoding="utf-8"?>
+<p:sld xmlns:a="http://schemas.openxmlformats.org/drawingml/2006/main" xmlns:r="http://schemas.openxmlformats.org/officeDocument/2006/relationships" xmlns:p="http://schemas.openxmlformats.org/presentationml/2006/main">
+  <p:cSld>
+    <p:bg>
+      <p:bgPr>
+        <a:solidFill>
+          <a:srgbClr val="0F272A"/>
+        </a:solidFill>
+        <a:effectLst/>
+      </p:bgPr>
+    </p:bg>
+    <p:spTree>
+      <p:nvGrpSpPr>
+        <p:cNvPr id="1" name=""/>
+        <p:cNvGrpSpPr/>
+        <p:nvPr/>
+      </p:nvGrpSpPr>
+      <p:grpSpPr>
+        <a:xfrm>
+          <a:off x="0" y="0"/>
+          <a:ext cx="0" cy="0"/>
+          <a:chOff x="0" y="0"/>
+          <a:chExt cx="0" cy="0"/>
+        </a:xfrm>
+      </p:grpSpPr>
+      <p:sp>
+        <p:nvSpPr>
+          <p:cNvPr id="2" name="TextBox 1"/>
+          <p:cNvSpPr txBox="1"/>
+          <p:nvPr/>
+        </p:nvSpPr>
+        <p:spPr>
+          <a:xfrm>
+            <a:off x="381000" y="152400"/>
+            <a:ext cx="10795000" cy="261610"/>
+          </a:xfrm>
+          <a:prstGeom prst="rect">
+            <a:avLst/>
+          </a:prstGeom>
+          <a:noFill/>
+        </p:spPr>
+        <p:txBody>
+          <a:bodyPr vert="horz" rtlCol="0">
+            <a:spAutoFit/>
+          </a:bodyPr>
+          <a:lstStyle/>
+          <a:p>
+            <a:r>
+              <a:rPr lang="en-US" sz="1100" smtClean="0">
+                <a:solidFill>
+                  <a:srgbClr val="5EEAD4"/>
+                </a:solidFill>
+                <a:latin typeface="Segoe UI" panose="020B0502040204020203" pitchFamily="34" charset="0"/>
+              </a:rPr>
+              <a:t>EVENTSPROJECT / MODULE TACHE</a:t>
+            </a:r>
+            <a:endParaRPr lang="en-US" sz="1100">
+              <a:solidFill>
+                <a:srgbClr val="5EEAD4"/>
+              </a:solidFill>
+              <a:latin typeface="Segoe UI" panose="020B0502040204020203" pitchFamily="34" charset="0"/>
+            </a:endParaRPr>
+          </a:p>
+        </p:txBody>
+      </p:sp>
+      <p:sp>
+        <p:nvSpPr>
+          <p:cNvPr id="3" name="TextBox 2"/>
+          <p:cNvSpPr txBox="1"/>
+          <p:nvPr/>
+        </p:nvSpPr>
+        <p:spPr>
+          <a:xfrm>
+            <a:off x="381000" y="533400"/>
+            <a:ext cx="11430000" cy="523220"/>
+          </a:xfrm>
+          <a:prstGeom prst="rect">
+            <a:avLst/>
+          </a:prstGeom>
+          <a:noFill/>
+        </p:spPr>
+        <p:txBody>
+          <a:bodyPr vert="horz" rtlCol="0">
+            <a:spAutoFit/>
+          </a:bodyPr>
+          <a:lstStyle/>
+          <a:p>
+            <a:r>
+              <a:rPr lang="en-US" sz="2800" smtClean="0">
+                <a:solidFill>
+                  <a:srgbClr val="FFFFFF"/>
+                </a:solidFill>
+                <a:latin typeface="Segoe UI" panose="020B0502040204020203" pitchFamily="34" charset="0"/>
+              </a:rPr>
+              <a:t>Contrôler la convergence</a:t>
+            </a:r>
+            <a:endParaRPr lang="en-US" sz="2800">
+              <a:solidFill>
+                <a:srgbClr val="FFFFFF"/>
+              </a:solidFill>
+              <a:latin typeface="Segoe UI" panose="020B0502040204020203" pitchFamily="34" charset="0"/>
+            </a:endParaRPr>
+          </a:p>
+        </p:txBody>
+      </p:sp>
+      <p:sp>
+        <p:nvSpPr>
+          <p:cNvPr id="4" name="TextBox 3"/>
+          <p:cNvSpPr txBox="1"/>
+          <p:nvPr/>
+        </p:nvSpPr>
+        <p:spPr>
+          <a:xfrm>
+            <a:off x="381000" y="1244600"/>
+            <a:ext cx="11430000" cy="338554"/>
+          </a:xfrm>
+          <a:prstGeom prst="rect">
+            <a:avLst/>
+          </a:prstGeom>
+          <a:noFill/>
+        </p:spPr>
+        <p:txBody>
+          <a:bodyPr vert="horz" rtlCol="0">
+            <a:spAutoFit/>
+          </a:bodyPr>
+          <a:lstStyle/>
+          <a:p>
+            <a:r>
+              <a:rPr lang="fr-FR" sz="1600" smtClean="0">
+                <a:solidFill>
+                  <a:srgbClr val="E1E1E1"/>
+                </a:solidFill>
+                <a:latin typeface="Segoe UI" panose="020B0502040204020203" pitchFamily="34" charset="0"/>
+              </a:rPr>
+              <a:t>Un nouveau plan ne détecte aucune différence entre configuration et infrastructure.</a:t>
+            </a:r>
+            <a:endParaRPr lang="en-US" sz="1600">
+              <a:solidFill>
+                <a:srgbClr val="E1E1E1"/>
+              </a:solidFill>
+              <a:latin typeface="Segoe UI" panose="020B0502040204020203" pitchFamily="34" charset="0"/>
+            </a:endParaRPr>
+          </a:p>
+        </p:txBody>
+      </p:sp>
+      <p:pic>
+        <p:nvPicPr>
+          <p:cNvPr id="5" name="Picture 4"/>
+          <p:cNvPicPr>
+            <a:picLocks noChangeAspect="1"/>
+          </p:cNvPicPr>
+          <p:nvPr/>
+        </p:nvPicPr>
+        <p:blipFill>
+          <a:blip r:embed="rId3">
+            <a:extLst>
+              <a:ext uri="{28A0092B-C50C-407E-A947-70E740481C1C}">
+                <a14:useLocalDpi xmlns:a14="http://schemas.microsoft.com/office/drawing/2010/main" val="0"/>
+              </a:ext>
+            </a:extLst>
+          </a:blip>
+          <a:stretch>
+            <a:fillRect/>
+          </a:stretch>
+        </p:blipFill>
+        <p:spPr>
+          <a:xfrm>
+            <a:off x="1953054" y="1981200"/>
+            <a:ext cx="8285892" cy="4318000"/>
+          </a:xfrm>
+          <a:prstGeom prst="rect">
+            <a:avLst/>
+          </a:prstGeom>
+        </p:spPr>
+      </p:pic>
+      <p:sp>
+        <p:nvSpPr>
+          <p:cNvPr id="6" name="TextBox 5"/>
+          <p:cNvSpPr txBox="1"/>
+          <p:nvPr/>
+        </p:nvSpPr>
+        <p:spPr>
+          <a:xfrm>
+            <a:off x="381000" y="6400800"/>
+            <a:ext cx="10795000" cy="230832"/>
+          </a:xfrm>
+          <a:prstGeom prst="rect">
+            <a:avLst/>
+          </a:prstGeom>
+          <a:noFill/>
+        </p:spPr>
+        <p:txBody>
+          <a:bodyPr vert="horz" rtlCol="0">
+            <a:spAutoFit/>
+          </a:bodyPr>
+          <a:lstStyle/>
+          <a:p>
+            <a:r>
+              <a:rPr lang="en-US" sz="900" smtClean="0">
+                <a:solidFill>
+                  <a:srgbClr val="5EEAD4"/>
+                </a:solidFill>
+                <a:latin typeface="Segoe UI" panose="020B0502040204020203" pitchFamily="34" charset="0"/>
+              </a:rPr>
+              <a:t>Preuve : 11-terraform/terraform-no-drift.png</a:t>
+            </a:r>
+            <a:endParaRPr lang="en-US" sz="900">
+              <a:solidFill>
+                <a:srgbClr val="5EEAD4"/>
+              </a:solidFill>
+              <a:latin typeface="Segoe UI" panose="020B0502040204020203" pitchFamily="34" charset="0"/>
+            </a:endParaRPr>
+          </a:p>
+        </p:txBody>
+      </p:sp>
+      <p:sp>
+        <p:nvSpPr>
+          <p:cNvPr id="7" name="TextBox 6"/>
+          <p:cNvSpPr txBox="1"/>
+          <p:nvPr/>
+        </p:nvSpPr>
+        <p:spPr>
+          <a:xfrm>
+            <a:off x="11582400" y="6438900"/>
+            <a:ext cx="381000" cy="246221"/>
+          </a:xfrm>
+          <a:prstGeom prst="rect">
+            <a:avLst/>
+          </a:prstGeom>
+          <a:noFill/>
+        </p:spPr>
+        <p:txBody>
+          <a:bodyPr vert="horz" rtlCol="0">
+            <a:spAutoFit/>
+          </a:bodyPr>
+          <a:lstStyle/>
+          <a:p>
+            <a:r>
+              <a:rPr lang="en-US" sz="1000" smtClean="0">
+                <a:solidFill>
+                  <a:srgbClr val="E1E1E1"/>
+                </a:solidFill>
+                <a:latin typeface="Segoe UI" panose="020B0502040204020203" pitchFamily="34" charset="0"/>
+              </a:rPr>
+              <a:t>20</a:t>
+            </a:r>
+            <a:endParaRPr lang="en-US" sz="1000">
+              <a:solidFill>
+                <a:srgbClr val="E1E1E1"/>
+              </a:solidFill>
+              <a:latin typeface="Segoe UI" panose="020B0502040204020203" pitchFamily="34" charset="0"/>
+            </a:endParaRPr>
+          </a:p>
+        </p:txBody>
+      </p:sp>
+    </p:spTree>
+    <p:extLst>
+      <p:ext uri="{BB962C8B-B14F-4D97-AF65-F5344CB8AC3E}">
+        <p14:creationId xmlns:p14="http://schemas.microsoft.com/office/powerpoint/2010/main" val="3530141923"/>
+      </p:ext>
+    </p:extLst>
+  </p:cSld>
+  <p:clrMapOvr>
+    <a:masterClrMapping/>
+  </p:clrMapOvr>
+</p:sld>
+</file>
+
+<file path=ppt/slides/slide21.xml><?xml version="1.0" encoding="utf-8"?>
+<p:sld xmlns:a="http://schemas.openxmlformats.org/drawingml/2006/main" xmlns:r="http://schemas.openxmlformats.org/officeDocument/2006/relationships" xmlns:p="http://schemas.openxmlformats.org/presentationml/2006/main">
+  <p:cSld>
+    <p:bg>
+      <p:bgPr>
+        <a:solidFill>
+          <a:srgbClr val="0F272A"/>
+        </a:solidFill>
+        <a:effectLst/>
+      </p:bgPr>
+    </p:bg>
+    <p:spTree>
+      <p:nvGrpSpPr>
+        <p:cNvPr id="1" name=""/>
+        <p:cNvGrpSpPr/>
+        <p:nvPr/>
+      </p:nvGrpSpPr>
+      <p:grpSpPr>
+        <a:xfrm>
+          <a:off x="0" y="0"/>
+          <a:ext cx="0" cy="0"/>
+          <a:chOff x="0" y="0"/>
+          <a:chExt cx="0" cy="0"/>
+        </a:xfrm>
+      </p:grpSpPr>
+      <p:sp>
+        <p:nvSpPr>
+          <p:cNvPr id="2" name="TextBox 1"/>
+          <p:cNvSpPr txBox="1"/>
+          <p:nvPr/>
+        </p:nvSpPr>
+        <p:spPr>
+          <a:xfrm>
+            <a:off x="381000" y="152400"/>
+            <a:ext cx="10795000" cy="261610"/>
+          </a:xfrm>
+          <a:prstGeom prst="rect">
+            <a:avLst/>
+          </a:prstGeom>
+          <a:noFill/>
+        </p:spPr>
+        <p:txBody>
+          <a:bodyPr vert="horz" rtlCol="0">
+            <a:spAutoFit/>
+          </a:bodyPr>
+          <a:lstStyle/>
+          <a:p>
+            <a:r>
+              <a:rPr lang="en-US" sz="1100" smtClean="0">
+                <a:solidFill>
+                  <a:srgbClr val="5EEAD4"/>
+                </a:solidFill>
+                <a:latin typeface="Segoe UI" panose="020B0502040204020203" pitchFamily="34" charset="0"/>
+              </a:rPr>
+              <a:t>EVENTSPROJECT / MODULE TACHE</a:t>
+            </a:r>
+            <a:endParaRPr lang="en-US" sz="1100">
+              <a:solidFill>
+                <a:srgbClr val="5EEAD4"/>
+              </a:solidFill>
+              <a:latin typeface="Segoe UI" panose="020B0502040204020203" pitchFamily="34" charset="0"/>
+            </a:endParaRPr>
+          </a:p>
+        </p:txBody>
+      </p:sp>
+      <p:sp>
+        <p:nvSpPr>
+          <p:cNvPr id="3" name="TextBox 2"/>
+          <p:cNvSpPr txBox="1"/>
+          <p:nvPr/>
+        </p:nvSpPr>
+        <p:spPr>
+          <a:xfrm>
+            <a:off x="381000" y="533400"/>
+            <a:ext cx="11430000" cy="523220"/>
+          </a:xfrm>
+          <a:prstGeom prst="rect">
+            <a:avLst/>
+          </a:prstGeom>
+          <a:noFill/>
+        </p:spPr>
+        <p:txBody>
+          <a:bodyPr vert="horz" rtlCol="0">
+            <a:spAutoFit/>
+          </a:bodyPr>
+          <a:lstStyle/>
+          <a:p>
+            <a:r>
+              <a:rPr lang="fr-FR" sz="2800" smtClean="0">
+                <a:solidFill>
+                  <a:srgbClr val="FFFFFF"/>
+                </a:solidFill>
+                <a:latin typeface="Segoe UI" panose="020B0502040204020203" pitchFamily="34" charset="0"/>
+              </a:rPr>
+              <a:t>Observer une application réellement collectée</a:t>
+            </a:r>
+            <a:endParaRPr lang="en-US" sz="2800">
+              <a:solidFill>
+                <a:srgbClr val="FFFFFF"/>
+              </a:solidFill>
+              <a:latin typeface="Segoe UI" panose="020B0502040204020203" pitchFamily="34" charset="0"/>
+            </a:endParaRPr>
+          </a:p>
+        </p:txBody>
+      </p:sp>
+      <p:sp>
+        <p:nvSpPr>
+          <p:cNvPr id="4" name="TextBox 3"/>
+          <p:cNvSpPr txBox="1"/>
+          <p:nvPr/>
+        </p:nvSpPr>
+        <p:spPr>
+          <a:xfrm>
+            <a:off x="381000" y="1244600"/>
+            <a:ext cx="11430000" cy="338554"/>
+          </a:xfrm>
+          <a:prstGeom prst="rect">
+            <a:avLst/>
+          </a:prstGeom>
+          <a:noFill/>
+        </p:spPr>
+        <p:txBody>
+          <a:bodyPr vert="horz" rtlCol="0">
+            <a:spAutoFit/>
+          </a:bodyPr>
+          <a:lstStyle/>
+          <a:p>
+            <a:r>
+              <a:rPr lang="fr-FR" sz="1600" smtClean="0">
+                <a:solidFill>
+                  <a:srgbClr val="E1E1E1"/>
+                </a:solidFill>
+                <a:latin typeface="Segoe UI" panose="020B0502040204020203" pitchFamily="34" charset="0"/>
+              </a:rPr>
+              <a:t>Prometheus collecte la cible Kubernetes events : 1/1 UP, métriques exposées par Actuator.</a:t>
+            </a:r>
+            <a:endParaRPr lang="en-US" sz="1600">
+              <a:solidFill>
+                <a:srgbClr val="E1E1E1"/>
+              </a:solidFill>
+              <a:latin typeface="Segoe UI" panose="020B0502040204020203" pitchFamily="34" charset="0"/>
+            </a:endParaRPr>
+          </a:p>
+        </p:txBody>
+      </p:sp>
+      <p:pic>
+        <p:nvPicPr>
+          <p:cNvPr id="5" name="Picture 4"/>
+          <p:cNvPicPr>
+            <a:picLocks noChangeAspect="1"/>
+          </p:cNvPicPr>
+          <p:nvPr/>
+        </p:nvPicPr>
+        <p:blipFill>
+          <a:blip r:embed="rId3">
+            <a:extLst>
+              <a:ext uri="{28A0092B-C50C-407E-A947-70E740481C1C}">
+                <a14:useLocalDpi xmlns:a14="http://schemas.microsoft.com/office/drawing/2010/main" val="0"/>
+              </a:ext>
+            </a:extLst>
+          </a:blip>
+          <a:stretch>
+            <a:fillRect/>
+          </a:stretch>
+        </p:blipFill>
+        <p:spPr>
+          <a:xfrm>
+            <a:off x="381000" y="1981199"/>
+            <a:ext cx="11430000" cy="3175000"/>
+          </a:xfrm>
+          <a:prstGeom prst="rect">
+            <a:avLst/>
+          </a:prstGeom>
+        </p:spPr>
+      </p:pic>
+      <p:sp>
+        <p:nvSpPr>
+          <p:cNvPr id="6" name="TextBox 5"/>
+          <p:cNvSpPr txBox="1"/>
+          <p:nvPr/>
+        </p:nvSpPr>
+        <p:spPr>
+          <a:xfrm>
+            <a:off x="381000" y="6400800"/>
+            <a:ext cx="10795000" cy="230832"/>
+          </a:xfrm>
+          <a:prstGeom prst="rect">
+            <a:avLst/>
+          </a:prstGeom>
+          <a:noFill/>
+        </p:spPr>
+        <p:txBody>
+          <a:bodyPr vert="horz" rtlCol="0">
+            <a:spAutoFit/>
+          </a:bodyPr>
+          <a:lstStyle/>
+          <a:p>
+            <a:r>
+              <a:rPr lang="en-US" sz="900" smtClean="0">
+                <a:solidFill>
+                  <a:srgbClr val="5EEAD4"/>
+                </a:solidFill>
+                <a:latin typeface="Segoe UI" panose="020B0502040204020203" pitchFamily="34" charset="0"/>
+              </a:rPr>
+              <a:t>Preuve : 13-monitoring/prometheus-targets.png</a:t>
+            </a:r>
+            <a:endParaRPr lang="en-US" sz="900">
+              <a:solidFill>
+                <a:srgbClr val="5EEAD4"/>
+              </a:solidFill>
+              <a:latin typeface="Segoe UI" panose="020B0502040204020203" pitchFamily="34" charset="0"/>
+            </a:endParaRPr>
+          </a:p>
+        </p:txBody>
+      </p:sp>
+      <p:sp>
+        <p:nvSpPr>
+          <p:cNvPr id="7" name="TextBox 6"/>
+          <p:cNvSpPr txBox="1"/>
+          <p:nvPr/>
+        </p:nvSpPr>
+        <p:spPr>
+          <a:xfrm>
+            <a:off x="11582400" y="6438900"/>
+            <a:ext cx="381000" cy="246221"/>
+          </a:xfrm>
+          <a:prstGeom prst="rect">
+            <a:avLst/>
+          </a:prstGeom>
+          <a:noFill/>
+        </p:spPr>
+        <p:txBody>
+          <a:bodyPr vert="horz" rtlCol="0">
+            <a:spAutoFit/>
+          </a:bodyPr>
+          <a:lstStyle/>
+          <a:p>
+            <a:r>
+              <a:rPr lang="en-US" sz="1000" smtClean="0">
+                <a:solidFill>
+                  <a:srgbClr val="E1E1E1"/>
+                </a:solidFill>
+                <a:latin typeface="Segoe UI" panose="020B0502040204020203" pitchFamily="34" charset="0"/>
+              </a:rPr>
+              <a:t>21</a:t>
+            </a:r>
+            <a:endParaRPr lang="en-US" sz="1000">
+              <a:solidFill>
+                <a:srgbClr val="E1E1E1"/>
+              </a:solidFill>
+              <a:latin typeface="Segoe UI" panose="020B0502040204020203" pitchFamily="34" charset="0"/>
+            </a:endParaRPr>
+          </a:p>
+        </p:txBody>
+      </p:sp>
+    </p:spTree>
+    <p:extLst>
+      <p:ext uri="{BB962C8B-B14F-4D97-AF65-F5344CB8AC3E}">
+        <p14:creationId xmlns:p14="http://schemas.microsoft.com/office/powerpoint/2010/main" val="271366284"/>
+      </p:ext>
+    </p:extLst>
+  </p:cSld>
+  <p:clrMapOvr>
+    <a:masterClrMapping/>
+  </p:clrMapOvr>
+</p:sld>
+</file>
+
+<file path=ppt/slides/slide22.xml><?xml version="1.0" encoding="utf-8"?>
+<p:sld xmlns:a="http://schemas.openxmlformats.org/drawingml/2006/main" xmlns:r="http://schemas.openxmlformats.org/officeDocument/2006/relationships" xmlns:p="http://schemas.openxmlformats.org/presentationml/2006/main">
+  <p:cSld>
+    <p:bg>
+      <p:bgPr>
+        <a:solidFill>
+          <a:srgbClr val="0F272A"/>
+        </a:solidFill>
+        <a:effectLst/>
+      </p:bgPr>
+    </p:bg>
+    <p:spTree>
+      <p:nvGrpSpPr>
+        <p:cNvPr id="1" name=""/>
+        <p:cNvGrpSpPr/>
+        <p:nvPr/>
+      </p:nvGrpSpPr>
+      <p:grpSpPr>
+        <a:xfrm>
+          <a:off x="0" y="0"/>
+          <a:ext cx="0" cy="0"/>
+          <a:chOff x="0" y="0"/>
+          <a:chExt cx="0" cy="0"/>
+        </a:xfrm>
+      </p:grpSpPr>
+      <p:sp>
+        <p:nvSpPr>
+          <p:cNvPr id="2" name="TextBox 1"/>
+          <p:cNvSpPr txBox="1"/>
+          <p:nvPr/>
+        </p:nvSpPr>
+        <p:spPr>
+          <a:xfrm>
+            <a:off x="381000" y="152400"/>
+            <a:ext cx="10795000" cy="261610"/>
+          </a:xfrm>
+          <a:prstGeom prst="rect">
+            <a:avLst/>
+          </a:prstGeom>
+          <a:noFill/>
+        </p:spPr>
+        <p:txBody>
+          <a:bodyPr vert="horz" rtlCol="0">
+            <a:spAutoFit/>
+          </a:bodyPr>
+          <a:lstStyle/>
+          <a:p>
+            <a:r>
+              <a:rPr lang="en-US" sz="1100" smtClean="0">
+                <a:solidFill>
+                  <a:srgbClr val="5EEAD4"/>
+                </a:solidFill>
+                <a:latin typeface="Segoe UI" panose="020B0502040204020203" pitchFamily="34" charset="0"/>
+              </a:rPr>
+              <a:t>EVENTSPROJECT / MODULE TACHE</a:t>
+            </a:r>
+            <a:endParaRPr lang="en-US" sz="1100">
+              <a:solidFill>
+                <a:srgbClr val="5EEAD4"/>
+              </a:solidFill>
+              <a:latin typeface="Segoe UI" panose="020B0502040204020203" pitchFamily="34" charset="0"/>
+            </a:endParaRPr>
+          </a:p>
+        </p:txBody>
+      </p:sp>
+      <p:sp>
+        <p:nvSpPr>
+          <p:cNvPr id="3" name="TextBox 2"/>
+          <p:cNvSpPr txBox="1"/>
+          <p:nvPr/>
+        </p:nvSpPr>
+        <p:spPr>
+          <a:xfrm>
+            <a:off x="381000" y="533400"/>
+            <a:ext cx="11430000" cy="523220"/>
+          </a:xfrm>
+          <a:prstGeom prst="rect">
+            <a:avLst/>
+          </a:prstGeom>
+          <a:noFill/>
+        </p:spPr>
+        <p:txBody>
+          <a:bodyPr vert="horz" rtlCol="0">
+            <a:spAutoFit/>
+          </a:bodyPr>
+          <a:lstStyle/>
+          <a:p>
+            <a:r>
+              <a:rPr lang="fr-FR" sz="2800" smtClean="0">
+                <a:solidFill>
+                  <a:srgbClr val="FFFFFF"/>
+                </a:solidFill>
+                <a:latin typeface="Segoe UI" panose="020B0502040204020203" pitchFamily="34" charset="0"/>
+              </a:rPr>
+              <a:t>Visualiser les métriques dans Grafana</a:t>
+            </a:r>
+            <a:endParaRPr lang="en-US" sz="2800">
+              <a:solidFill>
+                <a:srgbClr val="FFFFFF"/>
+              </a:solidFill>
+              <a:latin typeface="Segoe UI" panose="020B0502040204020203" pitchFamily="34" charset="0"/>
+            </a:endParaRPr>
+          </a:p>
+        </p:txBody>
+      </p:sp>
+      <p:sp>
+        <p:nvSpPr>
+          <p:cNvPr id="4" name="TextBox 3"/>
+          <p:cNvSpPr txBox="1"/>
+          <p:nvPr/>
+        </p:nvSpPr>
+        <p:spPr>
+          <a:xfrm>
+            <a:off x="381000" y="1244600"/>
+            <a:ext cx="11430000" cy="338554"/>
+          </a:xfrm>
+          <a:prstGeom prst="rect">
+            <a:avLst/>
+          </a:prstGeom>
+          <a:noFill/>
+        </p:spPr>
+        <p:txBody>
+          <a:bodyPr vert="horz" rtlCol="0">
+            <a:spAutoFit/>
+          </a:bodyPr>
+          <a:lstStyle/>
+          <a:p>
+            <a:r>
+              <a:rPr lang="fr-FR" sz="1600" smtClean="0">
+                <a:solidFill>
+                  <a:srgbClr val="E1E1E1"/>
+                </a:solidFill>
+                <a:latin typeface="Segoe UI" panose="020B0502040204020203" pitchFamily="34" charset="0"/>
+              </a:rPr>
+              <a:t>Dashboard provisionné : cible UP, CPU Java, mémoire JVM et débit HTTP ; quatre requêtes réelles vérifiées.</a:t>
+            </a:r>
+            <a:endParaRPr lang="en-US" sz="1600">
+              <a:solidFill>
+                <a:srgbClr val="E1E1E1"/>
+              </a:solidFill>
+              <a:latin typeface="Segoe UI" panose="020B0502040204020203" pitchFamily="34" charset="0"/>
+            </a:endParaRPr>
+          </a:p>
+        </p:txBody>
+      </p:sp>
+      <p:pic>
+        <p:nvPicPr>
+          <p:cNvPr id="5" name="Picture 4"/>
+          <p:cNvPicPr>
+            <a:picLocks noChangeAspect="1"/>
+          </p:cNvPicPr>
+          <p:nvPr/>
+        </p:nvPicPr>
+        <p:blipFill>
+          <a:blip r:embed="rId3">
+            <a:extLst>
+              <a:ext uri="{28A0092B-C50C-407E-A947-70E740481C1C}">
+                <a14:useLocalDpi xmlns:a14="http://schemas.microsoft.com/office/drawing/2010/main" val="0"/>
+              </a:ext>
+            </a:extLst>
+          </a:blip>
+          <a:stretch>
+            <a:fillRect/>
+          </a:stretch>
+        </p:blipFill>
+        <p:spPr>
+          <a:xfrm>
+            <a:off x="2641600" y="1981200"/>
+            <a:ext cx="6908800" cy="4318000"/>
+          </a:xfrm>
+          <a:prstGeom prst="rect">
+            <a:avLst/>
+          </a:prstGeom>
+        </p:spPr>
+      </p:pic>
+      <p:sp>
+        <p:nvSpPr>
+          <p:cNvPr id="6" name="TextBox 5"/>
+          <p:cNvSpPr txBox="1"/>
+          <p:nvPr/>
+        </p:nvSpPr>
+        <p:spPr>
+          <a:xfrm>
+            <a:off x="381000" y="6400800"/>
+            <a:ext cx="10795000" cy="230832"/>
+          </a:xfrm>
+          <a:prstGeom prst="rect">
+            <a:avLst/>
+          </a:prstGeom>
+          <a:noFill/>
+        </p:spPr>
+        <p:txBody>
+          <a:bodyPr vert="horz" rtlCol="0">
+            <a:spAutoFit/>
+          </a:bodyPr>
+          <a:lstStyle/>
+          <a:p>
+            <a:r>
+              <a:rPr lang="en-US" sz="900" smtClean="0">
+                <a:solidFill>
+                  <a:srgbClr val="5EEAD4"/>
+                </a:solidFill>
+                <a:latin typeface="Segoe UI" panose="020B0502040204020203" pitchFamily="34" charset="0"/>
+              </a:rPr>
+              <a:t>Preuve : 13-monitoring/grafana-dashboard.png</a:t>
+            </a:r>
+            <a:endParaRPr lang="en-US" sz="900">
+              <a:solidFill>
+                <a:srgbClr val="5EEAD4"/>
+              </a:solidFill>
+              <a:latin typeface="Segoe UI" panose="020B0502040204020203" pitchFamily="34" charset="0"/>
+            </a:endParaRPr>
+          </a:p>
+        </p:txBody>
+      </p:sp>
+      <p:sp>
+        <p:nvSpPr>
+          <p:cNvPr id="7" name="TextBox 6"/>
+          <p:cNvSpPr txBox="1"/>
+          <p:nvPr/>
+        </p:nvSpPr>
+        <p:spPr>
+          <a:xfrm>
+            <a:off x="11582400" y="6438900"/>
+            <a:ext cx="381000" cy="246221"/>
+          </a:xfrm>
+          <a:prstGeom prst="rect">
+            <a:avLst/>
+          </a:prstGeom>
+          <a:noFill/>
+        </p:spPr>
+        <p:txBody>
+          <a:bodyPr vert="horz" rtlCol="0">
+            <a:spAutoFit/>
+          </a:bodyPr>
+          <a:lstStyle/>
+          <a:p>
+            <a:r>
+              <a:rPr lang="en-US" sz="1000" smtClean="0">
+                <a:solidFill>
+                  <a:srgbClr val="E1E1E1"/>
+                </a:solidFill>
+                <a:latin typeface="Segoe UI" panose="020B0502040204020203" pitchFamily="34" charset="0"/>
+              </a:rPr>
+              <a:t>22</a:t>
+            </a:r>
+            <a:endParaRPr lang="en-US" sz="1000">
+              <a:solidFill>
+                <a:srgbClr val="E1E1E1"/>
+              </a:solidFill>
+              <a:latin typeface="Segoe UI" panose="020B0502040204020203" pitchFamily="34" charset="0"/>
+            </a:endParaRPr>
+          </a:p>
+        </p:txBody>
+      </p:sp>
+    </p:spTree>
+    <p:extLst>
+      <p:ext uri="{BB962C8B-B14F-4D97-AF65-F5344CB8AC3E}">
+        <p14:creationId xmlns:p14="http://schemas.microsoft.com/office/powerpoint/2010/main" val="4022575795"/>
+      </p:ext>
+    </p:extLst>
+  </p:cSld>
+  <p:clrMapOvr>
+    <a:masterClrMapping/>
+  </p:clrMapOvr>
+</p:sld>
+</file>
+
+<file path=ppt/slides/slide23.xml><?xml version="1.0" encoding="utf-8"?>
+<p:sld xmlns:a="http://schemas.openxmlformats.org/drawingml/2006/main" xmlns:r="http://schemas.openxmlformats.org/officeDocument/2006/relationships" xmlns:p="http://schemas.openxmlformats.org/presentationml/2006/main">
+  <p:cSld>
+    <p:bg>
+      <p:bgPr>
+        <a:solidFill>
+          <a:srgbClr val="0F272A"/>
+        </a:solidFill>
+        <a:effectLst/>
+      </p:bgPr>
+    </p:bg>
+    <p:spTree>
+      <p:nvGrpSpPr>
+        <p:cNvPr id="1" name=""/>
+        <p:cNvGrpSpPr/>
+        <p:nvPr/>
+      </p:nvGrpSpPr>
+      <p:grpSpPr>
+        <a:xfrm>
+          <a:off x="0" y="0"/>
+          <a:ext cx="0" cy="0"/>
+          <a:chOff x="0" y="0"/>
+          <a:chExt cx="0" cy="0"/>
+        </a:xfrm>
+      </p:grpSpPr>
+      <p:sp>
+        <p:nvSpPr>
+          <p:cNvPr id="2" name="TextBox 1"/>
+          <p:cNvSpPr txBox="1"/>
+          <p:nvPr/>
+        </p:nvSpPr>
+        <p:spPr>
+          <a:xfrm>
+            <a:off x="381000" y="152400"/>
+            <a:ext cx="10795000" cy="261610"/>
+          </a:xfrm>
+          <a:prstGeom prst="rect">
+            <a:avLst/>
+          </a:prstGeom>
+          <a:noFill/>
+        </p:spPr>
+        <p:txBody>
+          <a:bodyPr vert="horz" rtlCol="0">
+            <a:spAutoFit/>
+          </a:bodyPr>
+          <a:lstStyle/>
+          <a:p>
+            <a:r>
+              <a:rPr lang="en-US" sz="1100" smtClean="0">
+                <a:solidFill>
+                  <a:srgbClr val="5EEAD4"/>
+                </a:solidFill>
+                <a:latin typeface="Segoe UI" panose="020B0502040204020203" pitchFamily="34" charset="0"/>
+              </a:rPr>
+              <a:t>EVENTSPROJECT / MODULE TACHE</a:t>
+            </a:r>
+            <a:endParaRPr lang="en-US" sz="1100">
+              <a:solidFill>
+                <a:srgbClr val="5EEAD4"/>
+              </a:solidFill>
+              <a:latin typeface="Segoe UI" panose="020B0502040204020203" pitchFamily="34" charset="0"/>
+            </a:endParaRPr>
+          </a:p>
+        </p:txBody>
+      </p:sp>
+      <p:sp>
+        <p:nvSpPr>
+          <p:cNvPr id="3" name="TextBox 2"/>
+          <p:cNvSpPr txBox="1"/>
+          <p:nvPr/>
+        </p:nvSpPr>
+        <p:spPr>
+          <a:xfrm>
+            <a:off x="381000" y="533400"/>
+            <a:ext cx="11430000" cy="523220"/>
+          </a:xfrm>
+          <a:prstGeom prst="rect">
+            <a:avLst/>
+          </a:prstGeom>
+          <a:noFill/>
+        </p:spPr>
+        <p:txBody>
+          <a:bodyPr vert="horz" rtlCol="0">
+            <a:spAutoFit/>
+          </a:bodyPr>
+          <a:lstStyle/>
+          <a:p>
+            <a:r>
+              <a:rPr lang="fr-FR" sz="2800" smtClean="0">
+                <a:solidFill>
+                  <a:srgbClr val="FFFFFF"/>
+                </a:solidFill>
+                <a:latin typeface="Segoe UI" panose="020B0502040204020203" pitchFamily="34" charset="0"/>
+              </a:rPr>
+              <a:t>Publier le livrable dans Nexus</a:t>
+            </a:r>
+            <a:endParaRPr lang="en-US" sz="2800">
+              <a:solidFill>
+                <a:srgbClr val="FFFFFF"/>
+              </a:solidFill>
+              <a:latin typeface="Segoe UI" panose="020B0502040204020203" pitchFamily="34" charset="0"/>
+            </a:endParaRPr>
+          </a:p>
+        </p:txBody>
+      </p:sp>
+      <p:sp>
+        <p:nvSpPr>
+          <p:cNvPr id="4" name="TextBox 3"/>
+          <p:cNvSpPr txBox="1"/>
+          <p:nvPr/>
+        </p:nvSpPr>
+        <p:spPr>
+          <a:xfrm>
+            <a:off x="381000" y="1244600"/>
+            <a:ext cx="11430000" cy="338554"/>
+          </a:xfrm>
+          <a:prstGeom prst="rect">
+            <a:avLst/>
+          </a:prstGeom>
+          <a:noFill/>
+        </p:spPr>
+        <p:txBody>
+          <a:bodyPr vert="horz" rtlCol="0">
+            <a:spAutoFit/>
+          </a:bodyPr>
+          <a:lstStyle/>
+          <a:p>
+            <a:r>
+              <a:rPr lang="fr-FR" sz="1600" smtClean="0">
+                <a:solidFill>
+                  <a:srgbClr val="E1E1E1"/>
+                </a:solidFill>
+                <a:latin typeface="Segoe UI" panose="020B0502040204020203" pitchFamily="34" charset="0"/>
+              </a:rPr>
+              <a:t>Le dépôt Maven snapshots contient le JAR et le POM de tn.esprit:eventsProject:1.0.0-SNAPSHOT.</a:t>
+            </a:r>
+            <a:endParaRPr lang="en-US" sz="1600">
+              <a:solidFill>
+                <a:srgbClr val="E1E1E1"/>
+              </a:solidFill>
+              <a:latin typeface="Segoe UI" panose="020B0502040204020203" pitchFamily="34" charset="0"/>
+            </a:endParaRPr>
+          </a:p>
+        </p:txBody>
+      </p:sp>
+      <p:pic>
+        <p:nvPicPr>
+          <p:cNvPr id="5" name="Picture 4"/>
+          <p:cNvPicPr>
+            <a:picLocks noChangeAspect="1"/>
+          </p:cNvPicPr>
+          <p:nvPr/>
+        </p:nvPicPr>
+        <p:blipFill>
+          <a:blip r:embed="rId3">
+            <a:extLst>
+              <a:ext uri="{28A0092B-C50C-407E-A947-70E740481C1C}">
+                <a14:useLocalDpi xmlns:a14="http://schemas.microsoft.com/office/drawing/2010/main" val="0"/>
+              </a:ext>
+            </a:extLst>
+          </a:blip>
+          <a:stretch>
+            <a:fillRect/>
+          </a:stretch>
+        </p:blipFill>
+        <p:spPr>
+          <a:xfrm>
+            <a:off x="1312985" y="1981200"/>
+            <a:ext cx="9566031" cy="4318000"/>
+          </a:xfrm>
+          <a:prstGeom prst="rect">
+            <a:avLst/>
+          </a:prstGeom>
+        </p:spPr>
+      </p:pic>
+      <p:sp>
+        <p:nvSpPr>
+          <p:cNvPr id="6" name="TextBox 5"/>
+          <p:cNvSpPr txBox="1"/>
+          <p:nvPr/>
+        </p:nvSpPr>
+        <p:spPr>
+          <a:xfrm>
+            <a:off x="381000" y="6400800"/>
+            <a:ext cx="10795000" cy="230832"/>
+          </a:xfrm>
+          <a:prstGeom prst="rect">
+            <a:avLst/>
+          </a:prstGeom>
+          <a:noFill/>
+        </p:spPr>
+        <p:txBody>
+          <a:bodyPr vert="horz" rtlCol="0">
+            <a:spAutoFit/>
+          </a:bodyPr>
+          <a:lstStyle/>
+          <a:p>
+            <a:r>
+              <a:rPr lang="en-US" sz="900" smtClean="0">
+                <a:solidFill>
+                  <a:srgbClr val="5EEAD4"/>
+                </a:solidFill>
+                <a:latin typeface="Segoe UI" panose="020B0502040204020203" pitchFamily="34" charset="0"/>
+              </a:rPr>
+              <a:t>Preuve : 07-nexus/nexus-repository.png</a:t>
+            </a:r>
+            <a:endParaRPr lang="en-US" sz="900">
+              <a:solidFill>
+                <a:srgbClr val="5EEAD4"/>
+              </a:solidFill>
+              <a:latin typeface="Segoe UI" panose="020B0502040204020203" pitchFamily="34" charset="0"/>
+            </a:endParaRPr>
+          </a:p>
+        </p:txBody>
+      </p:sp>
+      <p:sp>
+        <p:nvSpPr>
+          <p:cNvPr id="7" name="TextBox 6"/>
+          <p:cNvSpPr txBox="1"/>
+          <p:nvPr/>
+        </p:nvSpPr>
+        <p:spPr>
+          <a:xfrm>
+            <a:off x="11582400" y="6438900"/>
+            <a:ext cx="381000" cy="246221"/>
+          </a:xfrm>
+          <a:prstGeom prst="rect">
+            <a:avLst/>
+          </a:prstGeom>
+          <a:noFill/>
+        </p:spPr>
+        <p:txBody>
+          <a:bodyPr vert="horz" rtlCol="0">
+            <a:spAutoFit/>
+          </a:bodyPr>
+          <a:lstStyle/>
+          <a:p>
+            <a:r>
+              <a:rPr lang="en-US" sz="1000" smtClean="0">
+                <a:solidFill>
+                  <a:srgbClr val="E1E1E1"/>
+                </a:solidFill>
+                <a:latin typeface="Segoe UI" panose="020B0502040204020203" pitchFamily="34" charset="0"/>
+              </a:rPr>
+              <a:t>23</a:t>
+            </a:r>
+            <a:endParaRPr lang="en-US" sz="1000">
+              <a:solidFill>
+                <a:srgbClr val="E1E1E1"/>
+              </a:solidFill>
+              <a:latin typeface="Segoe UI" panose="020B0502040204020203" pitchFamily="34" charset="0"/>
+            </a:endParaRPr>
+          </a:p>
+        </p:txBody>
+      </p:sp>
+    </p:spTree>
+    <p:extLst>
+      <p:ext uri="{BB962C8B-B14F-4D97-AF65-F5344CB8AC3E}">
+        <p14:creationId xmlns:p14="http://schemas.microsoft.com/office/powerpoint/2010/main" val="2779334075"/>
+      </p:ext>
+    </p:extLst>
+  </p:cSld>
+  <p:clrMapOvr>
+    <a:masterClrMapping/>
+  </p:clrMapOvr>
+</p:sld>
+</file>
+
+<file path=ppt/slides/slide24.xml><?xml version="1.0" encoding="utf-8"?>
+<p:sld xmlns:a="http://schemas.openxmlformats.org/drawingml/2006/main" xmlns:r="http://schemas.openxmlformats.org/officeDocument/2006/relationships" xmlns:p="http://schemas.openxmlformats.org/presentationml/2006/main">
+  <p:cSld>
+    <p:bg>
+      <p:bgPr>
+        <a:solidFill>
+          <a:srgbClr val="0F272A"/>
+        </a:solidFill>
+        <a:effectLst/>
+      </p:bgPr>
+    </p:bg>
+    <p:spTree>
+      <p:nvGrpSpPr>
+        <p:cNvPr id="1" name=""/>
+        <p:cNvGrpSpPr/>
+        <p:nvPr/>
+      </p:nvGrpSpPr>
+      <p:grpSpPr>
+        <a:xfrm>
+          <a:off x="0" y="0"/>
+          <a:ext cx="0" cy="0"/>
+          <a:chOff x="0" y="0"/>
+          <a:chExt cx="0" cy="0"/>
+        </a:xfrm>
+      </p:grpSpPr>
+      <p:sp>
+        <p:nvSpPr>
+          <p:cNvPr id="2" name="TextBox 1"/>
+          <p:cNvSpPr txBox="1"/>
+          <p:nvPr/>
+        </p:nvSpPr>
+        <p:spPr>
+          <a:xfrm>
+            <a:off x="381000" y="152400"/>
+            <a:ext cx="10795000" cy="261610"/>
+          </a:xfrm>
+          <a:prstGeom prst="rect">
+            <a:avLst/>
+          </a:prstGeom>
+          <a:noFill/>
+        </p:spPr>
+        <p:txBody>
+          <a:bodyPr vert="horz" rtlCol="0">
+            <a:spAutoFit/>
+          </a:bodyPr>
+          <a:lstStyle/>
+          <a:p>
+            <a:r>
+              <a:rPr lang="en-US" sz="1100" smtClean="0">
+                <a:solidFill>
+                  <a:srgbClr val="5EEAD4"/>
+                </a:solidFill>
+                <a:latin typeface="Segoe UI" panose="020B0502040204020203" pitchFamily="34" charset="0"/>
+              </a:rPr>
+              <a:t>EVENTSPROJECT / MODULE TACHE</a:t>
+            </a:r>
+            <a:endParaRPr lang="en-US" sz="1100">
+              <a:solidFill>
+                <a:srgbClr val="5EEAD4"/>
+              </a:solidFill>
+              <a:latin typeface="Segoe UI" panose="020B0502040204020203" pitchFamily="34" charset="0"/>
+            </a:endParaRPr>
+          </a:p>
+        </p:txBody>
+      </p:sp>
+      <p:sp>
+        <p:nvSpPr>
+          <p:cNvPr id="3" name="TextBox 2"/>
+          <p:cNvSpPr txBox="1"/>
+          <p:nvPr/>
+        </p:nvSpPr>
+        <p:spPr>
+          <a:xfrm>
+            <a:off x="381000" y="533400"/>
+            <a:ext cx="11430000" cy="523220"/>
+          </a:xfrm>
+          <a:prstGeom prst="rect">
+            <a:avLst/>
+          </a:prstGeom>
+          <a:noFill/>
+        </p:spPr>
+        <p:txBody>
+          <a:bodyPr vert="horz" rtlCol="0">
+            <a:spAutoFit/>
+          </a:bodyPr>
+          <a:lstStyle/>
+          <a:p>
+            <a:r>
+              <a:rPr lang="fr-FR" sz="2800" smtClean="0">
+                <a:solidFill>
+                  <a:srgbClr val="FFFFFF"/>
+                </a:solidFill>
+                <a:latin typeface="Segoe UI" panose="020B0502040204020203" pitchFamily="34" charset="0"/>
+              </a:rPr>
+              <a:t>Relier le build au programme exécuté</a:t>
+            </a:r>
+            <a:endParaRPr lang="en-US" sz="2800">
+              <a:solidFill>
+                <a:srgbClr val="FFFFFF"/>
+              </a:solidFill>
+              <a:latin typeface="Segoe UI" panose="020B0502040204020203" pitchFamily="34" charset="0"/>
+            </a:endParaRPr>
+          </a:p>
+        </p:txBody>
+      </p:sp>
+      <p:sp>
+        <p:nvSpPr>
+          <p:cNvPr id="4" name="TextBox 3"/>
+          <p:cNvSpPr txBox="1"/>
+          <p:nvPr/>
+        </p:nvSpPr>
+        <p:spPr>
+          <a:xfrm>
+            <a:off x="381000" y="1244600"/>
+            <a:ext cx="11430000" cy="338554"/>
+          </a:xfrm>
+          <a:prstGeom prst="rect">
+            <a:avLst/>
+          </a:prstGeom>
+          <a:noFill/>
+        </p:spPr>
+        <p:txBody>
+          <a:bodyPr vert="horz" rtlCol="0">
+            <a:spAutoFit/>
+          </a:bodyPr>
+          <a:lstStyle/>
+          <a:p>
+            <a:r>
+              <a:rPr lang="fr-FR" sz="1600" smtClean="0">
+                <a:solidFill>
+                  <a:srgbClr val="E1E1E1"/>
+                </a:solidFill>
+                <a:latin typeface="Segoe UI" panose="020B0502040204020203" pitchFamily="34" charset="0"/>
+              </a:rPr>
+              <a:t>Même SHA-256 pour le JAR archivé par Jenkins, téléchargé de Nexus et présent dans le pod Kubernetes.</a:t>
+            </a:r>
+            <a:endParaRPr lang="en-US" sz="1600">
+              <a:solidFill>
+                <a:srgbClr val="E1E1E1"/>
+              </a:solidFill>
+              <a:latin typeface="Segoe UI" panose="020B0502040204020203" pitchFamily="34" charset="0"/>
+            </a:endParaRPr>
+          </a:p>
+        </p:txBody>
+      </p:sp>
+      <p:pic>
+        <p:nvPicPr>
+          <p:cNvPr id="5" name="Picture 4"/>
+          <p:cNvPicPr>
+            <a:picLocks noChangeAspect="1"/>
+          </p:cNvPicPr>
+          <p:nvPr/>
+        </p:nvPicPr>
+        <p:blipFill>
+          <a:blip r:embed="rId3">
+            <a:extLst>
+              <a:ext uri="{28A0092B-C50C-407E-A947-70E740481C1C}">
+                <a14:useLocalDpi xmlns:a14="http://schemas.microsoft.com/office/drawing/2010/main" val="0"/>
+              </a:ext>
+            </a:extLst>
+          </a:blip>
+          <a:stretch>
+            <a:fillRect/>
+          </a:stretch>
+        </p:blipFill>
+        <p:spPr>
+          <a:xfrm>
+            <a:off x="1953054" y="1981200"/>
+            <a:ext cx="8285892" cy="4318000"/>
+          </a:xfrm>
+          <a:prstGeom prst="rect">
+            <a:avLst/>
+          </a:prstGeom>
+        </p:spPr>
+      </p:pic>
+      <p:sp>
+        <p:nvSpPr>
+          <p:cNvPr id="6" name="TextBox 5"/>
+          <p:cNvSpPr txBox="1"/>
+          <p:nvPr/>
+        </p:nvSpPr>
+        <p:spPr>
+          <a:xfrm>
+            <a:off x="381000" y="6400800"/>
+            <a:ext cx="10795000" cy="230832"/>
+          </a:xfrm>
+          <a:prstGeom prst="rect">
+            <a:avLst/>
+          </a:prstGeom>
+          <a:noFill/>
+        </p:spPr>
+        <p:txBody>
+          <a:bodyPr vert="horz" rtlCol="0">
+            <a:spAutoFit/>
+          </a:bodyPr>
+          <a:lstStyle/>
+          <a:p>
+            <a:r>
+              <a:rPr lang="en-US" sz="900" smtClean="0">
+                <a:solidFill>
+                  <a:srgbClr val="5EEAD4"/>
+                </a:solidFill>
+                <a:latin typeface="Segoe UI" panose="020B0502040204020203" pitchFamily="34" charset="0"/>
+              </a:rPr>
+              <a:t>Preuve : 12-final-validation/local-delivery.png</a:t>
+            </a:r>
+            <a:endParaRPr lang="en-US" sz="900">
+              <a:solidFill>
+                <a:srgbClr val="5EEAD4"/>
+              </a:solidFill>
+              <a:latin typeface="Segoe UI" panose="020B0502040204020203" pitchFamily="34" charset="0"/>
+            </a:endParaRPr>
+          </a:p>
+        </p:txBody>
+      </p:sp>
+      <p:sp>
+        <p:nvSpPr>
+          <p:cNvPr id="7" name="TextBox 6"/>
+          <p:cNvSpPr txBox="1"/>
+          <p:nvPr/>
+        </p:nvSpPr>
+        <p:spPr>
+          <a:xfrm>
+            <a:off x="11582400" y="6438900"/>
+            <a:ext cx="381000" cy="246221"/>
+          </a:xfrm>
+          <a:prstGeom prst="rect">
+            <a:avLst/>
+          </a:prstGeom>
+          <a:noFill/>
+        </p:spPr>
+        <p:txBody>
+          <a:bodyPr vert="horz" rtlCol="0">
+            <a:spAutoFit/>
+          </a:bodyPr>
+          <a:lstStyle/>
+          <a:p>
+            <a:r>
+              <a:rPr lang="en-US" sz="1000" smtClean="0">
+                <a:solidFill>
+                  <a:srgbClr val="E1E1E1"/>
+                </a:solidFill>
+                <a:latin typeface="Segoe UI" panose="020B0502040204020203" pitchFamily="34" charset="0"/>
+              </a:rPr>
+              <a:t>24</a:t>
+            </a:r>
+            <a:endParaRPr lang="en-US" sz="1000">
+              <a:solidFill>
+                <a:srgbClr val="E1E1E1"/>
+              </a:solidFill>
+              <a:latin typeface="Segoe UI" panose="020B0502040204020203" pitchFamily="34" charset="0"/>
+            </a:endParaRPr>
+          </a:p>
+        </p:txBody>
+      </p:sp>
+    </p:spTree>
+    <p:extLst>
+      <p:ext uri="{BB962C8B-B14F-4D97-AF65-F5344CB8AC3E}">
+        <p14:creationId xmlns:p14="http://schemas.microsoft.com/office/powerpoint/2010/main" val="457852932"/>
       </p:ext>
     </p:extLst>
   </p:cSld>
@@ -8399,7 +10164,7 @@
     </p:spTree>
     <p:extLst>
       <p:ext uri="{BB962C8B-B14F-4D97-AF65-F5344CB8AC3E}">
-        <p14:creationId xmlns:p14="http://schemas.microsoft.com/office/powerpoint/2010/main" val="894905943"/>
+        <p14:creationId xmlns:p14="http://schemas.microsoft.com/office/powerpoint/2010/main" val="4253480446"/>
       </p:ext>
     </p:extLst>
   </p:cSld>
@@ -8667,7 +10432,7 @@
     </p:spTree>
     <p:extLst>
       <p:ext uri="{BB962C8B-B14F-4D97-AF65-F5344CB8AC3E}">
-        <p14:creationId xmlns:p14="http://schemas.microsoft.com/office/powerpoint/2010/main" val="3320067548"/>
+        <p14:creationId xmlns:p14="http://schemas.microsoft.com/office/powerpoint/2010/main" val="2195156587"/>
       </p:ext>
     </p:extLst>
   </p:cSld>
@@ -8935,7 +10700,7 @@
     </p:spTree>
     <p:extLst>
       <p:ext uri="{BB962C8B-B14F-4D97-AF65-F5344CB8AC3E}">
-        <p14:creationId xmlns:p14="http://schemas.microsoft.com/office/powerpoint/2010/main" val="1939189304"/>
+        <p14:creationId xmlns:p14="http://schemas.microsoft.com/office/powerpoint/2010/main" val="3292979624"/>
       </p:ext>
     </p:extLst>
   </p:cSld>
@@ -9203,7 +10968,7 @@
     </p:spTree>
     <p:extLst>
       <p:ext uri="{BB962C8B-B14F-4D97-AF65-F5344CB8AC3E}">
-        <p14:creationId xmlns:p14="http://schemas.microsoft.com/office/powerpoint/2010/main" val="1950710264"/>
+        <p14:creationId xmlns:p14="http://schemas.microsoft.com/office/powerpoint/2010/main" val="2248988109"/>
       </p:ext>
     </p:extLst>
   </p:cSld>
@@ -9471,7 +11236,7 @@
     </p:spTree>
     <p:extLst>
       <p:ext uri="{BB962C8B-B14F-4D97-AF65-F5344CB8AC3E}">
-        <p14:creationId xmlns:p14="http://schemas.microsoft.com/office/powerpoint/2010/main" val="3327717445"/>
+        <p14:creationId xmlns:p14="http://schemas.microsoft.com/office/powerpoint/2010/main" val="3456391981"/>
       </p:ext>
     </p:extLst>
   </p:cSld>
@@ -9569,13 +11334,13 @@
           <a:lstStyle/>
           <a:p>
             <a:r>
-              <a:rPr lang="fr-FR" sz="2800" smtClean="0">
+              <a:rPr lang="en-US" sz="2800" smtClean="0">
                 <a:solidFill>
                   <a:srgbClr val="FFFFFF"/>
                 </a:solidFill>
                 <a:latin typeface="Segoe UI" panose="020B0502040204020203" pitchFamily="34" charset="0"/>
               </a:rPr>
-              <a:t>Des tests à trois niveaux</a:t>
+              <a:t>38 tests automatisés</a:t>
             </a:r>
             <a:endParaRPr lang="en-US" sz="2800">
               <a:solidFill>
@@ -9615,7 +11380,7 @@
                 </a:solidFill>
                 <a:latin typeface="Segoe UI" panose="020B0502040204020203" pitchFamily="34" charset="0"/>
               </a:rPr>
-              <a:t>20 tests réussis : Mockito, contrat HTTP et intégration JPA/H2 sans mocks.</a:t>
+              <a:t>Service Mockito, contrats HTTP, JPA/H2 sans mocks et mapping sécurisé des anciennes entrées.</a:t>
             </a:r>
             <a:endParaRPr lang="en-US" sz="1600">
               <a:solidFill>
@@ -9648,8 +11413,8 @@
         </p:blipFill>
         <p:spPr>
           <a:xfrm>
-            <a:off x="1953054" y="1981200"/>
-            <a:ext cx="8285892" cy="4318000"/>
+            <a:off x="2209800" y="1981200"/>
+            <a:ext cx="7772400" cy="4318000"/>
           </a:xfrm>
           <a:prstGeom prst="rect">
             <a:avLst/>
@@ -9685,7 +11450,7 @@
                 </a:solidFill>
                 <a:latin typeface="Segoe UI" panose="020B0502040204020203" pitchFamily="34" charset="0"/>
               </a:rPr>
-              <a:t>Preuve : 04-unit-tests/tests-success.png</a:t>
+              <a:t>Preuve : 08-jenkins/jenkins-tests.png</a:t>
             </a:r>
             <a:endParaRPr lang="en-US" sz="900">
               <a:solidFill>
@@ -9739,7 +11504,7 @@
     </p:spTree>
     <p:extLst>
       <p:ext uri="{BB962C8B-B14F-4D97-AF65-F5344CB8AC3E}">
-        <p14:creationId xmlns:p14="http://schemas.microsoft.com/office/powerpoint/2010/main" val="1206653591"/>
+        <p14:creationId xmlns:p14="http://schemas.microsoft.com/office/powerpoint/2010/main" val="1422515335"/>
       </p:ext>
     </p:extLst>
   </p:cSld>
@@ -9843,7 +11608,7 @@
                 </a:solidFill>
                 <a:latin typeface="Segoe UI" panose="020B0502040204020203" pitchFamily="34" charset="0"/>
               </a:rPr>
-              <a:t>Une couverture métier mesurée</a:t>
+              <a:t>Sécuriser les entrées existantes</a:t>
             </a:r>
             <a:endParaRPr lang="en-US" sz="2800">
               <a:solidFill>
@@ -9883,7 +11648,7 @@
                 </a:solidFill>
                 <a:latin typeface="Segoe UI" panose="020B0502040204020203" pitchFamily="34" charset="0"/>
               </a:rPr>
-              <a:t>TacheService : 24 lignes et 4 branches couvertes ; ce résultat concerne ce service.</a:t>
+              <a:t>Quatre entrées utilisent des DTO : identifiants générés et coût calculé protégés ; compatibilité HTTP/MySQL vérifiée.</a:t>
             </a:r>
             <a:endParaRPr lang="en-US" sz="1600">
               <a:solidFill>
@@ -9953,7 +11718,7 @@
                 </a:solidFill>
                 <a:latin typeface="Segoe UI" panose="020B0502040204020203" pitchFamily="34" charset="0"/>
               </a:rPr>
-              <a:t>Preuve : 04-unit-tests/coverage-service.png</a:t>
+              <a:t>Preuve : 12-final-validation/legacy-dto-api.png</a:t>
             </a:r>
             <a:endParaRPr lang="en-US" sz="900">
               <a:solidFill>
@@ -10007,7 +11772,7 @@
     </p:spTree>
     <p:extLst>
       <p:ext uri="{BB962C8B-B14F-4D97-AF65-F5344CB8AC3E}">
-        <p14:creationId xmlns:p14="http://schemas.microsoft.com/office/powerpoint/2010/main" val="1514066874"/>
+        <p14:creationId xmlns:p14="http://schemas.microsoft.com/office/powerpoint/2010/main" val="3118104429"/>
       </p:ext>
     </p:extLst>
   </p:cSld>

</xml_diff>

<commit_message>
docs: verify public delivery build 7 and finalize the 25-slide presentation
</commit_message>
<xml_diff>
--- a/docs/presentation/eventsProject-Tache.pptx
+++ b/docs/presentation/eventsProject-Tache.pptx
@@ -5,7 +5,7 @@
     <p:sldMasterId id="2147483648" r:id="rId1"/>
   </p:sldMasterIdLst>
   <p:notesMasterIdLst>
-    <p:notesMasterId r:id="rId26"/>
+    <p:notesMasterId r:id="rId27"/>
   </p:notesMasterIdLst>
   <p:sldIdLst>
     <p:sldId id="256" r:id="rId2"/>
@@ -32,6 +32,7 @@
     <p:sldId id="277" r:id="rId23"/>
     <p:sldId id="278" r:id="rId24"/>
     <p:sldId id="279" r:id="rId25"/>
+    <p:sldId id="280" r:id="rId26"/>
   </p:sldIdLst>
   <p:sldSz cx="12192000" cy="6858000"/>
   <p:notesSz cx="6858000" cy="9144000"/>
@@ -213,7 +214,7 @@
             </a:lvl1pPr>
           </a:lstStyle>
           <a:p>
-            <a:fld id="{E2A5EAC1-0049-44D6-989B-F817D27EE345}" type="datetimeFigureOut">
+            <a:fld id="{AD5BF8BE-CB2F-4A6E-BF13-290BAA044677}" type="datetimeFigureOut">
               <a:rPr lang="en-US" smtClean="0"/>
               <a:t>10/29/2026</a:t>
             </a:fld>
@@ -372,7 +373,7 @@
             </a:lvl1pPr>
           </a:lstStyle>
           <a:p>
-            <a:fld id="{39E91E94-9227-4269-937B-80A0D5D87A88}" type="slidenum">
+            <a:fld id="{54A143B8-B843-4E15-B9C0-488B5B777352}" type="slidenum">
               <a:rPr lang="en-US" smtClean="0"/>
               <a:t>‹#›</a:t>
             </a:fld>
@@ -383,7 +384,7 @@
     </p:spTree>
     <p:extLst>
       <p:ext uri="{BB962C8B-B14F-4D97-AF65-F5344CB8AC3E}">
-        <p14:creationId xmlns:p14="http://schemas.microsoft.com/office/powerpoint/2010/main" val="1321516564"/>
+        <p14:creationId xmlns:p14="http://schemas.microsoft.com/office/powerpoint/2010/main" val="3085472980"/>
       </p:ext>
     </p:extLst>
   </p:cSld>
@@ -546,7 +547,7 @@
           <a:bodyPr/>
           <a:lstStyle/>
           <a:p>
-            <a:fld id="{39E91E94-9227-4269-937B-80A0D5D87A88}" type="slidenum">
+            <a:fld id="{54A143B8-B843-4E15-B9C0-488B5B777352}" type="slidenum">
               <a:rPr lang="en-US" smtClean="0"/>
               <a:t>1</a:t>
             </a:fld>
@@ -557,7 +558,7 @@
     </p:spTree>
     <p:extLst>
       <p:ext uri="{BB962C8B-B14F-4D97-AF65-F5344CB8AC3E}">
-        <p14:creationId xmlns:p14="http://schemas.microsoft.com/office/powerpoint/2010/main" val="2440493528"/>
+        <p14:creationId xmlns:p14="http://schemas.microsoft.com/office/powerpoint/2010/main" val="2870680616"/>
       </p:ext>
     </p:extLst>
   </p:cSld>
@@ -630,7 +631,7 @@
           <a:bodyPr/>
           <a:lstStyle/>
           <a:p>
-            <a:fld id="{39E91E94-9227-4269-937B-80A0D5D87A88}" type="slidenum">
+            <a:fld id="{54A143B8-B843-4E15-B9C0-488B5B777352}" type="slidenum">
               <a:rPr lang="en-US" smtClean="0"/>
               <a:t>10</a:t>
             </a:fld>
@@ -641,7 +642,7 @@
     </p:spTree>
     <p:extLst>
       <p:ext uri="{BB962C8B-B14F-4D97-AF65-F5344CB8AC3E}">
-        <p14:creationId xmlns:p14="http://schemas.microsoft.com/office/powerpoint/2010/main" val="2866487243"/>
+        <p14:creationId xmlns:p14="http://schemas.microsoft.com/office/powerpoint/2010/main" val="799473095"/>
       </p:ext>
     </p:extLst>
   </p:cSld>
@@ -714,7 +715,7 @@
           <a:bodyPr/>
           <a:lstStyle/>
           <a:p>
-            <a:fld id="{39E91E94-9227-4269-937B-80A0D5D87A88}" type="slidenum">
+            <a:fld id="{54A143B8-B843-4E15-B9C0-488B5B777352}" type="slidenum">
               <a:rPr lang="en-US" smtClean="0"/>
               <a:t>11</a:t>
             </a:fld>
@@ -725,7 +726,7 @@
     </p:spTree>
     <p:extLst>
       <p:ext uri="{BB962C8B-B14F-4D97-AF65-F5344CB8AC3E}">
-        <p14:creationId xmlns:p14="http://schemas.microsoft.com/office/powerpoint/2010/main" val="3865239220"/>
+        <p14:creationId xmlns:p14="http://schemas.microsoft.com/office/powerpoint/2010/main" val="1646165105"/>
       </p:ext>
     </p:extLst>
   </p:cSld>
@@ -798,7 +799,7 @@
           <a:bodyPr/>
           <a:lstStyle/>
           <a:p>
-            <a:fld id="{39E91E94-9227-4269-937B-80A0D5D87A88}" type="slidenum">
+            <a:fld id="{54A143B8-B843-4E15-B9C0-488B5B777352}" type="slidenum">
               <a:rPr lang="en-US" smtClean="0"/>
               <a:t>12</a:t>
             </a:fld>
@@ -809,7 +810,7 @@
     </p:spTree>
     <p:extLst>
       <p:ext uri="{BB962C8B-B14F-4D97-AF65-F5344CB8AC3E}">
-        <p14:creationId xmlns:p14="http://schemas.microsoft.com/office/powerpoint/2010/main" val="1597038625"/>
+        <p14:creationId xmlns:p14="http://schemas.microsoft.com/office/powerpoint/2010/main" val="1238696553"/>
       </p:ext>
     </p:extLst>
   </p:cSld>
@@ -882,7 +883,7 @@
           <a:bodyPr/>
           <a:lstStyle/>
           <a:p>
-            <a:fld id="{39E91E94-9227-4269-937B-80A0D5D87A88}" type="slidenum">
+            <a:fld id="{54A143B8-B843-4E15-B9C0-488B5B777352}" type="slidenum">
               <a:rPr lang="en-US" smtClean="0"/>
               <a:t>13</a:t>
             </a:fld>
@@ -893,7 +894,7 @@
     </p:spTree>
     <p:extLst>
       <p:ext uri="{BB962C8B-B14F-4D97-AF65-F5344CB8AC3E}">
-        <p14:creationId xmlns:p14="http://schemas.microsoft.com/office/powerpoint/2010/main" val="2083878556"/>
+        <p14:creationId xmlns:p14="http://schemas.microsoft.com/office/powerpoint/2010/main" val="934135721"/>
       </p:ext>
     </p:extLst>
   </p:cSld>
@@ -966,7 +967,7 @@
           <a:bodyPr/>
           <a:lstStyle/>
           <a:p>
-            <a:fld id="{39E91E94-9227-4269-937B-80A0D5D87A88}" type="slidenum">
+            <a:fld id="{54A143B8-B843-4E15-B9C0-488B5B777352}" type="slidenum">
               <a:rPr lang="en-US" smtClean="0"/>
               <a:t>14</a:t>
             </a:fld>
@@ -977,7 +978,7 @@
     </p:spTree>
     <p:extLst>
       <p:ext uri="{BB962C8B-B14F-4D97-AF65-F5344CB8AC3E}">
-        <p14:creationId xmlns:p14="http://schemas.microsoft.com/office/powerpoint/2010/main" val="2401353998"/>
+        <p14:creationId xmlns:p14="http://schemas.microsoft.com/office/powerpoint/2010/main" val="613009976"/>
       </p:ext>
     </p:extLst>
   </p:cSld>
@@ -1050,7 +1051,7 @@
           <a:bodyPr/>
           <a:lstStyle/>
           <a:p>
-            <a:fld id="{39E91E94-9227-4269-937B-80A0D5D87A88}" type="slidenum">
+            <a:fld id="{54A143B8-B843-4E15-B9C0-488B5B777352}" type="slidenum">
               <a:rPr lang="en-US" smtClean="0"/>
               <a:t>15</a:t>
             </a:fld>
@@ -1061,7 +1062,7 @@
     </p:spTree>
     <p:extLst>
       <p:ext uri="{BB962C8B-B14F-4D97-AF65-F5344CB8AC3E}">
-        <p14:creationId xmlns:p14="http://schemas.microsoft.com/office/powerpoint/2010/main" val="1074881612"/>
+        <p14:creationId xmlns:p14="http://schemas.microsoft.com/office/powerpoint/2010/main" val="1111509946"/>
       </p:ext>
     </p:extLst>
   </p:cSld>
@@ -1134,7 +1135,7 @@
           <a:bodyPr/>
           <a:lstStyle/>
           <a:p>
-            <a:fld id="{39E91E94-9227-4269-937B-80A0D5D87A88}" type="slidenum">
+            <a:fld id="{54A143B8-B843-4E15-B9C0-488B5B777352}" type="slidenum">
               <a:rPr lang="en-US" smtClean="0"/>
               <a:t>16</a:t>
             </a:fld>
@@ -1145,7 +1146,7 @@
     </p:spTree>
     <p:extLst>
       <p:ext uri="{BB962C8B-B14F-4D97-AF65-F5344CB8AC3E}">
-        <p14:creationId xmlns:p14="http://schemas.microsoft.com/office/powerpoint/2010/main" val="3600502929"/>
+        <p14:creationId xmlns:p14="http://schemas.microsoft.com/office/powerpoint/2010/main" val="3149397995"/>
       </p:ext>
     </p:extLst>
   </p:cSld>
@@ -1218,7 +1219,7 @@
           <a:bodyPr/>
           <a:lstStyle/>
           <a:p>
-            <a:fld id="{39E91E94-9227-4269-937B-80A0D5D87A88}" type="slidenum">
+            <a:fld id="{54A143B8-B843-4E15-B9C0-488B5B777352}" type="slidenum">
               <a:rPr lang="en-US" smtClean="0"/>
               <a:t>17</a:t>
             </a:fld>
@@ -1229,7 +1230,7 @@
     </p:spTree>
     <p:extLst>
       <p:ext uri="{BB962C8B-B14F-4D97-AF65-F5344CB8AC3E}">
-        <p14:creationId xmlns:p14="http://schemas.microsoft.com/office/powerpoint/2010/main" val="3240129585"/>
+        <p14:creationId xmlns:p14="http://schemas.microsoft.com/office/powerpoint/2010/main" val="2360377795"/>
       </p:ext>
     </p:extLst>
   </p:cSld>
@@ -1302,7 +1303,7 @@
           <a:bodyPr/>
           <a:lstStyle/>
           <a:p>
-            <a:fld id="{39E91E94-9227-4269-937B-80A0D5D87A88}" type="slidenum">
+            <a:fld id="{54A143B8-B843-4E15-B9C0-488B5B777352}" type="slidenum">
               <a:rPr lang="en-US" smtClean="0"/>
               <a:t>18</a:t>
             </a:fld>
@@ -1313,7 +1314,7 @@
     </p:spTree>
     <p:extLst>
       <p:ext uri="{BB962C8B-B14F-4D97-AF65-F5344CB8AC3E}">
-        <p14:creationId xmlns:p14="http://schemas.microsoft.com/office/powerpoint/2010/main" val="1307325829"/>
+        <p14:creationId xmlns:p14="http://schemas.microsoft.com/office/powerpoint/2010/main" val="2004483061"/>
       </p:ext>
     </p:extLst>
   </p:cSld>
@@ -1386,7 +1387,7 @@
           <a:bodyPr/>
           <a:lstStyle/>
           <a:p>
-            <a:fld id="{39E91E94-9227-4269-937B-80A0D5D87A88}" type="slidenum">
+            <a:fld id="{54A143B8-B843-4E15-B9C0-488B5B777352}" type="slidenum">
               <a:rPr lang="en-US" smtClean="0"/>
               <a:t>19</a:t>
             </a:fld>
@@ -1397,7 +1398,7 @@
     </p:spTree>
     <p:extLst>
       <p:ext uri="{BB962C8B-B14F-4D97-AF65-F5344CB8AC3E}">
-        <p14:creationId xmlns:p14="http://schemas.microsoft.com/office/powerpoint/2010/main" val="2482262260"/>
+        <p14:creationId xmlns:p14="http://schemas.microsoft.com/office/powerpoint/2010/main" val="3404336856"/>
       </p:ext>
     </p:extLst>
   </p:cSld>
@@ -1470,7 +1471,7 @@
           <a:bodyPr/>
           <a:lstStyle/>
           <a:p>
-            <a:fld id="{39E91E94-9227-4269-937B-80A0D5D87A88}" type="slidenum">
+            <a:fld id="{54A143B8-B843-4E15-B9C0-488B5B777352}" type="slidenum">
               <a:rPr lang="en-US" smtClean="0"/>
               <a:t>2</a:t>
             </a:fld>
@@ -1481,7 +1482,7 @@
     </p:spTree>
     <p:extLst>
       <p:ext uri="{BB962C8B-B14F-4D97-AF65-F5344CB8AC3E}">
-        <p14:creationId xmlns:p14="http://schemas.microsoft.com/office/powerpoint/2010/main" val="2399758814"/>
+        <p14:creationId xmlns:p14="http://schemas.microsoft.com/office/powerpoint/2010/main" val="1674566991"/>
       </p:ext>
     </p:extLst>
   </p:cSld>
@@ -1554,7 +1555,7 @@
           <a:bodyPr/>
           <a:lstStyle/>
           <a:p>
-            <a:fld id="{39E91E94-9227-4269-937B-80A0D5D87A88}" type="slidenum">
+            <a:fld id="{54A143B8-B843-4E15-B9C0-488B5B777352}" type="slidenum">
               <a:rPr lang="en-US" smtClean="0"/>
               <a:t>20</a:t>
             </a:fld>
@@ -1565,7 +1566,7 @@
     </p:spTree>
     <p:extLst>
       <p:ext uri="{BB962C8B-B14F-4D97-AF65-F5344CB8AC3E}">
-        <p14:creationId xmlns:p14="http://schemas.microsoft.com/office/powerpoint/2010/main" val="1394240634"/>
+        <p14:creationId xmlns:p14="http://schemas.microsoft.com/office/powerpoint/2010/main" val="690551839"/>
       </p:ext>
     </p:extLst>
   </p:cSld>
@@ -1638,7 +1639,7 @@
           <a:bodyPr/>
           <a:lstStyle/>
           <a:p>
-            <a:fld id="{39E91E94-9227-4269-937B-80A0D5D87A88}" type="slidenum">
+            <a:fld id="{54A143B8-B843-4E15-B9C0-488B5B777352}" type="slidenum">
               <a:rPr lang="en-US" smtClean="0"/>
               <a:t>21</a:t>
             </a:fld>
@@ -1649,7 +1650,7 @@
     </p:spTree>
     <p:extLst>
       <p:ext uri="{BB962C8B-B14F-4D97-AF65-F5344CB8AC3E}">
-        <p14:creationId xmlns:p14="http://schemas.microsoft.com/office/powerpoint/2010/main" val="2603842740"/>
+        <p14:creationId xmlns:p14="http://schemas.microsoft.com/office/powerpoint/2010/main" val="104340086"/>
       </p:ext>
     </p:extLst>
   </p:cSld>
@@ -1722,7 +1723,7 @@
           <a:bodyPr/>
           <a:lstStyle/>
           <a:p>
-            <a:fld id="{39E91E94-9227-4269-937B-80A0D5D87A88}" type="slidenum">
+            <a:fld id="{54A143B8-B843-4E15-B9C0-488B5B777352}" type="slidenum">
               <a:rPr lang="en-US" smtClean="0"/>
               <a:t>22</a:t>
             </a:fld>
@@ -1733,7 +1734,7 @@
     </p:spTree>
     <p:extLst>
       <p:ext uri="{BB962C8B-B14F-4D97-AF65-F5344CB8AC3E}">
-        <p14:creationId xmlns:p14="http://schemas.microsoft.com/office/powerpoint/2010/main" val="3629553499"/>
+        <p14:creationId xmlns:p14="http://schemas.microsoft.com/office/powerpoint/2010/main" val="4160987656"/>
       </p:ext>
     </p:extLst>
   </p:cSld>
@@ -1806,7 +1807,7 @@
           <a:bodyPr/>
           <a:lstStyle/>
           <a:p>
-            <a:fld id="{39E91E94-9227-4269-937B-80A0D5D87A88}" type="slidenum">
+            <a:fld id="{54A143B8-B843-4E15-B9C0-488B5B777352}" type="slidenum">
               <a:rPr lang="en-US" smtClean="0"/>
               <a:t>23</a:t>
             </a:fld>
@@ -1817,7 +1818,7 @@
     </p:spTree>
     <p:extLst>
       <p:ext uri="{BB962C8B-B14F-4D97-AF65-F5344CB8AC3E}">
-        <p14:creationId xmlns:p14="http://schemas.microsoft.com/office/powerpoint/2010/main" val="2291460243"/>
+        <p14:creationId xmlns:p14="http://schemas.microsoft.com/office/powerpoint/2010/main" val="4145832586"/>
       </p:ext>
     </p:extLst>
   </p:cSld>
@@ -1890,7 +1891,7 @@
           <a:bodyPr/>
           <a:lstStyle/>
           <a:p>
-            <a:fld id="{39E91E94-9227-4269-937B-80A0D5D87A88}" type="slidenum">
+            <a:fld id="{54A143B8-B843-4E15-B9C0-488B5B777352}" type="slidenum">
               <a:rPr lang="en-US" smtClean="0"/>
               <a:t>24</a:t>
             </a:fld>
@@ -1901,7 +1902,91 @@
     </p:spTree>
     <p:extLst>
       <p:ext uri="{BB962C8B-B14F-4D97-AF65-F5344CB8AC3E}">
-        <p14:creationId xmlns:p14="http://schemas.microsoft.com/office/powerpoint/2010/main" val="3229301419"/>
+        <p14:creationId xmlns:p14="http://schemas.microsoft.com/office/powerpoint/2010/main" val="456404152"/>
+      </p:ext>
+    </p:extLst>
+  </p:cSld>
+  <p:clrMapOvr>
+    <a:masterClrMapping/>
+  </p:clrMapOvr>
+</p:notes>
+</file>
+
+<file path=ppt/notesSlides/notesSlide25.xml><?xml version="1.0" encoding="utf-8"?>
+<p:notes xmlns:a="http://schemas.openxmlformats.org/drawingml/2006/main" xmlns:r="http://schemas.openxmlformats.org/officeDocument/2006/relationships" xmlns:p="http://schemas.openxmlformats.org/presentationml/2006/main">
+  <p:cSld>
+    <p:spTree>
+      <p:nvGrpSpPr>
+        <p:cNvPr id="1" name=""/>
+        <p:cNvGrpSpPr/>
+        <p:nvPr/>
+      </p:nvGrpSpPr>
+      <p:grpSpPr>
+        <a:xfrm>
+          <a:off x="0" y="0"/>
+          <a:ext cx="0" cy="0"/>
+          <a:chOff x="0" y="0"/>
+          <a:chExt cx="0" cy="0"/>
+        </a:xfrm>
+      </p:grpSpPr>
+      <p:sp>
+        <p:nvSpPr>
+          <p:cNvPr id="2" name="Slide Image Placeholder 1"/>
+          <p:cNvSpPr>
+            <a:spLocks noGrp="1" noRot="1" noChangeAspect="1"/>
+          </p:cNvSpPr>
+          <p:nvPr>
+            <p:ph type="sldImg"/>
+          </p:nvPr>
+        </p:nvSpPr>
+        <p:spPr/>
+      </p:sp>
+      <p:sp>
+        <p:nvSpPr>
+          <p:cNvPr id="3" name="Notes Placeholder 2"/>
+          <p:cNvSpPr>
+            <a:spLocks noGrp="1"/>
+          </p:cNvSpPr>
+          <p:nvPr>
+            <p:ph type="body" idx="1"/>
+          </p:nvPr>
+        </p:nvSpPr>
+        <p:spPr/>
+        <p:txBody>
+          <a:bodyPr/>
+          <a:lstStyle/>
+          <a:p>
+            <a:endParaRPr lang="en-US"/>
+          </a:p>
+        </p:txBody>
+      </p:sp>
+      <p:sp>
+        <p:nvSpPr>
+          <p:cNvPr id="4" name="Slide Number Placeholder 3"/>
+          <p:cNvSpPr>
+            <a:spLocks noGrp="1"/>
+          </p:cNvSpPr>
+          <p:nvPr>
+            <p:ph type="sldNum" sz="quarter" idx="10"/>
+          </p:nvPr>
+        </p:nvSpPr>
+        <p:spPr/>
+        <p:txBody>
+          <a:bodyPr/>
+          <a:lstStyle/>
+          <a:p>
+            <a:fld id="{54A143B8-B843-4E15-B9C0-488B5B777352}" type="slidenum">
+              <a:rPr lang="en-US" smtClean="0"/>
+              <a:t>25</a:t>
+            </a:fld>
+            <a:endParaRPr lang="en-US"/>
+          </a:p>
+        </p:txBody>
+      </p:sp>
+    </p:spTree>
+    <p:extLst>
+      <p:ext uri="{BB962C8B-B14F-4D97-AF65-F5344CB8AC3E}">
+        <p14:creationId xmlns:p14="http://schemas.microsoft.com/office/powerpoint/2010/main" val="1681073096"/>
       </p:ext>
     </p:extLst>
   </p:cSld>
@@ -1974,7 +2059,7 @@
           <a:bodyPr/>
           <a:lstStyle/>
           <a:p>
-            <a:fld id="{39E91E94-9227-4269-937B-80A0D5D87A88}" type="slidenum">
+            <a:fld id="{54A143B8-B843-4E15-B9C0-488B5B777352}" type="slidenum">
               <a:rPr lang="en-US" smtClean="0"/>
               <a:t>3</a:t>
             </a:fld>
@@ -1985,7 +2070,7 @@
     </p:spTree>
     <p:extLst>
       <p:ext uri="{BB962C8B-B14F-4D97-AF65-F5344CB8AC3E}">
-        <p14:creationId xmlns:p14="http://schemas.microsoft.com/office/powerpoint/2010/main" val="2779272014"/>
+        <p14:creationId xmlns:p14="http://schemas.microsoft.com/office/powerpoint/2010/main" val="2448627530"/>
       </p:ext>
     </p:extLst>
   </p:cSld>
@@ -2058,7 +2143,7 @@
           <a:bodyPr/>
           <a:lstStyle/>
           <a:p>
-            <a:fld id="{39E91E94-9227-4269-937B-80A0D5D87A88}" type="slidenum">
+            <a:fld id="{54A143B8-B843-4E15-B9C0-488B5B777352}" type="slidenum">
               <a:rPr lang="en-US" smtClean="0"/>
               <a:t>4</a:t>
             </a:fld>
@@ -2069,7 +2154,7 @@
     </p:spTree>
     <p:extLst>
       <p:ext uri="{BB962C8B-B14F-4D97-AF65-F5344CB8AC3E}">
-        <p14:creationId xmlns:p14="http://schemas.microsoft.com/office/powerpoint/2010/main" val="4138991492"/>
+        <p14:creationId xmlns:p14="http://schemas.microsoft.com/office/powerpoint/2010/main" val="1347673264"/>
       </p:ext>
     </p:extLst>
   </p:cSld>
@@ -2142,7 +2227,7 @@
           <a:bodyPr/>
           <a:lstStyle/>
           <a:p>
-            <a:fld id="{39E91E94-9227-4269-937B-80A0D5D87A88}" type="slidenum">
+            <a:fld id="{54A143B8-B843-4E15-B9C0-488B5B777352}" type="slidenum">
               <a:rPr lang="en-US" smtClean="0"/>
               <a:t>5</a:t>
             </a:fld>
@@ -2153,7 +2238,7 @@
     </p:spTree>
     <p:extLst>
       <p:ext uri="{BB962C8B-B14F-4D97-AF65-F5344CB8AC3E}">
-        <p14:creationId xmlns:p14="http://schemas.microsoft.com/office/powerpoint/2010/main" val="3496718713"/>
+        <p14:creationId xmlns:p14="http://schemas.microsoft.com/office/powerpoint/2010/main" val="2549512898"/>
       </p:ext>
     </p:extLst>
   </p:cSld>
@@ -2226,7 +2311,7 @@
           <a:bodyPr/>
           <a:lstStyle/>
           <a:p>
-            <a:fld id="{39E91E94-9227-4269-937B-80A0D5D87A88}" type="slidenum">
+            <a:fld id="{54A143B8-B843-4E15-B9C0-488B5B777352}" type="slidenum">
               <a:rPr lang="en-US" smtClean="0"/>
               <a:t>6</a:t>
             </a:fld>
@@ -2237,7 +2322,7 @@
     </p:spTree>
     <p:extLst>
       <p:ext uri="{BB962C8B-B14F-4D97-AF65-F5344CB8AC3E}">
-        <p14:creationId xmlns:p14="http://schemas.microsoft.com/office/powerpoint/2010/main" val="2760396397"/>
+        <p14:creationId xmlns:p14="http://schemas.microsoft.com/office/powerpoint/2010/main" val="3231376554"/>
       </p:ext>
     </p:extLst>
   </p:cSld>
@@ -2310,7 +2395,7 @@
           <a:bodyPr/>
           <a:lstStyle/>
           <a:p>
-            <a:fld id="{39E91E94-9227-4269-937B-80A0D5D87A88}" type="slidenum">
+            <a:fld id="{54A143B8-B843-4E15-B9C0-488B5B777352}" type="slidenum">
               <a:rPr lang="en-US" smtClean="0"/>
               <a:t>7</a:t>
             </a:fld>
@@ -2321,7 +2406,7 @@
     </p:spTree>
     <p:extLst>
       <p:ext uri="{BB962C8B-B14F-4D97-AF65-F5344CB8AC3E}">
-        <p14:creationId xmlns:p14="http://schemas.microsoft.com/office/powerpoint/2010/main" val="715391740"/>
+        <p14:creationId xmlns:p14="http://schemas.microsoft.com/office/powerpoint/2010/main" val="1935351993"/>
       </p:ext>
     </p:extLst>
   </p:cSld>
@@ -2394,7 +2479,7 @@
           <a:bodyPr/>
           <a:lstStyle/>
           <a:p>
-            <a:fld id="{39E91E94-9227-4269-937B-80A0D5D87A88}" type="slidenum">
+            <a:fld id="{54A143B8-B843-4E15-B9C0-488B5B777352}" type="slidenum">
               <a:rPr lang="en-US" smtClean="0"/>
               <a:t>8</a:t>
             </a:fld>
@@ -2405,7 +2490,7 @@
     </p:spTree>
     <p:extLst>
       <p:ext uri="{BB962C8B-B14F-4D97-AF65-F5344CB8AC3E}">
-        <p14:creationId xmlns:p14="http://schemas.microsoft.com/office/powerpoint/2010/main" val="818798279"/>
+        <p14:creationId xmlns:p14="http://schemas.microsoft.com/office/powerpoint/2010/main" val="2923853510"/>
       </p:ext>
     </p:extLst>
   </p:cSld>
@@ -2478,7 +2563,7 @@
           <a:bodyPr/>
           <a:lstStyle/>
           <a:p>
-            <a:fld id="{39E91E94-9227-4269-937B-80A0D5D87A88}" type="slidenum">
+            <a:fld id="{54A143B8-B843-4E15-B9C0-488B5B777352}" type="slidenum">
               <a:rPr lang="en-US" smtClean="0"/>
               <a:t>9</a:t>
             </a:fld>
@@ -2489,7 +2574,7 @@
     </p:spTree>
     <p:extLst>
       <p:ext uri="{BB962C8B-B14F-4D97-AF65-F5344CB8AC3E}">
-        <p14:creationId xmlns:p14="http://schemas.microsoft.com/office/powerpoint/2010/main" val="598568397"/>
+        <p14:creationId xmlns:p14="http://schemas.microsoft.com/office/powerpoint/2010/main" val="695265187"/>
       </p:ext>
     </p:extLst>
   </p:cSld>
@@ -2628,7 +2713,7 @@
           <a:bodyPr/>
           <a:lstStyle/>
           <a:p>
-            <a:fld id="{DF576A0F-B297-49EA-9A26-68F7C937C1F4}" type="datetimeFigureOut">
+            <a:fld id="{A97F56DE-5A2C-4080-93C8-1532081C3908}" type="datetimeFigureOut">
               <a:rPr lang="en-US" smtClean="0"/>
               <a:t>10/29/2026</a:t>
             </a:fld>
@@ -2670,7 +2755,7 @@
           <a:bodyPr/>
           <a:lstStyle/>
           <a:p>
-            <a:fld id="{2A7D25A6-F907-4F71-B230-A0943727CD78}" type="slidenum">
+            <a:fld id="{B5C9DD09-6691-41F4-A257-DA361A76118D}" type="slidenum">
               <a:rPr lang="en-US" smtClean="0"/>
               <a:t>‹#›</a:t>
             </a:fld>
@@ -2681,7 +2766,7 @@
     </p:spTree>
     <p:extLst>
       <p:ext uri="{BB962C8B-B14F-4D97-AF65-F5344CB8AC3E}">
-        <p14:creationId xmlns:p14="http://schemas.microsoft.com/office/powerpoint/2010/main" val="1096479138"/>
+        <p14:creationId xmlns:p14="http://schemas.microsoft.com/office/powerpoint/2010/main" val="2403617933"/>
       </p:ext>
     </p:extLst>
   </p:cSld>
@@ -2798,7 +2883,7 @@
           <a:bodyPr/>
           <a:lstStyle/>
           <a:p>
-            <a:fld id="{DF576A0F-B297-49EA-9A26-68F7C937C1F4}" type="datetimeFigureOut">
+            <a:fld id="{A97F56DE-5A2C-4080-93C8-1532081C3908}" type="datetimeFigureOut">
               <a:rPr lang="en-US" smtClean="0"/>
               <a:t>10/29/2026</a:t>
             </a:fld>
@@ -2840,7 +2925,7 @@
           <a:bodyPr/>
           <a:lstStyle/>
           <a:p>
-            <a:fld id="{2A7D25A6-F907-4F71-B230-A0943727CD78}" type="slidenum">
+            <a:fld id="{B5C9DD09-6691-41F4-A257-DA361A76118D}" type="slidenum">
               <a:rPr lang="en-US" smtClean="0"/>
               <a:t>‹#›</a:t>
             </a:fld>
@@ -2851,7 +2936,7 @@
     </p:spTree>
     <p:extLst>
       <p:ext uri="{BB962C8B-B14F-4D97-AF65-F5344CB8AC3E}">
-        <p14:creationId xmlns:p14="http://schemas.microsoft.com/office/powerpoint/2010/main" val="2448885096"/>
+        <p14:creationId xmlns:p14="http://schemas.microsoft.com/office/powerpoint/2010/main" val="2132969200"/>
       </p:ext>
     </p:extLst>
   </p:cSld>
@@ -2978,7 +3063,7 @@
           <a:bodyPr/>
           <a:lstStyle/>
           <a:p>
-            <a:fld id="{DF576A0F-B297-49EA-9A26-68F7C937C1F4}" type="datetimeFigureOut">
+            <a:fld id="{A97F56DE-5A2C-4080-93C8-1532081C3908}" type="datetimeFigureOut">
               <a:rPr lang="en-US" smtClean="0"/>
               <a:t>10/29/2026</a:t>
             </a:fld>
@@ -3020,7 +3105,7 @@
           <a:bodyPr/>
           <a:lstStyle/>
           <a:p>
-            <a:fld id="{2A7D25A6-F907-4F71-B230-A0943727CD78}" type="slidenum">
+            <a:fld id="{B5C9DD09-6691-41F4-A257-DA361A76118D}" type="slidenum">
               <a:rPr lang="en-US" smtClean="0"/>
               <a:t>‹#›</a:t>
             </a:fld>
@@ -3031,7 +3116,7 @@
     </p:spTree>
     <p:extLst>
       <p:ext uri="{BB962C8B-B14F-4D97-AF65-F5344CB8AC3E}">
-        <p14:creationId xmlns:p14="http://schemas.microsoft.com/office/powerpoint/2010/main" val="464436706"/>
+        <p14:creationId xmlns:p14="http://schemas.microsoft.com/office/powerpoint/2010/main" val="2484653764"/>
       </p:ext>
     </p:extLst>
   </p:cSld>
@@ -3148,7 +3233,7 @@
           <a:bodyPr/>
           <a:lstStyle/>
           <a:p>
-            <a:fld id="{DF576A0F-B297-49EA-9A26-68F7C937C1F4}" type="datetimeFigureOut">
+            <a:fld id="{A97F56DE-5A2C-4080-93C8-1532081C3908}" type="datetimeFigureOut">
               <a:rPr lang="en-US" smtClean="0"/>
               <a:t>10/29/2026</a:t>
             </a:fld>
@@ -3190,7 +3275,7 @@
           <a:bodyPr/>
           <a:lstStyle/>
           <a:p>
-            <a:fld id="{2A7D25A6-F907-4F71-B230-A0943727CD78}" type="slidenum">
+            <a:fld id="{B5C9DD09-6691-41F4-A257-DA361A76118D}" type="slidenum">
               <a:rPr lang="en-US" smtClean="0"/>
               <a:t>‹#›</a:t>
             </a:fld>
@@ -3201,7 +3286,7 @@
     </p:spTree>
     <p:extLst>
       <p:ext uri="{BB962C8B-B14F-4D97-AF65-F5344CB8AC3E}">
-        <p14:creationId xmlns:p14="http://schemas.microsoft.com/office/powerpoint/2010/main" val="1032933428"/>
+        <p14:creationId xmlns:p14="http://schemas.microsoft.com/office/powerpoint/2010/main" val="521625078"/>
       </p:ext>
     </p:extLst>
   </p:cSld>
@@ -3394,7 +3479,7 @@
           <a:bodyPr/>
           <a:lstStyle/>
           <a:p>
-            <a:fld id="{DF576A0F-B297-49EA-9A26-68F7C937C1F4}" type="datetimeFigureOut">
+            <a:fld id="{A97F56DE-5A2C-4080-93C8-1532081C3908}" type="datetimeFigureOut">
               <a:rPr lang="en-US" smtClean="0"/>
               <a:t>10/29/2026</a:t>
             </a:fld>
@@ -3436,7 +3521,7 @@
           <a:bodyPr/>
           <a:lstStyle/>
           <a:p>
-            <a:fld id="{2A7D25A6-F907-4F71-B230-A0943727CD78}" type="slidenum">
+            <a:fld id="{B5C9DD09-6691-41F4-A257-DA361A76118D}" type="slidenum">
               <a:rPr lang="en-US" smtClean="0"/>
               <a:t>‹#›</a:t>
             </a:fld>
@@ -3447,7 +3532,7 @@
     </p:spTree>
     <p:extLst>
       <p:ext uri="{BB962C8B-B14F-4D97-AF65-F5344CB8AC3E}">
-        <p14:creationId xmlns:p14="http://schemas.microsoft.com/office/powerpoint/2010/main" val="1039457174"/>
+        <p14:creationId xmlns:p14="http://schemas.microsoft.com/office/powerpoint/2010/main" val="3384609087"/>
       </p:ext>
     </p:extLst>
   </p:cSld>
@@ -3626,7 +3711,7 @@
           <a:bodyPr/>
           <a:lstStyle/>
           <a:p>
-            <a:fld id="{DF576A0F-B297-49EA-9A26-68F7C937C1F4}" type="datetimeFigureOut">
+            <a:fld id="{A97F56DE-5A2C-4080-93C8-1532081C3908}" type="datetimeFigureOut">
               <a:rPr lang="en-US" smtClean="0"/>
               <a:t>10/29/2026</a:t>
             </a:fld>
@@ -3668,7 +3753,7 @@
           <a:bodyPr/>
           <a:lstStyle/>
           <a:p>
-            <a:fld id="{2A7D25A6-F907-4F71-B230-A0943727CD78}" type="slidenum">
+            <a:fld id="{B5C9DD09-6691-41F4-A257-DA361A76118D}" type="slidenum">
               <a:rPr lang="en-US" smtClean="0"/>
               <a:t>‹#›</a:t>
             </a:fld>
@@ -3679,7 +3764,7 @@
     </p:spTree>
     <p:extLst>
       <p:ext uri="{BB962C8B-B14F-4D97-AF65-F5344CB8AC3E}">
-        <p14:creationId xmlns:p14="http://schemas.microsoft.com/office/powerpoint/2010/main" val="871475173"/>
+        <p14:creationId xmlns:p14="http://schemas.microsoft.com/office/powerpoint/2010/main" val="2176775965"/>
       </p:ext>
     </p:extLst>
   </p:cSld>
@@ -3993,7 +4078,7 @@
           <a:bodyPr/>
           <a:lstStyle/>
           <a:p>
-            <a:fld id="{DF576A0F-B297-49EA-9A26-68F7C937C1F4}" type="datetimeFigureOut">
+            <a:fld id="{A97F56DE-5A2C-4080-93C8-1532081C3908}" type="datetimeFigureOut">
               <a:rPr lang="en-US" smtClean="0"/>
               <a:t>10/29/2026</a:t>
             </a:fld>
@@ -4035,7 +4120,7 @@
           <a:bodyPr/>
           <a:lstStyle/>
           <a:p>
-            <a:fld id="{2A7D25A6-F907-4F71-B230-A0943727CD78}" type="slidenum">
+            <a:fld id="{B5C9DD09-6691-41F4-A257-DA361A76118D}" type="slidenum">
               <a:rPr lang="en-US" smtClean="0"/>
               <a:t>‹#›</a:t>
             </a:fld>
@@ -4046,7 +4131,7 @@
     </p:spTree>
     <p:extLst>
       <p:ext uri="{BB962C8B-B14F-4D97-AF65-F5344CB8AC3E}">
-        <p14:creationId xmlns:p14="http://schemas.microsoft.com/office/powerpoint/2010/main" val="2342612629"/>
+        <p14:creationId xmlns:p14="http://schemas.microsoft.com/office/powerpoint/2010/main" val="1445012908"/>
       </p:ext>
     </p:extLst>
   </p:cSld>
@@ -4111,7 +4196,7 @@
           <a:bodyPr/>
           <a:lstStyle/>
           <a:p>
-            <a:fld id="{DF576A0F-B297-49EA-9A26-68F7C937C1F4}" type="datetimeFigureOut">
+            <a:fld id="{A97F56DE-5A2C-4080-93C8-1532081C3908}" type="datetimeFigureOut">
               <a:rPr lang="en-US" smtClean="0"/>
               <a:t>10/29/2026</a:t>
             </a:fld>
@@ -4153,7 +4238,7 @@
           <a:bodyPr/>
           <a:lstStyle/>
           <a:p>
-            <a:fld id="{2A7D25A6-F907-4F71-B230-A0943727CD78}" type="slidenum">
+            <a:fld id="{B5C9DD09-6691-41F4-A257-DA361A76118D}" type="slidenum">
               <a:rPr lang="en-US" smtClean="0"/>
               <a:t>‹#›</a:t>
             </a:fld>
@@ -4164,7 +4249,7 @@
     </p:spTree>
     <p:extLst>
       <p:ext uri="{BB962C8B-B14F-4D97-AF65-F5344CB8AC3E}">
-        <p14:creationId xmlns:p14="http://schemas.microsoft.com/office/powerpoint/2010/main" val="1164170204"/>
+        <p14:creationId xmlns:p14="http://schemas.microsoft.com/office/powerpoint/2010/main" val="2261241327"/>
       </p:ext>
     </p:extLst>
   </p:cSld>
@@ -4206,7 +4291,7 @@
           <a:bodyPr/>
           <a:lstStyle/>
           <a:p>
-            <a:fld id="{DF576A0F-B297-49EA-9A26-68F7C937C1F4}" type="datetimeFigureOut">
+            <a:fld id="{A97F56DE-5A2C-4080-93C8-1532081C3908}" type="datetimeFigureOut">
               <a:rPr lang="en-US" smtClean="0"/>
               <a:t>10/29/2026</a:t>
             </a:fld>
@@ -4248,7 +4333,7 @@
           <a:bodyPr/>
           <a:lstStyle/>
           <a:p>
-            <a:fld id="{2A7D25A6-F907-4F71-B230-A0943727CD78}" type="slidenum">
+            <a:fld id="{B5C9DD09-6691-41F4-A257-DA361A76118D}" type="slidenum">
               <a:rPr lang="en-US" smtClean="0"/>
               <a:t>‹#›</a:t>
             </a:fld>
@@ -4259,7 +4344,7 @@
     </p:spTree>
     <p:extLst>
       <p:ext uri="{BB962C8B-B14F-4D97-AF65-F5344CB8AC3E}">
-        <p14:creationId xmlns:p14="http://schemas.microsoft.com/office/powerpoint/2010/main" val="1918931567"/>
+        <p14:creationId xmlns:p14="http://schemas.microsoft.com/office/powerpoint/2010/main" val="1214463488"/>
       </p:ext>
     </p:extLst>
   </p:cSld>
@@ -4483,7 +4568,7 @@
           <a:bodyPr/>
           <a:lstStyle/>
           <a:p>
-            <a:fld id="{DF576A0F-B297-49EA-9A26-68F7C937C1F4}" type="datetimeFigureOut">
+            <a:fld id="{A97F56DE-5A2C-4080-93C8-1532081C3908}" type="datetimeFigureOut">
               <a:rPr lang="en-US" smtClean="0"/>
               <a:t>10/29/2026</a:t>
             </a:fld>
@@ -4525,7 +4610,7 @@
           <a:bodyPr/>
           <a:lstStyle/>
           <a:p>
-            <a:fld id="{2A7D25A6-F907-4F71-B230-A0943727CD78}" type="slidenum">
+            <a:fld id="{B5C9DD09-6691-41F4-A257-DA361A76118D}" type="slidenum">
               <a:rPr lang="en-US" smtClean="0"/>
               <a:t>‹#›</a:t>
             </a:fld>
@@ -4536,7 +4621,7 @@
     </p:spTree>
     <p:extLst>
       <p:ext uri="{BB962C8B-B14F-4D97-AF65-F5344CB8AC3E}">
-        <p14:creationId xmlns:p14="http://schemas.microsoft.com/office/powerpoint/2010/main" val="1585973772"/>
+        <p14:creationId xmlns:p14="http://schemas.microsoft.com/office/powerpoint/2010/main" val="226514647"/>
       </p:ext>
     </p:extLst>
   </p:cSld>
@@ -4736,7 +4821,7 @@
           <a:bodyPr/>
           <a:lstStyle/>
           <a:p>
-            <a:fld id="{DF576A0F-B297-49EA-9A26-68F7C937C1F4}" type="datetimeFigureOut">
+            <a:fld id="{A97F56DE-5A2C-4080-93C8-1532081C3908}" type="datetimeFigureOut">
               <a:rPr lang="en-US" smtClean="0"/>
               <a:t>10/29/2026</a:t>
             </a:fld>
@@ -4778,7 +4863,7 @@
           <a:bodyPr/>
           <a:lstStyle/>
           <a:p>
-            <a:fld id="{2A7D25A6-F907-4F71-B230-A0943727CD78}" type="slidenum">
+            <a:fld id="{B5C9DD09-6691-41F4-A257-DA361A76118D}" type="slidenum">
               <a:rPr lang="en-US" smtClean="0"/>
               <a:t>‹#›</a:t>
             </a:fld>
@@ -4789,7 +4874,7 @@
     </p:spTree>
     <p:extLst>
       <p:ext uri="{BB962C8B-B14F-4D97-AF65-F5344CB8AC3E}">
-        <p14:creationId xmlns:p14="http://schemas.microsoft.com/office/powerpoint/2010/main" val="692165931"/>
+        <p14:creationId xmlns:p14="http://schemas.microsoft.com/office/powerpoint/2010/main" val="2009745960"/>
       </p:ext>
     </p:extLst>
   </p:cSld>
@@ -4949,7 +5034,7 @@
             </a:lvl1pPr>
           </a:lstStyle>
           <a:p>
-            <a:fld id="{DF576A0F-B297-49EA-9A26-68F7C937C1F4}" type="datetimeFigureOut">
+            <a:fld id="{A97F56DE-5A2C-4080-93C8-1532081C3908}" type="datetimeFigureOut">
               <a:rPr lang="en-US" smtClean="0"/>
               <a:t>10/29/2026</a:t>
             </a:fld>
@@ -5027,7 +5112,7 @@
             </a:lvl1pPr>
           </a:lstStyle>
           <a:p>
-            <a:fld id="{2A7D25A6-F907-4F71-B230-A0943727CD78}" type="slidenum">
+            <a:fld id="{B5C9DD09-6691-41F4-A257-DA361A76118D}" type="slidenum">
               <a:rPr lang="en-US" smtClean="0"/>
               <a:t>‹#›</a:t>
             </a:fld>
@@ -5038,7 +5123,7 @@
     </p:spTree>
     <p:extLst>
       <p:ext uri="{BB962C8B-B14F-4D97-AF65-F5344CB8AC3E}">
-        <p14:creationId xmlns:p14="http://schemas.microsoft.com/office/powerpoint/2010/main" val="3335129912"/>
+        <p14:creationId xmlns:p14="http://schemas.microsoft.com/office/powerpoint/2010/main" val="3777716397"/>
       </p:ext>
     </p:extLst>
   </p:cSld>
@@ -5608,7 +5693,7 @@
     </p:spTree>
     <p:extLst>
       <p:ext uri="{BB962C8B-B14F-4D97-AF65-F5344CB8AC3E}">
-        <p14:creationId xmlns:p14="http://schemas.microsoft.com/office/powerpoint/2010/main" val="486204109"/>
+        <p14:creationId xmlns:p14="http://schemas.microsoft.com/office/powerpoint/2010/main" val="1854495601"/>
       </p:ext>
     </p:extLst>
   </p:cSld>
@@ -5876,7 +5961,7 @@
     </p:spTree>
     <p:extLst>
       <p:ext uri="{BB962C8B-B14F-4D97-AF65-F5344CB8AC3E}">
-        <p14:creationId xmlns:p14="http://schemas.microsoft.com/office/powerpoint/2010/main" val="3298236615"/>
+        <p14:creationId xmlns:p14="http://schemas.microsoft.com/office/powerpoint/2010/main" val="2350092272"/>
       </p:ext>
     </p:extLst>
   </p:cSld>
@@ -6144,7 +6229,7 @@
     </p:spTree>
     <p:extLst>
       <p:ext uri="{BB962C8B-B14F-4D97-AF65-F5344CB8AC3E}">
-        <p14:creationId xmlns:p14="http://schemas.microsoft.com/office/powerpoint/2010/main" val="2294904085"/>
+        <p14:creationId xmlns:p14="http://schemas.microsoft.com/office/powerpoint/2010/main" val="2022938886"/>
       </p:ext>
     </p:extLst>
   </p:cSld>
@@ -6282,13 +6367,13 @@
           <a:lstStyle/>
           <a:p>
             <a:r>
-              <a:rPr lang="fr-FR" sz="1600" smtClean="0">
+              <a:rPr lang="en-US" sz="1600" smtClean="0">
                 <a:solidFill>
                   <a:srgbClr val="E1E1E1"/>
                 </a:solidFill>
                 <a:latin typeface="Segoe UI" panose="020B0502040204020203" pitchFamily="34" charset="0"/>
               </a:rPr>
-              <a:t>Build #4 réussi : tests, gate, package, Nexus, image Docker, déploiement kind et vérification HTTP.</a:t>
+              <a:t>Build #7 réussi : 38 tests, gate Sonar, Nexus, image publique Docker Hub, rollout Kubernetes et vérification HTTP.</a:t>
             </a:r>
             <a:endParaRPr lang="en-US" sz="1600">
               <a:solidFill>
@@ -6308,7 +6393,7 @@
           <p:nvPr/>
         </p:nvPicPr>
         <p:blipFill>
-          <a:blip r:embed="rId3" cstate="print">
+          <a:blip r:embed="rId3">
             <a:extLst>
               <a:ext uri="{28A0092B-C50C-407E-A947-70E740481C1C}">
                 <a14:useLocalDpi xmlns:a14="http://schemas.microsoft.com/office/drawing/2010/main" val="0"/>
@@ -6321,8 +6406,8 @@
         </p:blipFill>
         <p:spPr>
           <a:xfrm>
-            <a:off x="2687053" y="1981200"/>
-            <a:ext cx="6817895" cy="4318000"/>
+            <a:off x="381000" y="1981199"/>
+            <a:ext cx="11430000" cy="2669656"/>
           </a:xfrm>
           <a:prstGeom prst="rect">
             <a:avLst/>
@@ -6412,7 +6497,7 @@
     </p:spTree>
     <p:extLst>
       <p:ext uri="{BB962C8B-B14F-4D97-AF65-F5344CB8AC3E}">
-        <p14:creationId xmlns:p14="http://schemas.microsoft.com/office/powerpoint/2010/main" val="3054971862"/>
+        <p14:creationId xmlns:p14="http://schemas.microsoft.com/office/powerpoint/2010/main" val="2558004702"/>
       </p:ext>
     </p:extLst>
   </p:cSld>
@@ -6680,7 +6765,7 @@
     </p:spTree>
     <p:extLst>
       <p:ext uri="{BB962C8B-B14F-4D97-AF65-F5344CB8AC3E}">
-        <p14:creationId xmlns:p14="http://schemas.microsoft.com/office/powerpoint/2010/main" val="3282565928"/>
+        <p14:creationId xmlns:p14="http://schemas.microsoft.com/office/powerpoint/2010/main" val="2174639924"/>
       </p:ext>
     </p:extLst>
   </p:cSld>
@@ -6948,7 +7033,7 @@
     </p:spTree>
     <p:extLst>
       <p:ext uri="{BB962C8B-B14F-4D97-AF65-F5344CB8AC3E}">
-        <p14:creationId xmlns:p14="http://schemas.microsoft.com/office/powerpoint/2010/main" val="1171873359"/>
+        <p14:creationId xmlns:p14="http://schemas.microsoft.com/office/powerpoint/2010/main" val="2700795567"/>
       </p:ext>
     </p:extLst>
   </p:cSld>
@@ -7216,7 +7301,7 @@
     </p:spTree>
     <p:extLst>
       <p:ext uri="{BB962C8B-B14F-4D97-AF65-F5344CB8AC3E}">
-        <p14:creationId xmlns:p14="http://schemas.microsoft.com/office/powerpoint/2010/main" val="286608906"/>
+        <p14:creationId xmlns:p14="http://schemas.microsoft.com/office/powerpoint/2010/main" val="1998537452"/>
       </p:ext>
     </p:extLst>
   </p:cSld>
@@ -7484,7 +7569,7 @@
     </p:spTree>
     <p:extLst>
       <p:ext uri="{BB962C8B-B14F-4D97-AF65-F5344CB8AC3E}">
-        <p14:creationId xmlns:p14="http://schemas.microsoft.com/office/powerpoint/2010/main" val="3571019790"/>
+        <p14:creationId xmlns:p14="http://schemas.microsoft.com/office/powerpoint/2010/main" val="2469210390"/>
       </p:ext>
     </p:extLst>
   </p:cSld>
@@ -7588,7 +7673,7 @@
                 </a:solidFill>
                 <a:latin typeface="Segoe UI" panose="020B0502040204020203" pitchFamily="34" charset="0"/>
               </a:rPr>
-              <a:t>Un déploiement Kubernetes réel</a:t>
+              <a:t>Une image publique vérifiée</a:t>
             </a:r>
             <a:endParaRPr lang="en-US" sz="2800">
               <a:solidFill>
@@ -7628,7 +7713,7 @@
                 </a:solidFill>
                 <a:latin typeface="Segoe UI" panose="020B0502040204020203" pitchFamily="34" charset="0"/>
               </a:rPr>
-              <a:t>Pods applicatif et MySQL prêts, Services actifs et volume persistant lié.</a:t>
+              <a:t>ayyoub1/events-tache : manifeste linux/amd64 accessible sans compte et identique à l'image locale du build #7.</a:t>
             </a:r>
             <a:endParaRPr lang="en-US" sz="1600">
               <a:solidFill>
@@ -7661,8 +7746,8 @@
         </p:blipFill>
         <p:spPr>
           <a:xfrm>
-            <a:off x="1953054" y="1981200"/>
-            <a:ext cx="8285892" cy="4318000"/>
+            <a:off x="2032000" y="1981200"/>
+            <a:ext cx="8128000" cy="4318000"/>
           </a:xfrm>
           <a:prstGeom prst="rect">
             <a:avLst/>
@@ -7698,7 +7783,7 @@
                 </a:solidFill>
                 <a:latin typeface="Segoe UI" panose="020B0502040204020203" pitchFamily="34" charset="0"/>
               </a:rPr>
-              <a:t>Preuve : 10-kubernetes/kubernetes-resources.png</a:t>
+              <a:t>Preuve : 09-docker/dockerhub-repository.png</a:t>
             </a:r>
             <a:endParaRPr lang="en-US" sz="900">
               <a:solidFill>
@@ -7752,7 +7837,7 @@
     </p:spTree>
     <p:extLst>
       <p:ext uri="{BB962C8B-B14F-4D97-AF65-F5344CB8AC3E}">
-        <p14:creationId xmlns:p14="http://schemas.microsoft.com/office/powerpoint/2010/main" val="437395934"/>
+        <p14:creationId xmlns:p14="http://schemas.microsoft.com/office/powerpoint/2010/main" val="3103325397"/>
       </p:ext>
     </p:extLst>
   </p:cSld>
@@ -7856,7 +7941,7 @@
                 </a:solidFill>
                 <a:latin typeface="Segoe UI" panose="020B0502040204020203" pitchFamily="34" charset="0"/>
               </a:rPr>
-              <a:t>Vérifier le service métier</a:t>
+              <a:t>Un déploiement Kubernetes réel</a:t>
             </a:r>
             <a:endParaRPr lang="en-US" sz="2800">
               <a:solidFill>
@@ -7896,7 +7981,7 @@
                 </a:solidFill>
                 <a:latin typeface="Segoe UI" panose="020B0502040204020203" pitchFamily="34" charset="0"/>
               </a:rPr>
-              <a:t>Le cycle HTTP complet réussit via Kubernetes ; readiness inclut la base MySQL.</a:t>
+              <a:t>Pods applicatif et MySQL prêts, Services actifs et volume persistant lié.</a:t>
             </a:r>
             <a:endParaRPr lang="en-US" sz="1600">
               <a:solidFill>
@@ -7966,7 +8051,7 @@
                 </a:solidFill>
                 <a:latin typeface="Segoe UI" panose="020B0502040204020203" pitchFamily="34" charset="0"/>
               </a:rPr>
-              <a:t>Preuve : 10-kubernetes/kubernetes-api-success.png</a:t>
+              <a:t>Preuve : 10-kubernetes/kubernetes-resources.png</a:t>
             </a:r>
             <a:endParaRPr lang="en-US" sz="900">
               <a:solidFill>
@@ -8020,7 +8105,7 @@
     </p:spTree>
     <p:extLst>
       <p:ext uri="{BB962C8B-B14F-4D97-AF65-F5344CB8AC3E}">
-        <p14:creationId xmlns:p14="http://schemas.microsoft.com/office/powerpoint/2010/main" val="3582428800"/>
+        <p14:creationId xmlns:p14="http://schemas.microsoft.com/office/powerpoint/2010/main" val="872345913"/>
       </p:ext>
     </p:extLst>
   </p:cSld>
@@ -8124,7 +8209,7 @@
                 </a:solidFill>
                 <a:latin typeface="Segoe UI" panose="020B0502040204020203" pitchFamily="34" charset="0"/>
               </a:rPr>
-              <a:t>Provisionner avec Terraform</a:t>
+              <a:t>Vérifier le service métier</a:t>
             </a:r>
             <a:endParaRPr lang="en-US" sz="2800">
               <a:solidFill>
@@ -8164,7 +8249,7 @@
                 </a:solidFill>
                 <a:latin typeface="Segoe UI" panose="020B0502040204020203" pitchFamily="34" charset="0"/>
               </a:rPr>
-              <a:t>Plan examiné et approuvé : 6 ressources Prometheus créées, aucune destruction.</a:t>
+              <a:t>Le cycle HTTP complet réussit via Kubernetes ; readiness inclut la base MySQL.</a:t>
             </a:r>
             <a:endParaRPr lang="en-US" sz="1600">
               <a:solidFill>
@@ -8234,7 +8319,7 @@
                 </a:solidFill>
                 <a:latin typeface="Segoe UI" panose="020B0502040204020203" pitchFamily="34" charset="0"/>
               </a:rPr>
-              <a:t>Preuve : 11-terraform/terraform-apply.png</a:t>
+              <a:t>Preuve : 10-kubernetes/kubernetes-api-success.png</a:t>
             </a:r>
             <a:endParaRPr lang="en-US" sz="900">
               <a:solidFill>
@@ -8288,7 +8373,7 @@
     </p:spTree>
     <p:extLst>
       <p:ext uri="{BB962C8B-B14F-4D97-AF65-F5344CB8AC3E}">
-        <p14:creationId xmlns:p14="http://schemas.microsoft.com/office/powerpoint/2010/main" val="2784599714"/>
+        <p14:creationId xmlns:p14="http://schemas.microsoft.com/office/powerpoint/2010/main" val="1525154557"/>
       </p:ext>
     </p:extLst>
   </p:cSld>
@@ -8556,7 +8641,7 @@
     </p:spTree>
     <p:extLst>
       <p:ext uri="{BB962C8B-B14F-4D97-AF65-F5344CB8AC3E}">
-        <p14:creationId xmlns:p14="http://schemas.microsoft.com/office/powerpoint/2010/main" val="3835462484"/>
+        <p14:creationId xmlns:p14="http://schemas.microsoft.com/office/powerpoint/2010/main" val="562140930"/>
       </p:ext>
     </p:extLst>
   </p:cSld>
@@ -8660,7 +8745,7 @@
                 </a:solidFill>
                 <a:latin typeface="Segoe UI" panose="020B0502040204020203" pitchFamily="34" charset="0"/>
               </a:rPr>
-              <a:t>Contrôler la convergence</a:t>
+              <a:t>Provisionner avec Terraform</a:t>
             </a:r>
             <a:endParaRPr lang="en-US" sz="2800">
               <a:solidFill>
@@ -8700,7 +8785,7 @@
                 </a:solidFill>
                 <a:latin typeface="Segoe UI" panose="020B0502040204020203" pitchFamily="34" charset="0"/>
               </a:rPr>
-              <a:t>Un nouveau plan ne détecte aucune différence entre configuration et infrastructure.</a:t>
+              <a:t>Plan examiné et approuvé : 6 ressources Prometheus créées, aucune destruction.</a:t>
             </a:r>
             <a:endParaRPr lang="en-US" sz="1600">
               <a:solidFill>
@@ -8770,7 +8855,7 @@
                 </a:solidFill>
                 <a:latin typeface="Segoe UI" panose="020B0502040204020203" pitchFamily="34" charset="0"/>
               </a:rPr>
-              <a:t>Preuve : 11-terraform/terraform-no-drift.png</a:t>
+              <a:t>Preuve : 11-terraform/terraform-apply.png</a:t>
             </a:r>
             <a:endParaRPr lang="en-US" sz="900">
               <a:solidFill>
@@ -8824,7 +8909,7 @@
     </p:spTree>
     <p:extLst>
       <p:ext uri="{BB962C8B-B14F-4D97-AF65-F5344CB8AC3E}">
-        <p14:creationId xmlns:p14="http://schemas.microsoft.com/office/powerpoint/2010/main" val="3530141923"/>
+        <p14:creationId xmlns:p14="http://schemas.microsoft.com/office/powerpoint/2010/main" val="781084518"/>
       </p:ext>
     </p:extLst>
   </p:cSld>
@@ -8922,13 +9007,13 @@
           <a:lstStyle/>
           <a:p>
             <a:r>
-              <a:rPr lang="fr-FR" sz="2800" smtClean="0">
+              <a:rPr lang="en-US" sz="2800" smtClean="0">
                 <a:solidFill>
                   <a:srgbClr val="FFFFFF"/>
                 </a:solidFill>
                 <a:latin typeface="Segoe UI" panose="020B0502040204020203" pitchFamily="34" charset="0"/>
               </a:rPr>
-              <a:t>Observer une application réellement collectée</a:t>
+              <a:t>Contrôler la convergence</a:t>
             </a:r>
             <a:endParaRPr lang="en-US" sz="2800">
               <a:solidFill>
@@ -8968,7 +9053,7 @@
                 </a:solidFill>
                 <a:latin typeface="Segoe UI" panose="020B0502040204020203" pitchFamily="34" charset="0"/>
               </a:rPr>
-              <a:t>Prometheus collecte la cible Kubernetes events : 1/1 UP, métriques exposées par Actuator.</a:t>
+              <a:t>Un nouveau plan ne détecte aucune différence entre configuration et infrastructure.</a:t>
             </a:r>
             <a:endParaRPr lang="en-US" sz="1600">
               <a:solidFill>
@@ -9001,8 +9086,8 @@
         </p:blipFill>
         <p:spPr>
           <a:xfrm>
-            <a:off x="381000" y="1981199"/>
-            <a:ext cx="11430000" cy="3175000"/>
+            <a:off x="1953054" y="1981200"/>
+            <a:ext cx="8285892" cy="4318000"/>
           </a:xfrm>
           <a:prstGeom prst="rect">
             <a:avLst/>
@@ -9038,7 +9123,7 @@
                 </a:solidFill>
                 <a:latin typeface="Segoe UI" panose="020B0502040204020203" pitchFamily="34" charset="0"/>
               </a:rPr>
-              <a:t>Preuve : 13-monitoring/prometheus-targets.png</a:t>
+              <a:t>Preuve : 11-terraform/terraform-no-drift.png</a:t>
             </a:r>
             <a:endParaRPr lang="en-US" sz="900">
               <a:solidFill>
@@ -9092,7 +9177,7 @@
     </p:spTree>
     <p:extLst>
       <p:ext uri="{BB962C8B-B14F-4D97-AF65-F5344CB8AC3E}">
-        <p14:creationId xmlns:p14="http://schemas.microsoft.com/office/powerpoint/2010/main" val="271366284"/>
+        <p14:creationId xmlns:p14="http://schemas.microsoft.com/office/powerpoint/2010/main" val="3339712777"/>
       </p:ext>
     </p:extLst>
   </p:cSld>
@@ -9196,7 +9281,7 @@
                 </a:solidFill>
                 <a:latin typeface="Segoe UI" panose="020B0502040204020203" pitchFamily="34" charset="0"/>
               </a:rPr>
-              <a:t>Visualiser les métriques dans Grafana</a:t>
+              <a:t>Observer une application réellement collectée</a:t>
             </a:r>
             <a:endParaRPr lang="en-US" sz="2800">
               <a:solidFill>
@@ -9236,7 +9321,7 @@
                 </a:solidFill>
                 <a:latin typeface="Segoe UI" panose="020B0502040204020203" pitchFamily="34" charset="0"/>
               </a:rPr>
-              <a:t>Dashboard provisionné : cible UP, CPU Java, mémoire JVM et débit HTTP ; quatre requêtes réelles vérifiées.</a:t>
+              <a:t>Prometheus collecte la cible Kubernetes events : 1/1 UP, métriques exposées par Actuator.</a:t>
             </a:r>
             <a:endParaRPr lang="en-US" sz="1600">
               <a:solidFill>
@@ -9269,8 +9354,8 @@
         </p:blipFill>
         <p:spPr>
           <a:xfrm>
-            <a:off x="2641600" y="1981200"/>
-            <a:ext cx="6908800" cy="4318000"/>
+            <a:off x="381000" y="1981199"/>
+            <a:ext cx="11430000" cy="3175000"/>
           </a:xfrm>
           <a:prstGeom prst="rect">
             <a:avLst/>
@@ -9306,7 +9391,7 @@
                 </a:solidFill>
                 <a:latin typeface="Segoe UI" panose="020B0502040204020203" pitchFamily="34" charset="0"/>
               </a:rPr>
-              <a:t>Preuve : 13-monitoring/grafana-dashboard.png</a:t>
+              <a:t>Preuve : 13-monitoring/prometheus-targets.png</a:t>
             </a:r>
             <a:endParaRPr lang="en-US" sz="900">
               <a:solidFill>
@@ -9360,7 +9445,7 @@
     </p:spTree>
     <p:extLst>
       <p:ext uri="{BB962C8B-B14F-4D97-AF65-F5344CB8AC3E}">
-        <p14:creationId xmlns:p14="http://schemas.microsoft.com/office/powerpoint/2010/main" val="4022575795"/>
+        <p14:creationId xmlns:p14="http://schemas.microsoft.com/office/powerpoint/2010/main" val="3548522472"/>
       </p:ext>
     </p:extLst>
   </p:cSld>
@@ -9464,7 +9549,7 @@
                 </a:solidFill>
                 <a:latin typeface="Segoe UI" panose="020B0502040204020203" pitchFamily="34" charset="0"/>
               </a:rPr>
-              <a:t>Publier le livrable dans Nexus</a:t>
+              <a:t>Visualiser les métriques dans Grafana</a:t>
             </a:r>
             <a:endParaRPr lang="en-US" sz="2800">
               <a:solidFill>
@@ -9504,7 +9589,7 @@
                 </a:solidFill>
                 <a:latin typeface="Segoe UI" panose="020B0502040204020203" pitchFamily="34" charset="0"/>
               </a:rPr>
-              <a:t>Le dépôt Maven snapshots contient le JAR et le POM de tn.esprit:eventsProject:1.0.0-SNAPSHOT.</a:t>
+              <a:t>Dashboard provisionné : cible UP, CPU Java, mémoire JVM et débit HTTP ; quatre requêtes réelles vérifiées.</a:t>
             </a:r>
             <a:endParaRPr lang="en-US" sz="1600">
               <a:solidFill>
@@ -9537,8 +9622,8 @@
         </p:blipFill>
         <p:spPr>
           <a:xfrm>
-            <a:off x="1312985" y="1981200"/>
-            <a:ext cx="9566031" cy="4318000"/>
+            <a:off x="2641600" y="1981200"/>
+            <a:ext cx="6908800" cy="4318000"/>
           </a:xfrm>
           <a:prstGeom prst="rect">
             <a:avLst/>
@@ -9574,7 +9659,7 @@
                 </a:solidFill>
                 <a:latin typeface="Segoe UI" panose="020B0502040204020203" pitchFamily="34" charset="0"/>
               </a:rPr>
-              <a:t>Preuve : 07-nexus/nexus-repository.png</a:t>
+              <a:t>Preuve : 13-monitoring/grafana-dashboard.png</a:t>
             </a:r>
             <a:endParaRPr lang="en-US" sz="900">
               <a:solidFill>
@@ -9628,7 +9713,7 @@
     </p:spTree>
     <p:extLst>
       <p:ext uri="{BB962C8B-B14F-4D97-AF65-F5344CB8AC3E}">
-        <p14:creationId xmlns:p14="http://schemas.microsoft.com/office/powerpoint/2010/main" val="2779334075"/>
+        <p14:creationId xmlns:p14="http://schemas.microsoft.com/office/powerpoint/2010/main" val="2874069022"/>
       </p:ext>
     </p:extLst>
   </p:cSld>
@@ -9732,7 +9817,7 @@
                 </a:solidFill>
                 <a:latin typeface="Segoe UI" panose="020B0502040204020203" pitchFamily="34" charset="0"/>
               </a:rPr>
-              <a:t>Relier le build au programme exécuté</a:t>
+              <a:t>Publier le livrable dans Nexus</a:t>
             </a:r>
             <a:endParaRPr lang="en-US" sz="2800">
               <a:solidFill>
@@ -9772,7 +9857,7 @@
                 </a:solidFill>
                 <a:latin typeface="Segoe UI" panose="020B0502040204020203" pitchFamily="34" charset="0"/>
               </a:rPr>
-              <a:t>Même SHA-256 pour le JAR archivé par Jenkins, téléchargé de Nexus et présent dans le pod Kubernetes.</a:t>
+              <a:t>Le dépôt Maven snapshots contient le JAR et le POM de tn.esprit:eventsProject:1.0.0-SNAPSHOT.</a:t>
             </a:r>
             <a:endParaRPr lang="en-US" sz="1600">
               <a:solidFill>
@@ -9805,8 +9890,8 @@
         </p:blipFill>
         <p:spPr>
           <a:xfrm>
-            <a:off x="1953054" y="1981200"/>
-            <a:ext cx="8285892" cy="4318000"/>
+            <a:off x="1312985" y="1981200"/>
+            <a:ext cx="9566031" cy="4318000"/>
           </a:xfrm>
           <a:prstGeom prst="rect">
             <a:avLst/>
@@ -9842,7 +9927,7 @@
                 </a:solidFill>
                 <a:latin typeface="Segoe UI" panose="020B0502040204020203" pitchFamily="34" charset="0"/>
               </a:rPr>
-              <a:t>Preuve : 12-final-validation/local-delivery.png</a:t>
+              <a:t>Preuve : 07-nexus/nexus-repository.png</a:t>
             </a:r>
             <a:endParaRPr lang="en-US" sz="900">
               <a:solidFill>
@@ -9896,7 +9981,275 @@
     </p:spTree>
     <p:extLst>
       <p:ext uri="{BB962C8B-B14F-4D97-AF65-F5344CB8AC3E}">
-        <p14:creationId xmlns:p14="http://schemas.microsoft.com/office/powerpoint/2010/main" val="457852932"/>
+        <p14:creationId xmlns:p14="http://schemas.microsoft.com/office/powerpoint/2010/main" val="185298109"/>
+      </p:ext>
+    </p:extLst>
+  </p:cSld>
+  <p:clrMapOvr>
+    <a:masterClrMapping/>
+  </p:clrMapOvr>
+</p:sld>
+</file>
+
+<file path=ppt/slides/slide25.xml><?xml version="1.0" encoding="utf-8"?>
+<p:sld xmlns:a="http://schemas.openxmlformats.org/drawingml/2006/main" xmlns:r="http://schemas.openxmlformats.org/officeDocument/2006/relationships" xmlns:p="http://schemas.openxmlformats.org/presentationml/2006/main">
+  <p:cSld>
+    <p:bg>
+      <p:bgPr>
+        <a:solidFill>
+          <a:srgbClr val="0F272A"/>
+        </a:solidFill>
+        <a:effectLst/>
+      </p:bgPr>
+    </p:bg>
+    <p:spTree>
+      <p:nvGrpSpPr>
+        <p:cNvPr id="1" name=""/>
+        <p:cNvGrpSpPr/>
+        <p:nvPr/>
+      </p:nvGrpSpPr>
+      <p:grpSpPr>
+        <a:xfrm>
+          <a:off x="0" y="0"/>
+          <a:ext cx="0" cy="0"/>
+          <a:chOff x="0" y="0"/>
+          <a:chExt cx="0" cy="0"/>
+        </a:xfrm>
+      </p:grpSpPr>
+      <p:sp>
+        <p:nvSpPr>
+          <p:cNvPr id="2" name="TextBox 1"/>
+          <p:cNvSpPr txBox="1"/>
+          <p:nvPr/>
+        </p:nvSpPr>
+        <p:spPr>
+          <a:xfrm>
+            <a:off x="381000" y="152400"/>
+            <a:ext cx="10795000" cy="261610"/>
+          </a:xfrm>
+          <a:prstGeom prst="rect">
+            <a:avLst/>
+          </a:prstGeom>
+          <a:noFill/>
+        </p:spPr>
+        <p:txBody>
+          <a:bodyPr vert="horz" rtlCol="0">
+            <a:spAutoFit/>
+          </a:bodyPr>
+          <a:lstStyle/>
+          <a:p>
+            <a:r>
+              <a:rPr lang="en-US" sz="1100" smtClean="0">
+                <a:solidFill>
+                  <a:srgbClr val="5EEAD4"/>
+                </a:solidFill>
+                <a:latin typeface="Segoe UI" panose="020B0502040204020203" pitchFamily="34" charset="0"/>
+              </a:rPr>
+              <a:t>EVENTSPROJECT / MODULE TACHE</a:t>
+            </a:r>
+            <a:endParaRPr lang="en-US" sz="1100">
+              <a:solidFill>
+                <a:srgbClr val="5EEAD4"/>
+              </a:solidFill>
+              <a:latin typeface="Segoe UI" panose="020B0502040204020203" pitchFamily="34" charset="0"/>
+            </a:endParaRPr>
+          </a:p>
+        </p:txBody>
+      </p:sp>
+      <p:sp>
+        <p:nvSpPr>
+          <p:cNvPr id="3" name="TextBox 2"/>
+          <p:cNvSpPr txBox="1"/>
+          <p:nvPr/>
+        </p:nvSpPr>
+        <p:spPr>
+          <a:xfrm>
+            <a:off x="381000" y="533400"/>
+            <a:ext cx="11430000" cy="523220"/>
+          </a:xfrm>
+          <a:prstGeom prst="rect">
+            <a:avLst/>
+          </a:prstGeom>
+          <a:noFill/>
+        </p:spPr>
+        <p:txBody>
+          <a:bodyPr vert="horz" rtlCol="0">
+            <a:spAutoFit/>
+          </a:bodyPr>
+          <a:lstStyle/>
+          <a:p>
+            <a:r>
+              <a:rPr lang="fr-FR" sz="2800" smtClean="0">
+                <a:solidFill>
+                  <a:srgbClr val="FFFFFF"/>
+                </a:solidFill>
+                <a:latin typeface="Segoe UI" panose="020B0502040204020203" pitchFamily="34" charset="0"/>
+              </a:rPr>
+              <a:t>Relier le build au programme exécuté</a:t>
+            </a:r>
+            <a:endParaRPr lang="en-US" sz="2800">
+              <a:solidFill>
+                <a:srgbClr val="FFFFFF"/>
+              </a:solidFill>
+              <a:latin typeface="Segoe UI" panose="020B0502040204020203" pitchFamily="34" charset="0"/>
+            </a:endParaRPr>
+          </a:p>
+        </p:txBody>
+      </p:sp>
+      <p:sp>
+        <p:nvSpPr>
+          <p:cNvPr id="4" name="TextBox 3"/>
+          <p:cNvSpPr txBox="1"/>
+          <p:nvPr/>
+        </p:nvSpPr>
+        <p:spPr>
+          <a:xfrm>
+            <a:off x="381000" y="1244600"/>
+            <a:ext cx="11430000" cy="338554"/>
+          </a:xfrm>
+          <a:prstGeom prst="rect">
+            <a:avLst/>
+          </a:prstGeom>
+          <a:noFill/>
+        </p:spPr>
+        <p:txBody>
+          <a:bodyPr vert="horz" rtlCol="0">
+            <a:spAutoFit/>
+          </a:bodyPr>
+          <a:lstStyle/>
+          <a:p>
+            <a:r>
+              <a:rPr lang="fr-FR" sz="1600" smtClean="0">
+                <a:solidFill>
+                  <a:srgbClr val="E1E1E1"/>
+                </a:solidFill>
+                <a:latin typeface="Segoe UI" panose="020B0502040204020203" pitchFamily="34" charset="0"/>
+              </a:rPr>
+              <a:t>Même SHA-256 pour le JAR archivé par Jenkins, téléchargé de Nexus et présent dans le pod Kubernetes.</a:t>
+            </a:r>
+            <a:endParaRPr lang="en-US" sz="1600">
+              <a:solidFill>
+                <a:srgbClr val="E1E1E1"/>
+              </a:solidFill>
+              <a:latin typeface="Segoe UI" panose="020B0502040204020203" pitchFamily="34" charset="0"/>
+            </a:endParaRPr>
+          </a:p>
+        </p:txBody>
+      </p:sp>
+      <p:pic>
+        <p:nvPicPr>
+          <p:cNvPr id="5" name="Picture 4"/>
+          <p:cNvPicPr>
+            <a:picLocks noChangeAspect="1"/>
+          </p:cNvPicPr>
+          <p:nvPr/>
+        </p:nvPicPr>
+        <p:blipFill>
+          <a:blip r:embed="rId3">
+            <a:extLst>
+              <a:ext uri="{28A0092B-C50C-407E-A947-70E740481C1C}">
+                <a14:useLocalDpi xmlns:a14="http://schemas.microsoft.com/office/drawing/2010/main" val="0"/>
+              </a:ext>
+            </a:extLst>
+          </a:blip>
+          <a:stretch>
+            <a:fillRect/>
+          </a:stretch>
+        </p:blipFill>
+        <p:spPr>
+          <a:xfrm>
+            <a:off x="1953054" y="1981200"/>
+            <a:ext cx="8285892" cy="4318000"/>
+          </a:xfrm>
+          <a:prstGeom prst="rect">
+            <a:avLst/>
+          </a:prstGeom>
+        </p:spPr>
+      </p:pic>
+      <p:sp>
+        <p:nvSpPr>
+          <p:cNvPr id="6" name="TextBox 5"/>
+          <p:cNvSpPr txBox="1"/>
+          <p:nvPr/>
+        </p:nvSpPr>
+        <p:spPr>
+          <a:xfrm>
+            <a:off x="381000" y="6400800"/>
+            <a:ext cx="10795000" cy="230832"/>
+          </a:xfrm>
+          <a:prstGeom prst="rect">
+            <a:avLst/>
+          </a:prstGeom>
+          <a:noFill/>
+        </p:spPr>
+        <p:txBody>
+          <a:bodyPr vert="horz" rtlCol="0">
+            <a:spAutoFit/>
+          </a:bodyPr>
+          <a:lstStyle/>
+          <a:p>
+            <a:r>
+              <a:rPr lang="en-US" sz="900" smtClean="0">
+                <a:solidFill>
+                  <a:srgbClr val="5EEAD4"/>
+                </a:solidFill>
+                <a:latin typeface="Segoe UI" panose="020B0502040204020203" pitchFamily="34" charset="0"/>
+              </a:rPr>
+              <a:t>Preuve : 12-final-validation/local-delivery.png</a:t>
+            </a:r>
+            <a:endParaRPr lang="en-US" sz="900">
+              <a:solidFill>
+                <a:srgbClr val="5EEAD4"/>
+              </a:solidFill>
+              <a:latin typeface="Segoe UI" panose="020B0502040204020203" pitchFamily="34" charset="0"/>
+            </a:endParaRPr>
+          </a:p>
+        </p:txBody>
+      </p:sp>
+      <p:sp>
+        <p:nvSpPr>
+          <p:cNvPr id="7" name="TextBox 6"/>
+          <p:cNvSpPr txBox="1"/>
+          <p:nvPr/>
+        </p:nvSpPr>
+        <p:spPr>
+          <a:xfrm>
+            <a:off x="11582400" y="6438900"/>
+            <a:ext cx="381000" cy="246221"/>
+          </a:xfrm>
+          <a:prstGeom prst="rect">
+            <a:avLst/>
+          </a:prstGeom>
+          <a:noFill/>
+        </p:spPr>
+        <p:txBody>
+          <a:bodyPr vert="horz" rtlCol="0">
+            <a:spAutoFit/>
+          </a:bodyPr>
+          <a:lstStyle/>
+          <a:p>
+            <a:r>
+              <a:rPr lang="en-US" sz="1000" smtClean="0">
+                <a:solidFill>
+                  <a:srgbClr val="E1E1E1"/>
+                </a:solidFill>
+                <a:latin typeface="Segoe UI" panose="020B0502040204020203" pitchFamily="34" charset="0"/>
+              </a:rPr>
+              <a:t>25</a:t>
+            </a:r>
+            <a:endParaRPr lang="en-US" sz="1000">
+              <a:solidFill>
+                <a:srgbClr val="E1E1E1"/>
+              </a:solidFill>
+              <a:latin typeface="Segoe UI" panose="020B0502040204020203" pitchFamily="34" charset="0"/>
+            </a:endParaRPr>
+          </a:p>
+        </p:txBody>
+      </p:sp>
+    </p:spTree>
+    <p:extLst>
+      <p:ext uri="{BB962C8B-B14F-4D97-AF65-F5344CB8AC3E}">
+        <p14:creationId xmlns:p14="http://schemas.microsoft.com/office/powerpoint/2010/main" val="3301167379"/>
       </p:ext>
     </p:extLst>
   </p:cSld>
@@ -10164,7 +10517,7 @@
     </p:spTree>
     <p:extLst>
       <p:ext uri="{BB962C8B-B14F-4D97-AF65-F5344CB8AC3E}">
-        <p14:creationId xmlns:p14="http://schemas.microsoft.com/office/powerpoint/2010/main" val="4253480446"/>
+        <p14:creationId xmlns:p14="http://schemas.microsoft.com/office/powerpoint/2010/main" val="1625641272"/>
       </p:ext>
     </p:extLst>
   </p:cSld>
@@ -10432,7 +10785,7 @@
     </p:spTree>
     <p:extLst>
       <p:ext uri="{BB962C8B-B14F-4D97-AF65-F5344CB8AC3E}">
-        <p14:creationId xmlns:p14="http://schemas.microsoft.com/office/powerpoint/2010/main" val="2195156587"/>
+        <p14:creationId xmlns:p14="http://schemas.microsoft.com/office/powerpoint/2010/main" val="3647241306"/>
       </p:ext>
     </p:extLst>
   </p:cSld>
@@ -10700,7 +11053,7 @@
     </p:spTree>
     <p:extLst>
       <p:ext uri="{BB962C8B-B14F-4D97-AF65-F5344CB8AC3E}">
-        <p14:creationId xmlns:p14="http://schemas.microsoft.com/office/powerpoint/2010/main" val="3292979624"/>
+        <p14:creationId xmlns:p14="http://schemas.microsoft.com/office/powerpoint/2010/main" val="2332772252"/>
       </p:ext>
     </p:extLst>
   </p:cSld>
@@ -10968,7 +11321,7 @@
     </p:spTree>
     <p:extLst>
       <p:ext uri="{BB962C8B-B14F-4D97-AF65-F5344CB8AC3E}">
-        <p14:creationId xmlns:p14="http://schemas.microsoft.com/office/powerpoint/2010/main" val="2248988109"/>
+        <p14:creationId xmlns:p14="http://schemas.microsoft.com/office/powerpoint/2010/main" val="3548370010"/>
       </p:ext>
     </p:extLst>
   </p:cSld>
@@ -11236,7 +11589,7 @@
     </p:spTree>
     <p:extLst>
       <p:ext uri="{BB962C8B-B14F-4D97-AF65-F5344CB8AC3E}">
-        <p14:creationId xmlns:p14="http://schemas.microsoft.com/office/powerpoint/2010/main" val="3456391981"/>
+        <p14:creationId xmlns:p14="http://schemas.microsoft.com/office/powerpoint/2010/main" val="2992952893"/>
       </p:ext>
     </p:extLst>
   </p:cSld>
@@ -11504,7 +11857,7 @@
     </p:spTree>
     <p:extLst>
       <p:ext uri="{BB962C8B-B14F-4D97-AF65-F5344CB8AC3E}">
-        <p14:creationId xmlns:p14="http://schemas.microsoft.com/office/powerpoint/2010/main" val="1422515335"/>
+        <p14:creationId xmlns:p14="http://schemas.microsoft.com/office/powerpoint/2010/main" val="3683255033"/>
       </p:ext>
     </p:extLst>
   </p:cSld>
@@ -11772,7 +12125,7 @@
     </p:spTree>
     <p:extLst>
       <p:ext uri="{BB962C8B-B14F-4D97-AF65-F5344CB8AC3E}">
-        <p14:creationId xmlns:p14="http://schemas.microsoft.com/office/powerpoint/2010/main" val="3118104429"/>
+        <p14:creationId xmlns:p14="http://schemas.microsoft.com/office/powerpoint/2010/main" val="3126871190"/>
       </p:ext>
     </p:extLst>
   </p:cSld>

</xml_diff>

<commit_message>
docs: record verified origin synchronization in the final presentation
</commit_message>
<xml_diff>
--- a/docs/presentation/eventsProject-Tache.pptx
+++ b/docs/presentation/eventsProject-Tache.pptx
@@ -214,7 +214,7 @@
             </a:lvl1pPr>
           </a:lstStyle>
           <a:p>
-            <a:fld id="{AD5BF8BE-CB2F-4A6E-BF13-290BAA044677}" type="datetimeFigureOut">
+            <a:fld id="{62F84A56-BBF5-49C7-8E2B-65646EFB9094}" type="datetimeFigureOut">
               <a:rPr lang="en-US" smtClean="0"/>
               <a:t>10/29/2026</a:t>
             </a:fld>
@@ -373,7 +373,7 @@
             </a:lvl1pPr>
           </a:lstStyle>
           <a:p>
-            <a:fld id="{54A143B8-B843-4E15-B9C0-488B5B777352}" type="slidenum">
+            <a:fld id="{D520FC40-E2A0-4524-A6FA-65C04552349B}" type="slidenum">
               <a:rPr lang="en-US" smtClean="0"/>
               <a:t>‹#›</a:t>
             </a:fld>
@@ -384,7 +384,7 @@
     </p:spTree>
     <p:extLst>
       <p:ext uri="{BB962C8B-B14F-4D97-AF65-F5344CB8AC3E}">
-        <p14:creationId xmlns:p14="http://schemas.microsoft.com/office/powerpoint/2010/main" val="3085472980"/>
+        <p14:creationId xmlns:p14="http://schemas.microsoft.com/office/powerpoint/2010/main" val="266775585"/>
       </p:ext>
     </p:extLst>
   </p:cSld>
@@ -547,7 +547,7 @@
           <a:bodyPr/>
           <a:lstStyle/>
           <a:p>
-            <a:fld id="{54A143B8-B843-4E15-B9C0-488B5B777352}" type="slidenum">
+            <a:fld id="{D520FC40-E2A0-4524-A6FA-65C04552349B}" type="slidenum">
               <a:rPr lang="en-US" smtClean="0"/>
               <a:t>1</a:t>
             </a:fld>
@@ -558,7 +558,7 @@
     </p:spTree>
     <p:extLst>
       <p:ext uri="{BB962C8B-B14F-4D97-AF65-F5344CB8AC3E}">
-        <p14:creationId xmlns:p14="http://schemas.microsoft.com/office/powerpoint/2010/main" val="2870680616"/>
+        <p14:creationId xmlns:p14="http://schemas.microsoft.com/office/powerpoint/2010/main" val="1814069089"/>
       </p:ext>
     </p:extLst>
   </p:cSld>
@@ -631,7 +631,7 @@
           <a:bodyPr/>
           <a:lstStyle/>
           <a:p>
-            <a:fld id="{54A143B8-B843-4E15-B9C0-488B5B777352}" type="slidenum">
+            <a:fld id="{D520FC40-E2A0-4524-A6FA-65C04552349B}" type="slidenum">
               <a:rPr lang="en-US" smtClean="0"/>
               <a:t>10</a:t>
             </a:fld>
@@ -642,7 +642,7 @@
     </p:spTree>
     <p:extLst>
       <p:ext uri="{BB962C8B-B14F-4D97-AF65-F5344CB8AC3E}">
-        <p14:creationId xmlns:p14="http://schemas.microsoft.com/office/powerpoint/2010/main" val="799473095"/>
+        <p14:creationId xmlns:p14="http://schemas.microsoft.com/office/powerpoint/2010/main" val="2226977172"/>
       </p:ext>
     </p:extLst>
   </p:cSld>
@@ -715,7 +715,7 @@
           <a:bodyPr/>
           <a:lstStyle/>
           <a:p>
-            <a:fld id="{54A143B8-B843-4E15-B9C0-488B5B777352}" type="slidenum">
+            <a:fld id="{D520FC40-E2A0-4524-A6FA-65C04552349B}" type="slidenum">
               <a:rPr lang="en-US" smtClean="0"/>
               <a:t>11</a:t>
             </a:fld>
@@ -726,7 +726,7 @@
     </p:spTree>
     <p:extLst>
       <p:ext uri="{BB962C8B-B14F-4D97-AF65-F5344CB8AC3E}">
-        <p14:creationId xmlns:p14="http://schemas.microsoft.com/office/powerpoint/2010/main" val="1646165105"/>
+        <p14:creationId xmlns:p14="http://schemas.microsoft.com/office/powerpoint/2010/main" val="446321155"/>
       </p:ext>
     </p:extLst>
   </p:cSld>
@@ -799,7 +799,7 @@
           <a:bodyPr/>
           <a:lstStyle/>
           <a:p>
-            <a:fld id="{54A143B8-B843-4E15-B9C0-488B5B777352}" type="slidenum">
+            <a:fld id="{D520FC40-E2A0-4524-A6FA-65C04552349B}" type="slidenum">
               <a:rPr lang="en-US" smtClean="0"/>
               <a:t>12</a:t>
             </a:fld>
@@ -810,7 +810,7 @@
     </p:spTree>
     <p:extLst>
       <p:ext uri="{BB962C8B-B14F-4D97-AF65-F5344CB8AC3E}">
-        <p14:creationId xmlns:p14="http://schemas.microsoft.com/office/powerpoint/2010/main" val="1238696553"/>
+        <p14:creationId xmlns:p14="http://schemas.microsoft.com/office/powerpoint/2010/main" val="2563072017"/>
       </p:ext>
     </p:extLst>
   </p:cSld>
@@ -883,7 +883,7 @@
           <a:bodyPr/>
           <a:lstStyle/>
           <a:p>
-            <a:fld id="{54A143B8-B843-4E15-B9C0-488B5B777352}" type="slidenum">
+            <a:fld id="{D520FC40-E2A0-4524-A6FA-65C04552349B}" type="slidenum">
               <a:rPr lang="en-US" smtClean="0"/>
               <a:t>13</a:t>
             </a:fld>
@@ -894,7 +894,7 @@
     </p:spTree>
     <p:extLst>
       <p:ext uri="{BB962C8B-B14F-4D97-AF65-F5344CB8AC3E}">
-        <p14:creationId xmlns:p14="http://schemas.microsoft.com/office/powerpoint/2010/main" val="934135721"/>
+        <p14:creationId xmlns:p14="http://schemas.microsoft.com/office/powerpoint/2010/main" val="2354814756"/>
       </p:ext>
     </p:extLst>
   </p:cSld>
@@ -967,7 +967,7 @@
           <a:bodyPr/>
           <a:lstStyle/>
           <a:p>
-            <a:fld id="{54A143B8-B843-4E15-B9C0-488B5B777352}" type="slidenum">
+            <a:fld id="{D520FC40-E2A0-4524-A6FA-65C04552349B}" type="slidenum">
               <a:rPr lang="en-US" smtClean="0"/>
               <a:t>14</a:t>
             </a:fld>
@@ -978,7 +978,7 @@
     </p:spTree>
     <p:extLst>
       <p:ext uri="{BB962C8B-B14F-4D97-AF65-F5344CB8AC3E}">
-        <p14:creationId xmlns:p14="http://schemas.microsoft.com/office/powerpoint/2010/main" val="613009976"/>
+        <p14:creationId xmlns:p14="http://schemas.microsoft.com/office/powerpoint/2010/main" val="3020696672"/>
       </p:ext>
     </p:extLst>
   </p:cSld>
@@ -1051,7 +1051,7 @@
           <a:bodyPr/>
           <a:lstStyle/>
           <a:p>
-            <a:fld id="{54A143B8-B843-4E15-B9C0-488B5B777352}" type="slidenum">
+            <a:fld id="{D520FC40-E2A0-4524-A6FA-65C04552349B}" type="slidenum">
               <a:rPr lang="en-US" smtClean="0"/>
               <a:t>15</a:t>
             </a:fld>
@@ -1062,7 +1062,7 @@
     </p:spTree>
     <p:extLst>
       <p:ext uri="{BB962C8B-B14F-4D97-AF65-F5344CB8AC3E}">
-        <p14:creationId xmlns:p14="http://schemas.microsoft.com/office/powerpoint/2010/main" val="1111509946"/>
+        <p14:creationId xmlns:p14="http://schemas.microsoft.com/office/powerpoint/2010/main" val="617930352"/>
       </p:ext>
     </p:extLst>
   </p:cSld>
@@ -1135,7 +1135,7 @@
           <a:bodyPr/>
           <a:lstStyle/>
           <a:p>
-            <a:fld id="{54A143B8-B843-4E15-B9C0-488B5B777352}" type="slidenum">
+            <a:fld id="{D520FC40-E2A0-4524-A6FA-65C04552349B}" type="slidenum">
               <a:rPr lang="en-US" smtClean="0"/>
               <a:t>16</a:t>
             </a:fld>
@@ -1146,7 +1146,7 @@
     </p:spTree>
     <p:extLst>
       <p:ext uri="{BB962C8B-B14F-4D97-AF65-F5344CB8AC3E}">
-        <p14:creationId xmlns:p14="http://schemas.microsoft.com/office/powerpoint/2010/main" val="3149397995"/>
+        <p14:creationId xmlns:p14="http://schemas.microsoft.com/office/powerpoint/2010/main" val="3982976306"/>
       </p:ext>
     </p:extLst>
   </p:cSld>
@@ -1219,7 +1219,7 @@
           <a:bodyPr/>
           <a:lstStyle/>
           <a:p>
-            <a:fld id="{54A143B8-B843-4E15-B9C0-488B5B777352}" type="slidenum">
+            <a:fld id="{D520FC40-E2A0-4524-A6FA-65C04552349B}" type="slidenum">
               <a:rPr lang="en-US" smtClean="0"/>
               <a:t>17</a:t>
             </a:fld>
@@ -1230,7 +1230,7 @@
     </p:spTree>
     <p:extLst>
       <p:ext uri="{BB962C8B-B14F-4D97-AF65-F5344CB8AC3E}">
-        <p14:creationId xmlns:p14="http://schemas.microsoft.com/office/powerpoint/2010/main" val="2360377795"/>
+        <p14:creationId xmlns:p14="http://schemas.microsoft.com/office/powerpoint/2010/main" val="376902212"/>
       </p:ext>
     </p:extLst>
   </p:cSld>
@@ -1303,7 +1303,7 @@
           <a:bodyPr/>
           <a:lstStyle/>
           <a:p>
-            <a:fld id="{54A143B8-B843-4E15-B9C0-488B5B777352}" type="slidenum">
+            <a:fld id="{D520FC40-E2A0-4524-A6FA-65C04552349B}" type="slidenum">
               <a:rPr lang="en-US" smtClean="0"/>
               <a:t>18</a:t>
             </a:fld>
@@ -1314,7 +1314,7 @@
     </p:spTree>
     <p:extLst>
       <p:ext uri="{BB962C8B-B14F-4D97-AF65-F5344CB8AC3E}">
-        <p14:creationId xmlns:p14="http://schemas.microsoft.com/office/powerpoint/2010/main" val="2004483061"/>
+        <p14:creationId xmlns:p14="http://schemas.microsoft.com/office/powerpoint/2010/main" val="38025921"/>
       </p:ext>
     </p:extLst>
   </p:cSld>
@@ -1387,7 +1387,7 @@
           <a:bodyPr/>
           <a:lstStyle/>
           <a:p>
-            <a:fld id="{54A143B8-B843-4E15-B9C0-488B5B777352}" type="slidenum">
+            <a:fld id="{D520FC40-E2A0-4524-A6FA-65C04552349B}" type="slidenum">
               <a:rPr lang="en-US" smtClean="0"/>
               <a:t>19</a:t>
             </a:fld>
@@ -1398,7 +1398,7 @@
     </p:spTree>
     <p:extLst>
       <p:ext uri="{BB962C8B-B14F-4D97-AF65-F5344CB8AC3E}">
-        <p14:creationId xmlns:p14="http://schemas.microsoft.com/office/powerpoint/2010/main" val="3404336856"/>
+        <p14:creationId xmlns:p14="http://schemas.microsoft.com/office/powerpoint/2010/main" val="1564102977"/>
       </p:ext>
     </p:extLst>
   </p:cSld>
@@ -1471,7 +1471,7 @@
           <a:bodyPr/>
           <a:lstStyle/>
           <a:p>
-            <a:fld id="{54A143B8-B843-4E15-B9C0-488B5B777352}" type="slidenum">
+            <a:fld id="{D520FC40-E2A0-4524-A6FA-65C04552349B}" type="slidenum">
               <a:rPr lang="en-US" smtClean="0"/>
               <a:t>2</a:t>
             </a:fld>
@@ -1482,7 +1482,7 @@
     </p:spTree>
     <p:extLst>
       <p:ext uri="{BB962C8B-B14F-4D97-AF65-F5344CB8AC3E}">
-        <p14:creationId xmlns:p14="http://schemas.microsoft.com/office/powerpoint/2010/main" val="1674566991"/>
+        <p14:creationId xmlns:p14="http://schemas.microsoft.com/office/powerpoint/2010/main" val="2487008741"/>
       </p:ext>
     </p:extLst>
   </p:cSld>
@@ -1555,7 +1555,7 @@
           <a:bodyPr/>
           <a:lstStyle/>
           <a:p>
-            <a:fld id="{54A143B8-B843-4E15-B9C0-488B5B777352}" type="slidenum">
+            <a:fld id="{D520FC40-E2A0-4524-A6FA-65C04552349B}" type="slidenum">
               <a:rPr lang="en-US" smtClean="0"/>
               <a:t>20</a:t>
             </a:fld>
@@ -1566,7 +1566,7 @@
     </p:spTree>
     <p:extLst>
       <p:ext uri="{BB962C8B-B14F-4D97-AF65-F5344CB8AC3E}">
-        <p14:creationId xmlns:p14="http://schemas.microsoft.com/office/powerpoint/2010/main" val="690551839"/>
+        <p14:creationId xmlns:p14="http://schemas.microsoft.com/office/powerpoint/2010/main" val="280019860"/>
       </p:ext>
     </p:extLst>
   </p:cSld>
@@ -1639,7 +1639,7 @@
           <a:bodyPr/>
           <a:lstStyle/>
           <a:p>
-            <a:fld id="{54A143B8-B843-4E15-B9C0-488B5B777352}" type="slidenum">
+            <a:fld id="{D520FC40-E2A0-4524-A6FA-65C04552349B}" type="slidenum">
               <a:rPr lang="en-US" smtClean="0"/>
               <a:t>21</a:t>
             </a:fld>
@@ -1650,7 +1650,7 @@
     </p:spTree>
     <p:extLst>
       <p:ext uri="{BB962C8B-B14F-4D97-AF65-F5344CB8AC3E}">
-        <p14:creationId xmlns:p14="http://schemas.microsoft.com/office/powerpoint/2010/main" val="104340086"/>
+        <p14:creationId xmlns:p14="http://schemas.microsoft.com/office/powerpoint/2010/main" val="1930475915"/>
       </p:ext>
     </p:extLst>
   </p:cSld>
@@ -1723,7 +1723,7 @@
           <a:bodyPr/>
           <a:lstStyle/>
           <a:p>
-            <a:fld id="{54A143B8-B843-4E15-B9C0-488B5B777352}" type="slidenum">
+            <a:fld id="{D520FC40-E2A0-4524-A6FA-65C04552349B}" type="slidenum">
               <a:rPr lang="en-US" smtClean="0"/>
               <a:t>22</a:t>
             </a:fld>
@@ -1734,7 +1734,7 @@
     </p:spTree>
     <p:extLst>
       <p:ext uri="{BB962C8B-B14F-4D97-AF65-F5344CB8AC3E}">
-        <p14:creationId xmlns:p14="http://schemas.microsoft.com/office/powerpoint/2010/main" val="4160987656"/>
+        <p14:creationId xmlns:p14="http://schemas.microsoft.com/office/powerpoint/2010/main" val="893786975"/>
       </p:ext>
     </p:extLst>
   </p:cSld>
@@ -1807,7 +1807,7 @@
           <a:bodyPr/>
           <a:lstStyle/>
           <a:p>
-            <a:fld id="{54A143B8-B843-4E15-B9C0-488B5B777352}" type="slidenum">
+            <a:fld id="{D520FC40-E2A0-4524-A6FA-65C04552349B}" type="slidenum">
               <a:rPr lang="en-US" smtClean="0"/>
               <a:t>23</a:t>
             </a:fld>
@@ -1818,7 +1818,7 @@
     </p:spTree>
     <p:extLst>
       <p:ext uri="{BB962C8B-B14F-4D97-AF65-F5344CB8AC3E}">
-        <p14:creationId xmlns:p14="http://schemas.microsoft.com/office/powerpoint/2010/main" val="4145832586"/>
+        <p14:creationId xmlns:p14="http://schemas.microsoft.com/office/powerpoint/2010/main" val="484354662"/>
       </p:ext>
     </p:extLst>
   </p:cSld>
@@ -1891,7 +1891,7 @@
           <a:bodyPr/>
           <a:lstStyle/>
           <a:p>
-            <a:fld id="{54A143B8-B843-4E15-B9C0-488B5B777352}" type="slidenum">
+            <a:fld id="{D520FC40-E2A0-4524-A6FA-65C04552349B}" type="slidenum">
               <a:rPr lang="en-US" smtClean="0"/>
               <a:t>24</a:t>
             </a:fld>
@@ -1902,7 +1902,7 @@
     </p:spTree>
     <p:extLst>
       <p:ext uri="{BB962C8B-B14F-4D97-AF65-F5344CB8AC3E}">
-        <p14:creationId xmlns:p14="http://schemas.microsoft.com/office/powerpoint/2010/main" val="456404152"/>
+        <p14:creationId xmlns:p14="http://schemas.microsoft.com/office/powerpoint/2010/main" val="3562535636"/>
       </p:ext>
     </p:extLst>
   </p:cSld>
@@ -1975,7 +1975,7 @@
           <a:bodyPr/>
           <a:lstStyle/>
           <a:p>
-            <a:fld id="{54A143B8-B843-4E15-B9C0-488B5B777352}" type="slidenum">
+            <a:fld id="{D520FC40-E2A0-4524-A6FA-65C04552349B}" type="slidenum">
               <a:rPr lang="en-US" smtClean="0"/>
               <a:t>25</a:t>
             </a:fld>
@@ -1986,7 +1986,7 @@
     </p:spTree>
     <p:extLst>
       <p:ext uri="{BB962C8B-B14F-4D97-AF65-F5344CB8AC3E}">
-        <p14:creationId xmlns:p14="http://schemas.microsoft.com/office/powerpoint/2010/main" val="1681073096"/>
+        <p14:creationId xmlns:p14="http://schemas.microsoft.com/office/powerpoint/2010/main" val="930866795"/>
       </p:ext>
     </p:extLst>
   </p:cSld>
@@ -2059,7 +2059,7 @@
           <a:bodyPr/>
           <a:lstStyle/>
           <a:p>
-            <a:fld id="{54A143B8-B843-4E15-B9C0-488B5B777352}" type="slidenum">
+            <a:fld id="{D520FC40-E2A0-4524-A6FA-65C04552349B}" type="slidenum">
               <a:rPr lang="en-US" smtClean="0"/>
               <a:t>3</a:t>
             </a:fld>
@@ -2070,7 +2070,7 @@
     </p:spTree>
     <p:extLst>
       <p:ext uri="{BB962C8B-B14F-4D97-AF65-F5344CB8AC3E}">
-        <p14:creationId xmlns:p14="http://schemas.microsoft.com/office/powerpoint/2010/main" val="2448627530"/>
+        <p14:creationId xmlns:p14="http://schemas.microsoft.com/office/powerpoint/2010/main" val="2921588795"/>
       </p:ext>
     </p:extLst>
   </p:cSld>
@@ -2143,7 +2143,7 @@
           <a:bodyPr/>
           <a:lstStyle/>
           <a:p>
-            <a:fld id="{54A143B8-B843-4E15-B9C0-488B5B777352}" type="slidenum">
+            <a:fld id="{D520FC40-E2A0-4524-A6FA-65C04552349B}" type="slidenum">
               <a:rPr lang="en-US" smtClean="0"/>
               <a:t>4</a:t>
             </a:fld>
@@ -2154,7 +2154,7 @@
     </p:spTree>
     <p:extLst>
       <p:ext uri="{BB962C8B-B14F-4D97-AF65-F5344CB8AC3E}">
-        <p14:creationId xmlns:p14="http://schemas.microsoft.com/office/powerpoint/2010/main" val="1347673264"/>
+        <p14:creationId xmlns:p14="http://schemas.microsoft.com/office/powerpoint/2010/main" val="2815592021"/>
       </p:ext>
     </p:extLst>
   </p:cSld>
@@ -2227,7 +2227,7 @@
           <a:bodyPr/>
           <a:lstStyle/>
           <a:p>
-            <a:fld id="{54A143B8-B843-4E15-B9C0-488B5B777352}" type="slidenum">
+            <a:fld id="{D520FC40-E2A0-4524-A6FA-65C04552349B}" type="slidenum">
               <a:rPr lang="en-US" smtClean="0"/>
               <a:t>5</a:t>
             </a:fld>
@@ -2238,7 +2238,7 @@
     </p:spTree>
     <p:extLst>
       <p:ext uri="{BB962C8B-B14F-4D97-AF65-F5344CB8AC3E}">
-        <p14:creationId xmlns:p14="http://schemas.microsoft.com/office/powerpoint/2010/main" val="2549512898"/>
+        <p14:creationId xmlns:p14="http://schemas.microsoft.com/office/powerpoint/2010/main" val="2824897062"/>
       </p:ext>
     </p:extLst>
   </p:cSld>
@@ -2311,7 +2311,7 @@
           <a:bodyPr/>
           <a:lstStyle/>
           <a:p>
-            <a:fld id="{54A143B8-B843-4E15-B9C0-488B5B777352}" type="slidenum">
+            <a:fld id="{D520FC40-E2A0-4524-A6FA-65C04552349B}" type="slidenum">
               <a:rPr lang="en-US" smtClean="0"/>
               <a:t>6</a:t>
             </a:fld>
@@ -2322,7 +2322,7 @@
     </p:spTree>
     <p:extLst>
       <p:ext uri="{BB962C8B-B14F-4D97-AF65-F5344CB8AC3E}">
-        <p14:creationId xmlns:p14="http://schemas.microsoft.com/office/powerpoint/2010/main" val="3231376554"/>
+        <p14:creationId xmlns:p14="http://schemas.microsoft.com/office/powerpoint/2010/main" val="2921805238"/>
       </p:ext>
     </p:extLst>
   </p:cSld>
@@ -2395,7 +2395,7 @@
           <a:bodyPr/>
           <a:lstStyle/>
           <a:p>
-            <a:fld id="{54A143B8-B843-4E15-B9C0-488B5B777352}" type="slidenum">
+            <a:fld id="{D520FC40-E2A0-4524-A6FA-65C04552349B}" type="slidenum">
               <a:rPr lang="en-US" smtClean="0"/>
               <a:t>7</a:t>
             </a:fld>
@@ -2406,7 +2406,7 @@
     </p:spTree>
     <p:extLst>
       <p:ext uri="{BB962C8B-B14F-4D97-AF65-F5344CB8AC3E}">
-        <p14:creationId xmlns:p14="http://schemas.microsoft.com/office/powerpoint/2010/main" val="1935351993"/>
+        <p14:creationId xmlns:p14="http://schemas.microsoft.com/office/powerpoint/2010/main" val="3044268122"/>
       </p:ext>
     </p:extLst>
   </p:cSld>
@@ -2479,7 +2479,7 @@
           <a:bodyPr/>
           <a:lstStyle/>
           <a:p>
-            <a:fld id="{54A143B8-B843-4E15-B9C0-488B5B777352}" type="slidenum">
+            <a:fld id="{D520FC40-E2A0-4524-A6FA-65C04552349B}" type="slidenum">
               <a:rPr lang="en-US" smtClean="0"/>
               <a:t>8</a:t>
             </a:fld>
@@ -2490,7 +2490,7 @@
     </p:spTree>
     <p:extLst>
       <p:ext uri="{BB962C8B-B14F-4D97-AF65-F5344CB8AC3E}">
-        <p14:creationId xmlns:p14="http://schemas.microsoft.com/office/powerpoint/2010/main" val="2923853510"/>
+        <p14:creationId xmlns:p14="http://schemas.microsoft.com/office/powerpoint/2010/main" val="2681944712"/>
       </p:ext>
     </p:extLst>
   </p:cSld>
@@ -2563,7 +2563,7 @@
           <a:bodyPr/>
           <a:lstStyle/>
           <a:p>
-            <a:fld id="{54A143B8-B843-4E15-B9C0-488B5B777352}" type="slidenum">
+            <a:fld id="{D520FC40-E2A0-4524-A6FA-65C04552349B}" type="slidenum">
               <a:rPr lang="en-US" smtClean="0"/>
               <a:t>9</a:t>
             </a:fld>
@@ -2574,7 +2574,7 @@
     </p:spTree>
     <p:extLst>
       <p:ext uri="{BB962C8B-B14F-4D97-AF65-F5344CB8AC3E}">
-        <p14:creationId xmlns:p14="http://schemas.microsoft.com/office/powerpoint/2010/main" val="695265187"/>
+        <p14:creationId xmlns:p14="http://schemas.microsoft.com/office/powerpoint/2010/main" val="171474170"/>
       </p:ext>
     </p:extLst>
   </p:cSld>
@@ -2713,7 +2713,7 @@
           <a:bodyPr/>
           <a:lstStyle/>
           <a:p>
-            <a:fld id="{A97F56DE-5A2C-4080-93C8-1532081C3908}" type="datetimeFigureOut">
+            <a:fld id="{DE937A54-80FA-4392-BCD6-705053E0371A}" type="datetimeFigureOut">
               <a:rPr lang="en-US" smtClean="0"/>
               <a:t>10/29/2026</a:t>
             </a:fld>
@@ -2755,7 +2755,7 @@
           <a:bodyPr/>
           <a:lstStyle/>
           <a:p>
-            <a:fld id="{B5C9DD09-6691-41F4-A257-DA361A76118D}" type="slidenum">
+            <a:fld id="{7CE1603A-C848-4BF9-85B2-E19705A6FC59}" type="slidenum">
               <a:rPr lang="en-US" smtClean="0"/>
               <a:t>‹#›</a:t>
             </a:fld>
@@ -2766,7 +2766,7 @@
     </p:spTree>
     <p:extLst>
       <p:ext uri="{BB962C8B-B14F-4D97-AF65-F5344CB8AC3E}">
-        <p14:creationId xmlns:p14="http://schemas.microsoft.com/office/powerpoint/2010/main" val="2403617933"/>
+        <p14:creationId xmlns:p14="http://schemas.microsoft.com/office/powerpoint/2010/main" val="2046297693"/>
       </p:ext>
     </p:extLst>
   </p:cSld>
@@ -2883,7 +2883,7 @@
           <a:bodyPr/>
           <a:lstStyle/>
           <a:p>
-            <a:fld id="{A97F56DE-5A2C-4080-93C8-1532081C3908}" type="datetimeFigureOut">
+            <a:fld id="{DE937A54-80FA-4392-BCD6-705053E0371A}" type="datetimeFigureOut">
               <a:rPr lang="en-US" smtClean="0"/>
               <a:t>10/29/2026</a:t>
             </a:fld>
@@ -2925,7 +2925,7 @@
           <a:bodyPr/>
           <a:lstStyle/>
           <a:p>
-            <a:fld id="{B5C9DD09-6691-41F4-A257-DA361A76118D}" type="slidenum">
+            <a:fld id="{7CE1603A-C848-4BF9-85B2-E19705A6FC59}" type="slidenum">
               <a:rPr lang="en-US" smtClean="0"/>
               <a:t>‹#›</a:t>
             </a:fld>
@@ -2936,7 +2936,7 @@
     </p:spTree>
     <p:extLst>
       <p:ext uri="{BB962C8B-B14F-4D97-AF65-F5344CB8AC3E}">
-        <p14:creationId xmlns:p14="http://schemas.microsoft.com/office/powerpoint/2010/main" val="2132969200"/>
+        <p14:creationId xmlns:p14="http://schemas.microsoft.com/office/powerpoint/2010/main" val="723113803"/>
       </p:ext>
     </p:extLst>
   </p:cSld>
@@ -3063,7 +3063,7 @@
           <a:bodyPr/>
           <a:lstStyle/>
           <a:p>
-            <a:fld id="{A97F56DE-5A2C-4080-93C8-1532081C3908}" type="datetimeFigureOut">
+            <a:fld id="{DE937A54-80FA-4392-BCD6-705053E0371A}" type="datetimeFigureOut">
               <a:rPr lang="en-US" smtClean="0"/>
               <a:t>10/29/2026</a:t>
             </a:fld>
@@ -3105,7 +3105,7 @@
           <a:bodyPr/>
           <a:lstStyle/>
           <a:p>
-            <a:fld id="{B5C9DD09-6691-41F4-A257-DA361A76118D}" type="slidenum">
+            <a:fld id="{7CE1603A-C848-4BF9-85B2-E19705A6FC59}" type="slidenum">
               <a:rPr lang="en-US" smtClean="0"/>
               <a:t>‹#›</a:t>
             </a:fld>
@@ -3116,7 +3116,7 @@
     </p:spTree>
     <p:extLst>
       <p:ext uri="{BB962C8B-B14F-4D97-AF65-F5344CB8AC3E}">
-        <p14:creationId xmlns:p14="http://schemas.microsoft.com/office/powerpoint/2010/main" val="2484653764"/>
+        <p14:creationId xmlns:p14="http://schemas.microsoft.com/office/powerpoint/2010/main" val="413869315"/>
       </p:ext>
     </p:extLst>
   </p:cSld>
@@ -3233,7 +3233,7 @@
           <a:bodyPr/>
           <a:lstStyle/>
           <a:p>
-            <a:fld id="{A97F56DE-5A2C-4080-93C8-1532081C3908}" type="datetimeFigureOut">
+            <a:fld id="{DE937A54-80FA-4392-BCD6-705053E0371A}" type="datetimeFigureOut">
               <a:rPr lang="en-US" smtClean="0"/>
               <a:t>10/29/2026</a:t>
             </a:fld>
@@ -3275,7 +3275,7 @@
           <a:bodyPr/>
           <a:lstStyle/>
           <a:p>
-            <a:fld id="{B5C9DD09-6691-41F4-A257-DA361A76118D}" type="slidenum">
+            <a:fld id="{7CE1603A-C848-4BF9-85B2-E19705A6FC59}" type="slidenum">
               <a:rPr lang="en-US" smtClean="0"/>
               <a:t>‹#›</a:t>
             </a:fld>
@@ -3286,7 +3286,7 @@
     </p:spTree>
     <p:extLst>
       <p:ext uri="{BB962C8B-B14F-4D97-AF65-F5344CB8AC3E}">
-        <p14:creationId xmlns:p14="http://schemas.microsoft.com/office/powerpoint/2010/main" val="521625078"/>
+        <p14:creationId xmlns:p14="http://schemas.microsoft.com/office/powerpoint/2010/main" val="1368958472"/>
       </p:ext>
     </p:extLst>
   </p:cSld>
@@ -3479,7 +3479,7 @@
           <a:bodyPr/>
           <a:lstStyle/>
           <a:p>
-            <a:fld id="{A97F56DE-5A2C-4080-93C8-1532081C3908}" type="datetimeFigureOut">
+            <a:fld id="{DE937A54-80FA-4392-BCD6-705053E0371A}" type="datetimeFigureOut">
               <a:rPr lang="en-US" smtClean="0"/>
               <a:t>10/29/2026</a:t>
             </a:fld>
@@ -3521,7 +3521,7 @@
           <a:bodyPr/>
           <a:lstStyle/>
           <a:p>
-            <a:fld id="{B5C9DD09-6691-41F4-A257-DA361A76118D}" type="slidenum">
+            <a:fld id="{7CE1603A-C848-4BF9-85B2-E19705A6FC59}" type="slidenum">
               <a:rPr lang="en-US" smtClean="0"/>
               <a:t>‹#›</a:t>
             </a:fld>
@@ -3532,7 +3532,7 @@
     </p:spTree>
     <p:extLst>
       <p:ext uri="{BB962C8B-B14F-4D97-AF65-F5344CB8AC3E}">
-        <p14:creationId xmlns:p14="http://schemas.microsoft.com/office/powerpoint/2010/main" val="3384609087"/>
+        <p14:creationId xmlns:p14="http://schemas.microsoft.com/office/powerpoint/2010/main" val="1378268440"/>
       </p:ext>
     </p:extLst>
   </p:cSld>
@@ -3711,7 +3711,7 @@
           <a:bodyPr/>
           <a:lstStyle/>
           <a:p>
-            <a:fld id="{A97F56DE-5A2C-4080-93C8-1532081C3908}" type="datetimeFigureOut">
+            <a:fld id="{DE937A54-80FA-4392-BCD6-705053E0371A}" type="datetimeFigureOut">
               <a:rPr lang="en-US" smtClean="0"/>
               <a:t>10/29/2026</a:t>
             </a:fld>
@@ -3753,7 +3753,7 @@
           <a:bodyPr/>
           <a:lstStyle/>
           <a:p>
-            <a:fld id="{B5C9DD09-6691-41F4-A257-DA361A76118D}" type="slidenum">
+            <a:fld id="{7CE1603A-C848-4BF9-85B2-E19705A6FC59}" type="slidenum">
               <a:rPr lang="en-US" smtClean="0"/>
               <a:t>‹#›</a:t>
             </a:fld>
@@ -3764,7 +3764,7 @@
     </p:spTree>
     <p:extLst>
       <p:ext uri="{BB962C8B-B14F-4D97-AF65-F5344CB8AC3E}">
-        <p14:creationId xmlns:p14="http://schemas.microsoft.com/office/powerpoint/2010/main" val="2176775965"/>
+        <p14:creationId xmlns:p14="http://schemas.microsoft.com/office/powerpoint/2010/main" val="1288567911"/>
       </p:ext>
     </p:extLst>
   </p:cSld>
@@ -4078,7 +4078,7 @@
           <a:bodyPr/>
           <a:lstStyle/>
           <a:p>
-            <a:fld id="{A97F56DE-5A2C-4080-93C8-1532081C3908}" type="datetimeFigureOut">
+            <a:fld id="{DE937A54-80FA-4392-BCD6-705053E0371A}" type="datetimeFigureOut">
               <a:rPr lang="en-US" smtClean="0"/>
               <a:t>10/29/2026</a:t>
             </a:fld>
@@ -4120,7 +4120,7 @@
           <a:bodyPr/>
           <a:lstStyle/>
           <a:p>
-            <a:fld id="{B5C9DD09-6691-41F4-A257-DA361A76118D}" type="slidenum">
+            <a:fld id="{7CE1603A-C848-4BF9-85B2-E19705A6FC59}" type="slidenum">
               <a:rPr lang="en-US" smtClean="0"/>
               <a:t>‹#›</a:t>
             </a:fld>
@@ -4131,7 +4131,7 @@
     </p:spTree>
     <p:extLst>
       <p:ext uri="{BB962C8B-B14F-4D97-AF65-F5344CB8AC3E}">
-        <p14:creationId xmlns:p14="http://schemas.microsoft.com/office/powerpoint/2010/main" val="1445012908"/>
+        <p14:creationId xmlns:p14="http://schemas.microsoft.com/office/powerpoint/2010/main" val="393110814"/>
       </p:ext>
     </p:extLst>
   </p:cSld>
@@ -4196,7 +4196,7 @@
           <a:bodyPr/>
           <a:lstStyle/>
           <a:p>
-            <a:fld id="{A97F56DE-5A2C-4080-93C8-1532081C3908}" type="datetimeFigureOut">
+            <a:fld id="{DE937A54-80FA-4392-BCD6-705053E0371A}" type="datetimeFigureOut">
               <a:rPr lang="en-US" smtClean="0"/>
               <a:t>10/29/2026</a:t>
             </a:fld>
@@ -4238,7 +4238,7 @@
           <a:bodyPr/>
           <a:lstStyle/>
           <a:p>
-            <a:fld id="{B5C9DD09-6691-41F4-A257-DA361A76118D}" type="slidenum">
+            <a:fld id="{7CE1603A-C848-4BF9-85B2-E19705A6FC59}" type="slidenum">
               <a:rPr lang="en-US" smtClean="0"/>
               <a:t>‹#›</a:t>
             </a:fld>
@@ -4249,7 +4249,7 @@
     </p:spTree>
     <p:extLst>
       <p:ext uri="{BB962C8B-B14F-4D97-AF65-F5344CB8AC3E}">
-        <p14:creationId xmlns:p14="http://schemas.microsoft.com/office/powerpoint/2010/main" val="2261241327"/>
+        <p14:creationId xmlns:p14="http://schemas.microsoft.com/office/powerpoint/2010/main" val="2862317028"/>
       </p:ext>
     </p:extLst>
   </p:cSld>
@@ -4291,7 +4291,7 @@
           <a:bodyPr/>
           <a:lstStyle/>
           <a:p>
-            <a:fld id="{A97F56DE-5A2C-4080-93C8-1532081C3908}" type="datetimeFigureOut">
+            <a:fld id="{DE937A54-80FA-4392-BCD6-705053E0371A}" type="datetimeFigureOut">
               <a:rPr lang="en-US" smtClean="0"/>
               <a:t>10/29/2026</a:t>
             </a:fld>
@@ -4333,7 +4333,7 @@
           <a:bodyPr/>
           <a:lstStyle/>
           <a:p>
-            <a:fld id="{B5C9DD09-6691-41F4-A257-DA361A76118D}" type="slidenum">
+            <a:fld id="{7CE1603A-C848-4BF9-85B2-E19705A6FC59}" type="slidenum">
               <a:rPr lang="en-US" smtClean="0"/>
               <a:t>‹#›</a:t>
             </a:fld>
@@ -4344,7 +4344,7 @@
     </p:spTree>
     <p:extLst>
       <p:ext uri="{BB962C8B-B14F-4D97-AF65-F5344CB8AC3E}">
-        <p14:creationId xmlns:p14="http://schemas.microsoft.com/office/powerpoint/2010/main" val="1214463488"/>
+        <p14:creationId xmlns:p14="http://schemas.microsoft.com/office/powerpoint/2010/main" val="755589870"/>
       </p:ext>
     </p:extLst>
   </p:cSld>
@@ -4568,7 +4568,7 @@
           <a:bodyPr/>
           <a:lstStyle/>
           <a:p>
-            <a:fld id="{A97F56DE-5A2C-4080-93C8-1532081C3908}" type="datetimeFigureOut">
+            <a:fld id="{DE937A54-80FA-4392-BCD6-705053E0371A}" type="datetimeFigureOut">
               <a:rPr lang="en-US" smtClean="0"/>
               <a:t>10/29/2026</a:t>
             </a:fld>
@@ -4610,7 +4610,7 @@
           <a:bodyPr/>
           <a:lstStyle/>
           <a:p>
-            <a:fld id="{B5C9DD09-6691-41F4-A257-DA361A76118D}" type="slidenum">
+            <a:fld id="{7CE1603A-C848-4BF9-85B2-E19705A6FC59}" type="slidenum">
               <a:rPr lang="en-US" smtClean="0"/>
               <a:t>‹#›</a:t>
             </a:fld>
@@ -4621,7 +4621,7 @@
     </p:spTree>
     <p:extLst>
       <p:ext uri="{BB962C8B-B14F-4D97-AF65-F5344CB8AC3E}">
-        <p14:creationId xmlns:p14="http://schemas.microsoft.com/office/powerpoint/2010/main" val="226514647"/>
+        <p14:creationId xmlns:p14="http://schemas.microsoft.com/office/powerpoint/2010/main" val="655066153"/>
       </p:ext>
     </p:extLst>
   </p:cSld>
@@ -4821,7 +4821,7 @@
           <a:bodyPr/>
           <a:lstStyle/>
           <a:p>
-            <a:fld id="{A97F56DE-5A2C-4080-93C8-1532081C3908}" type="datetimeFigureOut">
+            <a:fld id="{DE937A54-80FA-4392-BCD6-705053E0371A}" type="datetimeFigureOut">
               <a:rPr lang="en-US" smtClean="0"/>
               <a:t>10/29/2026</a:t>
             </a:fld>
@@ -4863,7 +4863,7 @@
           <a:bodyPr/>
           <a:lstStyle/>
           <a:p>
-            <a:fld id="{B5C9DD09-6691-41F4-A257-DA361A76118D}" type="slidenum">
+            <a:fld id="{7CE1603A-C848-4BF9-85B2-E19705A6FC59}" type="slidenum">
               <a:rPr lang="en-US" smtClean="0"/>
               <a:t>‹#›</a:t>
             </a:fld>
@@ -4874,7 +4874,7 @@
     </p:spTree>
     <p:extLst>
       <p:ext uri="{BB962C8B-B14F-4D97-AF65-F5344CB8AC3E}">
-        <p14:creationId xmlns:p14="http://schemas.microsoft.com/office/powerpoint/2010/main" val="2009745960"/>
+        <p14:creationId xmlns:p14="http://schemas.microsoft.com/office/powerpoint/2010/main" val="1152350943"/>
       </p:ext>
     </p:extLst>
   </p:cSld>
@@ -5034,7 +5034,7 @@
             </a:lvl1pPr>
           </a:lstStyle>
           <a:p>
-            <a:fld id="{A97F56DE-5A2C-4080-93C8-1532081C3908}" type="datetimeFigureOut">
+            <a:fld id="{DE937A54-80FA-4392-BCD6-705053E0371A}" type="datetimeFigureOut">
               <a:rPr lang="en-US" smtClean="0"/>
               <a:t>10/29/2026</a:t>
             </a:fld>
@@ -5112,7 +5112,7 @@
             </a:lvl1pPr>
           </a:lstStyle>
           <a:p>
-            <a:fld id="{B5C9DD09-6691-41F4-A257-DA361A76118D}" type="slidenum">
+            <a:fld id="{7CE1603A-C848-4BF9-85B2-E19705A6FC59}" type="slidenum">
               <a:rPr lang="en-US" smtClean="0"/>
               <a:t>‹#›</a:t>
             </a:fld>
@@ -5123,7 +5123,7 @@
     </p:spTree>
     <p:extLst>
       <p:ext uri="{BB962C8B-B14F-4D97-AF65-F5344CB8AC3E}">
-        <p14:creationId xmlns:p14="http://schemas.microsoft.com/office/powerpoint/2010/main" val="3777716397"/>
+        <p14:creationId xmlns:p14="http://schemas.microsoft.com/office/powerpoint/2010/main" val="3426582360"/>
       </p:ext>
     </p:extLst>
   </p:cSld>
@@ -5693,7 +5693,7 @@
     </p:spTree>
     <p:extLst>
       <p:ext uri="{BB962C8B-B14F-4D97-AF65-F5344CB8AC3E}">
-        <p14:creationId xmlns:p14="http://schemas.microsoft.com/office/powerpoint/2010/main" val="1854495601"/>
+        <p14:creationId xmlns:p14="http://schemas.microsoft.com/office/powerpoint/2010/main" val="1141988603"/>
       </p:ext>
     </p:extLst>
   </p:cSld>
@@ -5961,7 +5961,7 @@
     </p:spTree>
     <p:extLst>
       <p:ext uri="{BB962C8B-B14F-4D97-AF65-F5344CB8AC3E}">
-        <p14:creationId xmlns:p14="http://schemas.microsoft.com/office/powerpoint/2010/main" val="2350092272"/>
+        <p14:creationId xmlns:p14="http://schemas.microsoft.com/office/powerpoint/2010/main" val="2785989350"/>
       </p:ext>
     </p:extLst>
   </p:cSld>
@@ -6229,7 +6229,7 @@
     </p:spTree>
     <p:extLst>
       <p:ext uri="{BB962C8B-B14F-4D97-AF65-F5344CB8AC3E}">
-        <p14:creationId xmlns:p14="http://schemas.microsoft.com/office/powerpoint/2010/main" val="2022938886"/>
+        <p14:creationId xmlns:p14="http://schemas.microsoft.com/office/powerpoint/2010/main" val="3852252931"/>
       </p:ext>
     </p:extLst>
   </p:cSld>
@@ -6497,7 +6497,7 @@
     </p:spTree>
     <p:extLst>
       <p:ext uri="{BB962C8B-B14F-4D97-AF65-F5344CB8AC3E}">
-        <p14:creationId xmlns:p14="http://schemas.microsoft.com/office/powerpoint/2010/main" val="2558004702"/>
+        <p14:creationId xmlns:p14="http://schemas.microsoft.com/office/powerpoint/2010/main" val="666811519"/>
       </p:ext>
     </p:extLst>
   </p:cSld>
@@ -6765,7 +6765,7 @@
     </p:spTree>
     <p:extLst>
       <p:ext uri="{BB962C8B-B14F-4D97-AF65-F5344CB8AC3E}">
-        <p14:creationId xmlns:p14="http://schemas.microsoft.com/office/powerpoint/2010/main" val="2174639924"/>
+        <p14:creationId xmlns:p14="http://schemas.microsoft.com/office/powerpoint/2010/main" val="1774822827"/>
       </p:ext>
     </p:extLst>
   </p:cSld>
@@ -7033,7 +7033,7 @@
     </p:spTree>
     <p:extLst>
       <p:ext uri="{BB962C8B-B14F-4D97-AF65-F5344CB8AC3E}">
-        <p14:creationId xmlns:p14="http://schemas.microsoft.com/office/powerpoint/2010/main" val="2700795567"/>
+        <p14:creationId xmlns:p14="http://schemas.microsoft.com/office/powerpoint/2010/main" val="1044099525"/>
       </p:ext>
     </p:extLst>
   </p:cSld>
@@ -7301,7 +7301,7 @@
     </p:spTree>
     <p:extLst>
       <p:ext uri="{BB962C8B-B14F-4D97-AF65-F5344CB8AC3E}">
-        <p14:creationId xmlns:p14="http://schemas.microsoft.com/office/powerpoint/2010/main" val="1998537452"/>
+        <p14:creationId xmlns:p14="http://schemas.microsoft.com/office/powerpoint/2010/main" val="689859779"/>
       </p:ext>
     </p:extLst>
   </p:cSld>
@@ -7569,7 +7569,7 @@
     </p:spTree>
     <p:extLst>
       <p:ext uri="{BB962C8B-B14F-4D97-AF65-F5344CB8AC3E}">
-        <p14:creationId xmlns:p14="http://schemas.microsoft.com/office/powerpoint/2010/main" val="2469210390"/>
+        <p14:creationId xmlns:p14="http://schemas.microsoft.com/office/powerpoint/2010/main" val="2890354272"/>
       </p:ext>
     </p:extLst>
   </p:cSld>
@@ -7837,7 +7837,7 @@
     </p:spTree>
     <p:extLst>
       <p:ext uri="{BB962C8B-B14F-4D97-AF65-F5344CB8AC3E}">
-        <p14:creationId xmlns:p14="http://schemas.microsoft.com/office/powerpoint/2010/main" val="3103325397"/>
+        <p14:creationId xmlns:p14="http://schemas.microsoft.com/office/powerpoint/2010/main" val="504213683"/>
       </p:ext>
     </p:extLst>
   </p:cSld>
@@ -8105,7 +8105,7 @@
     </p:spTree>
     <p:extLst>
       <p:ext uri="{BB962C8B-B14F-4D97-AF65-F5344CB8AC3E}">
-        <p14:creationId xmlns:p14="http://schemas.microsoft.com/office/powerpoint/2010/main" val="872345913"/>
+        <p14:creationId xmlns:p14="http://schemas.microsoft.com/office/powerpoint/2010/main" val="3706147594"/>
       </p:ext>
     </p:extLst>
   </p:cSld>
@@ -8373,7 +8373,7 @@
     </p:spTree>
     <p:extLst>
       <p:ext uri="{BB962C8B-B14F-4D97-AF65-F5344CB8AC3E}">
-        <p14:creationId xmlns:p14="http://schemas.microsoft.com/office/powerpoint/2010/main" val="1525154557"/>
+        <p14:creationId xmlns:p14="http://schemas.microsoft.com/office/powerpoint/2010/main" val="3366100259"/>
       </p:ext>
     </p:extLst>
   </p:cSld>
@@ -8641,7 +8641,7 @@
     </p:spTree>
     <p:extLst>
       <p:ext uri="{BB962C8B-B14F-4D97-AF65-F5344CB8AC3E}">
-        <p14:creationId xmlns:p14="http://schemas.microsoft.com/office/powerpoint/2010/main" val="562140930"/>
+        <p14:creationId xmlns:p14="http://schemas.microsoft.com/office/powerpoint/2010/main" val="3306769908"/>
       </p:ext>
     </p:extLst>
   </p:cSld>
@@ -8909,7 +8909,7 @@
     </p:spTree>
     <p:extLst>
       <p:ext uri="{BB962C8B-B14F-4D97-AF65-F5344CB8AC3E}">
-        <p14:creationId xmlns:p14="http://schemas.microsoft.com/office/powerpoint/2010/main" val="781084518"/>
+        <p14:creationId xmlns:p14="http://schemas.microsoft.com/office/powerpoint/2010/main" val="3042558375"/>
       </p:ext>
     </p:extLst>
   </p:cSld>
@@ -9177,7 +9177,7 @@
     </p:spTree>
     <p:extLst>
       <p:ext uri="{BB962C8B-B14F-4D97-AF65-F5344CB8AC3E}">
-        <p14:creationId xmlns:p14="http://schemas.microsoft.com/office/powerpoint/2010/main" val="3339712777"/>
+        <p14:creationId xmlns:p14="http://schemas.microsoft.com/office/powerpoint/2010/main" val="3670224675"/>
       </p:ext>
     </p:extLst>
   </p:cSld>
@@ -9445,7 +9445,7 @@
     </p:spTree>
     <p:extLst>
       <p:ext uri="{BB962C8B-B14F-4D97-AF65-F5344CB8AC3E}">
-        <p14:creationId xmlns:p14="http://schemas.microsoft.com/office/powerpoint/2010/main" val="3548522472"/>
+        <p14:creationId xmlns:p14="http://schemas.microsoft.com/office/powerpoint/2010/main" val="3335046480"/>
       </p:ext>
     </p:extLst>
   </p:cSld>
@@ -9713,7 +9713,7 @@
     </p:spTree>
     <p:extLst>
       <p:ext uri="{BB962C8B-B14F-4D97-AF65-F5344CB8AC3E}">
-        <p14:creationId xmlns:p14="http://schemas.microsoft.com/office/powerpoint/2010/main" val="2874069022"/>
+        <p14:creationId xmlns:p14="http://schemas.microsoft.com/office/powerpoint/2010/main" val="1835175522"/>
       </p:ext>
     </p:extLst>
   </p:cSld>
@@ -9981,7 +9981,7 @@
     </p:spTree>
     <p:extLst>
       <p:ext uri="{BB962C8B-B14F-4D97-AF65-F5344CB8AC3E}">
-        <p14:creationId xmlns:p14="http://schemas.microsoft.com/office/powerpoint/2010/main" val="185298109"/>
+        <p14:creationId xmlns:p14="http://schemas.microsoft.com/office/powerpoint/2010/main" val="1092710888"/>
       </p:ext>
     </p:extLst>
   </p:cSld>
@@ -10249,7 +10249,7 @@
     </p:spTree>
     <p:extLst>
       <p:ext uri="{BB962C8B-B14F-4D97-AF65-F5344CB8AC3E}">
-        <p14:creationId xmlns:p14="http://schemas.microsoft.com/office/powerpoint/2010/main" val="3301167379"/>
+        <p14:creationId xmlns:p14="http://schemas.microsoft.com/office/powerpoint/2010/main" val="3894256310"/>
       </p:ext>
     </p:extLst>
   </p:cSld>
@@ -10347,13 +10347,13 @@
           <a:lstStyle/>
           <a:p>
             <a:r>
-              <a:rPr lang="en-US" sz="2800" smtClean="0">
+              <a:rPr lang="fr-FR" sz="2800" smtClean="0">
                 <a:solidFill>
                   <a:srgbClr val="FFFFFF"/>
                 </a:solidFill>
                 <a:latin typeface="Segoe UI" panose="020B0502040204020203" pitchFamily="34" charset="0"/>
               </a:rPr>
-              <a:t>Une branche dédiée</a:t>
+              <a:t>Une branche dédiée et synchronisée</a:t>
             </a:r>
             <a:endParaRPr lang="en-US" sz="2800">
               <a:solidFill>
@@ -10393,7 +10393,7 @@
                 </a:solidFill>
                 <a:latin typeface="Segoe UI" panose="020B0502040204020203" pitchFamily="34" charset="0"/>
               </a:rPr>
-              <a:t>Branche locale Tache et commits vérifiés ; synchronisation distante encore à réaliser.</a:t>
+              <a:t>Branche Tache publiée sur origin après accord ; historique préservé et révisions locale/distante identiques.</a:t>
             </a:r>
             <a:endParaRPr lang="en-US" sz="1600">
               <a:solidFill>
@@ -10517,7 +10517,7 @@
     </p:spTree>
     <p:extLst>
       <p:ext uri="{BB962C8B-B14F-4D97-AF65-F5344CB8AC3E}">
-        <p14:creationId xmlns:p14="http://schemas.microsoft.com/office/powerpoint/2010/main" val="1625641272"/>
+        <p14:creationId xmlns:p14="http://schemas.microsoft.com/office/powerpoint/2010/main" val="394169638"/>
       </p:ext>
     </p:extLst>
   </p:cSld>
@@ -10785,7 +10785,7 @@
     </p:spTree>
     <p:extLst>
       <p:ext uri="{BB962C8B-B14F-4D97-AF65-F5344CB8AC3E}">
-        <p14:creationId xmlns:p14="http://schemas.microsoft.com/office/powerpoint/2010/main" val="3647241306"/>
+        <p14:creationId xmlns:p14="http://schemas.microsoft.com/office/powerpoint/2010/main" val="522141705"/>
       </p:ext>
     </p:extLst>
   </p:cSld>
@@ -11053,7 +11053,7 @@
     </p:spTree>
     <p:extLst>
       <p:ext uri="{BB962C8B-B14F-4D97-AF65-F5344CB8AC3E}">
-        <p14:creationId xmlns:p14="http://schemas.microsoft.com/office/powerpoint/2010/main" val="2332772252"/>
+        <p14:creationId xmlns:p14="http://schemas.microsoft.com/office/powerpoint/2010/main" val="3688331628"/>
       </p:ext>
     </p:extLst>
   </p:cSld>
@@ -11321,7 +11321,7 @@
     </p:spTree>
     <p:extLst>
       <p:ext uri="{BB962C8B-B14F-4D97-AF65-F5344CB8AC3E}">
-        <p14:creationId xmlns:p14="http://schemas.microsoft.com/office/powerpoint/2010/main" val="3548370010"/>
+        <p14:creationId xmlns:p14="http://schemas.microsoft.com/office/powerpoint/2010/main" val="1836772902"/>
       </p:ext>
     </p:extLst>
   </p:cSld>
@@ -11589,7 +11589,7 @@
     </p:spTree>
     <p:extLst>
       <p:ext uri="{BB962C8B-B14F-4D97-AF65-F5344CB8AC3E}">
-        <p14:creationId xmlns:p14="http://schemas.microsoft.com/office/powerpoint/2010/main" val="2992952893"/>
+        <p14:creationId xmlns:p14="http://schemas.microsoft.com/office/powerpoint/2010/main" val="1815399016"/>
       </p:ext>
     </p:extLst>
   </p:cSld>
@@ -11857,7 +11857,7 @@
     </p:spTree>
     <p:extLst>
       <p:ext uri="{BB962C8B-B14F-4D97-AF65-F5344CB8AC3E}">
-        <p14:creationId xmlns:p14="http://schemas.microsoft.com/office/powerpoint/2010/main" val="3683255033"/>
+        <p14:creationId xmlns:p14="http://schemas.microsoft.com/office/powerpoint/2010/main" val="83514872"/>
       </p:ext>
     </p:extLst>
   </p:cSld>
@@ -12125,7 +12125,7 @@
     </p:spTree>
     <p:extLst>
       <p:ext uri="{BB962C8B-B14F-4D97-AF65-F5344CB8AC3E}">
-        <p14:creationId xmlns:p14="http://schemas.microsoft.com/office/powerpoint/2010/main" val="3126871190"/>
+        <p14:creationId xmlns:p14="http://schemas.microsoft.com/office/powerpoint/2010/main" val="634347881"/>
       </p:ext>
     </p:extLst>
   </p:cSld>

</xml_diff>